<commit_message>
update dbtm + 4 TM icon(s)
</commit_message>
<xml_diff>
--- a/Icons_TimeMarks/BACKUP tm_icons/skulls.pptx
+++ b/Icons_TimeMarks/BACKUP tm_icons/skulls.pptx
@@ -29715,6 +29715,4358 @@
           </a:p>
         </p:txBody>
       </p:sp>
+      <p:grpSp>
+        <p:nvGrpSpPr>
+          <p:cNvPr id="7" name="Group 6">
+            <a:extLst>
+              <a:ext uri="{FF2B5EF4-FFF2-40B4-BE49-F238E27FC236}">
+                <a16:creationId xmlns:a16="http://schemas.microsoft.com/office/drawing/2014/main" id="{EC277D36-82DD-6802-D107-BE07F6D75659}"/>
+              </a:ext>
+            </a:extLst>
+          </p:cNvPr>
+          <p:cNvGrpSpPr/>
+          <p:nvPr/>
+        </p:nvGrpSpPr>
+        <p:grpSpPr>
+          <a:xfrm>
+            <a:off x="6710280" y="27166"/>
+            <a:ext cx="3255844" cy="3209307"/>
+            <a:chOff x="3036645" y="3256067"/>
+            <a:chExt cx="3255844" cy="3209307"/>
+          </a:xfrm>
+        </p:grpSpPr>
+        <p:sp>
+          <p:nvSpPr>
+            <p:cNvPr id="5" name="Freeform: Shape 4">
+              <a:extLst>
+                <a:ext uri="{FF2B5EF4-FFF2-40B4-BE49-F238E27FC236}">
+                  <a16:creationId xmlns:a16="http://schemas.microsoft.com/office/drawing/2014/main" id="{5DDF4340-995E-521E-1EE3-FC95DC018D72}"/>
+                </a:ext>
+              </a:extLst>
+            </p:cNvPr>
+            <p:cNvSpPr/>
+            <p:nvPr/>
+          </p:nvSpPr>
+          <p:spPr>
+            <a:xfrm rot="1318083">
+              <a:off x="3036645" y="3256067"/>
+              <a:ext cx="3255844" cy="3209307"/>
+            </a:xfrm>
+            <a:custGeom>
+              <a:avLst/>
+              <a:gdLst>
+                <a:gd name="csX0" fmla="*/ 2905604 w 3255844"/>
+                <a:gd name="csY0" fmla="*/ 276758 h 3209307"/>
+                <a:gd name="csX1" fmla="*/ 2893123 w 3255844"/>
+                <a:gd name="csY1" fmla="*/ 265905 h 3209307"/>
+                <a:gd name="csX2" fmla="*/ 2196887 w 3255844"/>
+                <a:gd name="csY2" fmla="*/ 0 h 3209307"/>
+                <a:gd name="csX3" fmla="*/ 1331339 w 3255844"/>
+                <a:gd name="csY3" fmla="*/ 457465 h 3209307"/>
+                <a:gd name="csX4" fmla="*/ 895038 w 3255844"/>
+                <a:gd name="csY4" fmla="*/ 972452 h 3209307"/>
+                <a:gd name="csX5" fmla="*/ 460365 w 3255844"/>
+                <a:gd name="csY5" fmla="*/ 1320299 h 3209307"/>
+                <a:gd name="csX6" fmla="*/ 3986 w 3255844"/>
+                <a:gd name="csY6" fmla="*/ 2087081 h 3209307"/>
+                <a:gd name="csX7" fmla="*/ 312219 w 3255844"/>
+                <a:gd name="csY7" fmla="*/ 2907045 h 3209307"/>
+                <a:gd name="csX8" fmla="*/ 332297 w 3255844"/>
+                <a:gd name="csY8" fmla="*/ 2926038 h 3209307"/>
+                <a:gd name="csX9" fmla="*/ 1036673 w 3255844"/>
+                <a:gd name="csY9" fmla="*/ 3209308 h 3209307"/>
+                <a:gd name="csX10" fmla="*/ 1502821 w 3255844"/>
+                <a:gd name="csY10" fmla="*/ 3095349 h 3209307"/>
+                <a:gd name="csX11" fmla="*/ 2379221 w 3255844"/>
+                <a:gd name="csY11" fmla="*/ 2481597 h 3209307"/>
+                <a:gd name="csX12" fmla="*/ 3100420 w 3255844"/>
+                <a:gd name="csY12" fmla="*/ 1606825 h 3209307"/>
+                <a:gd name="csX13" fmla="*/ 2905604 w 3255844"/>
+                <a:gd name="csY13" fmla="*/ 276758 h 3209307"/>
+                <a:gd name="csX14" fmla="*/ 2305419 w 3255844"/>
+                <a:gd name="csY14" fmla="*/ 2401283 h 3209307"/>
+                <a:gd name="csX15" fmla="*/ 1452896 w 3255844"/>
+                <a:gd name="csY15" fmla="*/ 2998755 h 3209307"/>
+                <a:gd name="csX16" fmla="*/ 1036673 w 3255844"/>
+                <a:gd name="csY16" fmla="*/ 3100775 h 3209307"/>
+                <a:gd name="csX17" fmla="*/ 407184 w 3255844"/>
+                <a:gd name="csY17" fmla="*/ 2847895 h 3209307"/>
+                <a:gd name="csX18" fmla="*/ 387649 w 3255844"/>
+                <a:gd name="csY18" fmla="*/ 2828901 h 3209307"/>
+                <a:gd name="csX19" fmla="*/ 111976 w 3255844"/>
+                <a:gd name="csY19" fmla="*/ 2096849 h 3209307"/>
+                <a:gd name="csX20" fmla="*/ 520601 w 3255844"/>
+                <a:gd name="csY20" fmla="*/ 1410923 h 3209307"/>
+                <a:gd name="csX21" fmla="*/ 969926 w 3255844"/>
+                <a:gd name="csY21" fmla="*/ 1051138 h 3209307"/>
+                <a:gd name="csX22" fmla="*/ 1421421 w 3255844"/>
+                <a:gd name="csY22" fmla="*/ 518243 h 3209307"/>
+                <a:gd name="csX23" fmla="*/ 2196887 w 3255844"/>
+                <a:gd name="csY23" fmla="*/ 108533 h 3209307"/>
+                <a:gd name="csX24" fmla="*/ 2820949 w 3255844"/>
+                <a:gd name="csY24" fmla="*/ 346762 h 3209307"/>
+                <a:gd name="csX25" fmla="*/ 2833430 w 3255844"/>
+                <a:gd name="csY25" fmla="*/ 357615 h 3209307"/>
+                <a:gd name="csX26" fmla="*/ 3007625 w 3255844"/>
+                <a:gd name="csY26" fmla="*/ 1549845 h 3209307"/>
+                <a:gd name="csX27" fmla="*/ 2305419 w 3255844"/>
+                <a:gd name="csY27" fmla="*/ 2401283 h 3209307"/>
+              </a:gdLst>
+              <a:ahLst/>
+              <a:cxnLst>
+                <a:cxn ang="0">
+                  <a:pos x="csX0" y="csY0"/>
+                </a:cxn>
+                <a:cxn ang="0">
+                  <a:pos x="csX1" y="csY1"/>
+                </a:cxn>
+                <a:cxn ang="0">
+                  <a:pos x="csX2" y="csY2"/>
+                </a:cxn>
+                <a:cxn ang="0">
+                  <a:pos x="csX3" y="csY3"/>
+                </a:cxn>
+                <a:cxn ang="0">
+                  <a:pos x="csX4" y="csY4"/>
+                </a:cxn>
+                <a:cxn ang="0">
+                  <a:pos x="csX5" y="csY5"/>
+                </a:cxn>
+                <a:cxn ang="0">
+                  <a:pos x="csX6" y="csY6"/>
+                </a:cxn>
+                <a:cxn ang="0">
+                  <a:pos x="csX7" y="csY7"/>
+                </a:cxn>
+                <a:cxn ang="0">
+                  <a:pos x="csX8" y="csY8"/>
+                </a:cxn>
+                <a:cxn ang="0">
+                  <a:pos x="csX9" y="csY9"/>
+                </a:cxn>
+                <a:cxn ang="0">
+                  <a:pos x="csX10" y="csY10"/>
+                </a:cxn>
+                <a:cxn ang="0">
+                  <a:pos x="csX11" y="csY11"/>
+                </a:cxn>
+                <a:cxn ang="0">
+                  <a:pos x="csX12" y="csY12"/>
+                </a:cxn>
+                <a:cxn ang="0">
+                  <a:pos x="csX13" y="csY13"/>
+                </a:cxn>
+                <a:cxn ang="0">
+                  <a:pos x="csX14" y="csY14"/>
+                </a:cxn>
+                <a:cxn ang="0">
+                  <a:pos x="csX15" y="csY15"/>
+                </a:cxn>
+                <a:cxn ang="0">
+                  <a:pos x="csX16" y="csY16"/>
+                </a:cxn>
+                <a:cxn ang="0">
+                  <a:pos x="csX17" y="csY17"/>
+                </a:cxn>
+                <a:cxn ang="0">
+                  <a:pos x="csX18" y="csY18"/>
+                </a:cxn>
+                <a:cxn ang="0">
+                  <a:pos x="csX19" y="csY19"/>
+                </a:cxn>
+                <a:cxn ang="0">
+                  <a:pos x="csX20" y="csY20"/>
+                </a:cxn>
+                <a:cxn ang="0">
+                  <a:pos x="csX21" y="csY21"/>
+                </a:cxn>
+                <a:cxn ang="0">
+                  <a:pos x="csX22" y="csY22"/>
+                </a:cxn>
+                <a:cxn ang="0">
+                  <a:pos x="csX23" y="csY23"/>
+                </a:cxn>
+                <a:cxn ang="0">
+                  <a:pos x="csX24" y="csY24"/>
+                </a:cxn>
+                <a:cxn ang="0">
+                  <a:pos x="csX25" y="csY25"/>
+                </a:cxn>
+                <a:cxn ang="0">
+                  <a:pos x="csX26" y="csY26"/>
+                </a:cxn>
+                <a:cxn ang="0">
+                  <a:pos x="csX27" y="csY27"/>
+                </a:cxn>
+              </a:cxnLst>
+              <a:rect l="l" t="t" r="r" b="b"/>
+              <a:pathLst>
+                <a:path w="3255844" h="3209307">
+                  <a:moveTo>
+                    <a:pt x="2905604" y="276758"/>
+                  </a:moveTo>
+                  <a:lnTo>
+                    <a:pt x="2893123" y="265905"/>
+                  </a:lnTo>
+                  <a:cubicBezTo>
+                    <a:pt x="2701020" y="94423"/>
+                    <a:pt x="2453566" y="0"/>
+                    <a:pt x="2196887" y="0"/>
+                  </a:cubicBezTo>
+                  <a:cubicBezTo>
+                    <a:pt x="1850125" y="0"/>
+                    <a:pt x="1526155" y="170939"/>
+                    <a:pt x="1331339" y="457465"/>
+                  </a:cubicBezTo>
+                  <a:cubicBezTo>
+                    <a:pt x="1204356" y="643598"/>
+                    <a:pt x="1057837" y="817250"/>
+                    <a:pt x="895038" y="972452"/>
+                  </a:cubicBezTo>
+                  <a:cubicBezTo>
+                    <a:pt x="761001" y="1100520"/>
+                    <a:pt x="614482" y="1217193"/>
+                    <a:pt x="460365" y="1320299"/>
+                  </a:cubicBezTo>
+                  <a:cubicBezTo>
+                    <a:pt x="197717" y="1495579"/>
+                    <a:pt x="31119" y="1775050"/>
+                    <a:pt x="3986" y="2087081"/>
+                  </a:cubicBezTo>
+                  <a:cubicBezTo>
+                    <a:pt x="-23147" y="2394771"/>
+                    <a:pt x="89184" y="2693778"/>
+                    <a:pt x="312219" y="2907045"/>
+                  </a:cubicBezTo>
+                  <a:lnTo>
+                    <a:pt x="332297" y="2926038"/>
+                  </a:lnTo>
+                  <a:cubicBezTo>
+                    <a:pt x="523314" y="3108915"/>
+                    <a:pt x="772939" y="3209308"/>
+                    <a:pt x="1036673" y="3209308"/>
+                  </a:cubicBezTo>
+                  <a:cubicBezTo>
+                    <a:pt x="1198387" y="3209308"/>
+                    <a:pt x="1359558" y="3169694"/>
+                    <a:pt x="1502821" y="3095349"/>
+                  </a:cubicBezTo>
+                  <a:cubicBezTo>
+                    <a:pt x="1820821" y="2929294"/>
+                    <a:pt x="2116030" y="2722539"/>
+                    <a:pt x="2379221" y="2481597"/>
+                  </a:cubicBezTo>
+                  <a:cubicBezTo>
+                    <a:pt x="2658150" y="2225460"/>
+                    <a:pt x="2900720" y="1930794"/>
+                    <a:pt x="3100420" y="1606825"/>
+                  </a:cubicBezTo>
+                  <a:cubicBezTo>
+                    <a:pt x="3366325" y="1174322"/>
+                    <a:pt x="3284383" y="614837"/>
+                    <a:pt x="2905604" y="276758"/>
+                  </a:cubicBezTo>
+                  <a:close/>
+                  <a:moveTo>
+                    <a:pt x="2305419" y="2401283"/>
+                  </a:moveTo>
+                  <a:cubicBezTo>
+                    <a:pt x="2049282" y="2636256"/>
+                    <a:pt x="1762214" y="2837584"/>
+                    <a:pt x="1452896" y="2998755"/>
+                  </a:cubicBezTo>
+                  <a:cubicBezTo>
+                    <a:pt x="1324827" y="3065502"/>
+                    <a:pt x="1181022" y="3100775"/>
+                    <a:pt x="1036673" y="3100775"/>
+                  </a:cubicBezTo>
+                  <a:cubicBezTo>
+                    <a:pt x="801158" y="3100775"/>
+                    <a:pt x="577581" y="3011236"/>
+                    <a:pt x="407184" y="2847895"/>
+                  </a:cubicBezTo>
+                  <a:lnTo>
+                    <a:pt x="387649" y="2828901"/>
+                  </a:lnTo>
+                  <a:cubicBezTo>
+                    <a:pt x="187949" y="2637884"/>
+                    <a:pt x="87556" y="2371437"/>
+                    <a:pt x="111976" y="2096849"/>
+                  </a:cubicBezTo>
+                  <a:cubicBezTo>
+                    <a:pt x="136396" y="1817378"/>
+                    <a:pt x="285085" y="1567210"/>
+                    <a:pt x="520601" y="1410923"/>
+                  </a:cubicBezTo>
+                  <a:cubicBezTo>
+                    <a:pt x="680144" y="1304019"/>
+                    <a:pt x="831547" y="1183005"/>
+                    <a:pt x="969926" y="1051138"/>
+                  </a:cubicBezTo>
+                  <a:cubicBezTo>
+                    <a:pt x="1138151" y="890510"/>
+                    <a:pt x="1290097" y="711431"/>
+                    <a:pt x="1421421" y="518243"/>
+                  </a:cubicBezTo>
+                  <a:cubicBezTo>
+                    <a:pt x="1596159" y="261563"/>
+                    <a:pt x="1885941" y="108533"/>
+                    <a:pt x="2196887" y="108533"/>
+                  </a:cubicBezTo>
+                  <a:cubicBezTo>
+                    <a:pt x="2426976" y="108533"/>
+                    <a:pt x="2648925" y="193188"/>
+                    <a:pt x="2820949" y="346762"/>
+                  </a:cubicBezTo>
+                  <a:lnTo>
+                    <a:pt x="2833430" y="357615"/>
+                  </a:lnTo>
+                  <a:cubicBezTo>
+                    <a:pt x="3172594" y="660963"/>
+                    <a:pt x="3245854" y="1161841"/>
+                    <a:pt x="3007625" y="1549845"/>
+                  </a:cubicBezTo>
+                  <a:cubicBezTo>
+                    <a:pt x="2813894" y="1865675"/>
+                    <a:pt x="2577293" y="2152201"/>
+                    <a:pt x="2305419" y="2401283"/>
+                  </a:cubicBezTo>
+                  <a:close/>
+                </a:path>
+              </a:pathLst>
+            </a:custGeom>
+            <a:solidFill>
+              <a:srgbClr val="000000"/>
+            </a:solidFill>
+            <a:ln w="54173" cap="flat">
+              <a:noFill/>
+              <a:prstDash val="solid"/>
+              <a:miter/>
+            </a:ln>
+          </p:spPr>
+          <p:txBody>
+            <a:bodyPr/>
+            <a:lstStyle/>
+            <a:p>
+              <a:endParaRPr lang="en-US"/>
+            </a:p>
+          </p:txBody>
+        </p:sp>
+        <p:sp>
+          <p:nvSpPr>
+            <p:cNvPr id="6" name="Freeform: Shape 5">
+              <a:extLst>
+                <a:ext uri="{FF2B5EF4-FFF2-40B4-BE49-F238E27FC236}">
+                  <a16:creationId xmlns:a16="http://schemas.microsoft.com/office/drawing/2014/main" id="{148E98FC-C7DA-972A-5C16-BC25790CF8C2}"/>
+                </a:ext>
+              </a:extLst>
+            </p:cNvPr>
+            <p:cNvSpPr/>
+            <p:nvPr/>
+          </p:nvSpPr>
+          <p:spPr>
+            <a:xfrm rot="1318083">
+              <a:off x="3244188" y="3464015"/>
+              <a:ext cx="2840252" cy="2793519"/>
+            </a:xfrm>
+            <a:custGeom>
+              <a:avLst/>
+              <a:gdLst>
+                <a:gd name="csX0" fmla="*/ 2559683 w 2840252"/>
+                <a:gd name="csY0" fmla="*/ 224011 h 2793519"/>
+                <a:gd name="csX1" fmla="*/ 2547201 w 2840252"/>
+                <a:gd name="csY1" fmla="*/ 213158 h 2793519"/>
+                <a:gd name="csX2" fmla="*/ 1886238 w 2840252"/>
+                <a:gd name="csY2" fmla="*/ 6403 h 2793519"/>
+                <a:gd name="csX3" fmla="*/ 1295821 w 2840252"/>
+                <a:gd name="csY3" fmla="*/ 366188 h 2793519"/>
+                <a:gd name="csX4" fmla="*/ 830759 w 2840252"/>
+                <a:gd name="csY4" fmla="*/ 914821 h 2793519"/>
+                <a:gd name="csX5" fmla="*/ 367867 w 2840252"/>
+                <a:gd name="csY5" fmla="*/ 1285459 h 2793519"/>
+                <a:gd name="csX6" fmla="*/ 3198 w 2840252"/>
+                <a:gd name="csY6" fmla="*/ 1897583 h 2793519"/>
+                <a:gd name="csX7" fmla="*/ 249024 w 2840252"/>
+                <a:gd name="csY7" fmla="*/ 2549321 h 2793519"/>
+                <a:gd name="csX8" fmla="*/ 249024 w 2840252"/>
+                <a:gd name="csY8" fmla="*/ 2549864 h 2793519"/>
+                <a:gd name="csX9" fmla="*/ 268560 w 2840252"/>
+                <a:gd name="csY9" fmla="*/ 2568314 h 2793519"/>
+                <a:gd name="csX10" fmla="*/ 828588 w 2840252"/>
+                <a:gd name="csY10" fmla="*/ 2793519 h 2793519"/>
+                <a:gd name="csX11" fmla="*/ 1199227 w 2840252"/>
+                <a:gd name="csY11" fmla="*/ 2702895 h 2793519"/>
+                <a:gd name="csX12" fmla="*/ 2031129 w 2840252"/>
+                <a:gd name="csY12" fmla="*/ 2120075 h 2793519"/>
+                <a:gd name="csX13" fmla="*/ 2715970 w 2840252"/>
+                <a:gd name="csY13" fmla="*/ 1289801 h 2793519"/>
+                <a:gd name="csX14" fmla="*/ 2559683 w 2840252"/>
+                <a:gd name="csY14" fmla="*/ 224011 h 2793519"/>
+                <a:gd name="csX15" fmla="*/ 641370 w 2840252"/>
+                <a:gd name="csY15" fmla="*/ 1742924 h 2793519"/>
+                <a:gd name="csX16" fmla="*/ 588731 w 2840252"/>
+                <a:gd name="csY16" fmla="*/ 1785252 h 2793519"/>
+                <a:gd name="csX17" fmla="*/ 576793 w 2840252"/>
+                <a:gd name="csY17" fmla="*/ 1784166 h 2793519"/>
+                <a:gd name="csX18" fmla="*/ 435158 w 2840252"/>
+                <a:gd name="csY18" fmla="*/ 1752692 h 2793519"/>
+                <a:gd name="csX19" fmla="*/ 393915 w 2840252"/>
+                <a:gd name="csY19" fmla="*/ 1687572 h 2793519"/>
+                <a:gd name="csX20" fmla="*/ 458492 w 2840252"/>
+                <a:gd name="csY20" fmla="*/ 1646330 h 2793519"/>
+                <a:gd name="csX21" fmla="*/ 600127 w 2840252"/>
+                <a:gd name="csY21" fmla="*/ 1677805 h 2793519"/>
+                <a:gd name="csX22" fmla="*/ 641370 w 2840252"/>
+                <a:gd name="csY22" fmla="*/ 1742924 h 2793519"/>
+                <a:gd name="csX23" fmla="*/ 881227 w 2840252"/>
+                <a:gd name="csY23" fmla="*/ 2280703 h 2793519"/>
+                <a:gd name="csX24" fmla="*/ 901848 w 2840252"/>
+                <a:gd name="csY24" fmla="*/ 2260082 h 2793519"/>
+                <a:gd name="csX25" fmla="*/ 978906 w 2840252"/>
+                <a:gd name="csY25" fmla="*/ 2260082 h 2793519"/>
+                <a:gd name="csX26" fmla="*/ 978906 w 2840252"/>
+                <a:gd name="csY26" fmla="*/ 2336597 h 2793519"/>
+                <a:gd name="csX27" fmla="*/ 957742 w 2840252"/>
+                <a:gd name="csY27" fmla="*/ 2357761 h 2793519"/>
+                <a:gd name="csX28" fmla="*/ 919213 w 2840252"/>
+                <a:gd name="csY28" fmla="*/ 2373498 h 2793519"/>
+                <a:gd name="csX29" fmla="*/ 881227 w 2840252"/>
+                <a:gd name="csY29" fmla="*/ 2357761 h 2793519"/>
+                <a:gd name="csX30" fmla="*/ 881227 w 2840252"/>
+                <a:gd name="csY30" fmla="*/ 2280703 h 2793519"/>
+                <a:gd name="csX31" fmla="*/ 1252408 w 2840252"/>
+                <a:gd name="csY31" fmla="*/ 1379340 h 2793519"/>
+                <a:gd name="csX32" fmla="*/ 1208452 w 2840252"/>
+                <a:gd name="csY32" fmla="*/ 1402132 h 2793519"/>
+                <a:gd name="csX33" fmla="*/ 1176978 w 2840252"/>
+                <a:gd name="csY33" fmla="*/ 1391821 h 2793519"/>
+                <a:gd name="csX34" fmla="*/ 1066275 w 2840252"/>
+                <a:gd name="csY34" fmla="*/ 1313135 h 2793519"/>
+                <a:gd name="csX35" fmla="*/ 1053793 w 2840252"/>
+                <a:gd name="csY35" fmla="*/ 1237162 h 2793519"/>
+                <a:gd name="csX36" fmla="*/ 1129766 w 2840252"/>
+                <a:gd name="csY36" fmla="*/ 1224681 h 2793519"/>
+                <a:gd name="csX37" fmla="*/ 1239927 w 2840252"/>
+                <a:gd name="csY37" fmla="*/ 1303367 h 2793519"/>
+                <a:gd name="csX38" fmla="*/ 1252408 w 2840252"/>
+                <a:gd name="csY38" fmla="*/ 1379340 h 2793519"/>
+                <a:gd name="csX39" fmla="*/ 1098834 w 2840252"/>
+                <a:gd name="csY39" fmla="*/ 1820525 h 2793519"/>
+                <a:gd name="csX40" fmla="*/ 1153101 w 2840252"/>
+                <a:gd name="csY40" fmla="*/ 1763545 h 2793519"/>
+                <a:gd name="csX41" fmla="*/ 1207367 w 2840252"/>
+                <a:gd name="csY41" fmla="*/ 1815098 h 2793519"/>
+                <a:gd name="csX42" fmla="*/ 1207367 w 2840252"/>
+                <a:gd name="csY42" fmla="*/ 1820525 h 2793519"/>
+                <a:gd name="csX43" fmla="*/ 1153101 w 2840252"/>
+                <a:gd name="csY43" fmla="*/ 1874791 h 2793519"/>
+                <a:gd name="csX44" fmla="*/ 1098834 w 2840252"/>
+                <a:gd name="csY44" fmla="*/ 1820525 h 2793519"/>
+                <a:gd name="csX45" fmla="*/ 1448309 w 2840252"/>
+                <a:gd name="csY45" fmla="*/ 829622 h 2793519"/>
+                <a:gd name="csX46" fmla="*/ 1521569 w 2840252"/>
+                <a:gd name="csY46" fmla="*/ 805745 h 2793519"/>
+                <a:gd name="csX47" fmla="*/ 1657777 w 2840252"/>
+                <a:gd name="csY47" fmla="*/ 873578 h 2793519"/>
+                <a:gd name="csX48" fmla="*/ 1682197 w 2840252"/>
+                <a:gd name="csY48" fmla="*/ 946838 h 2793519"/>
+                <a:gd name="csX49" fmla="*/ 1633357 w 2840252"/>
+                <a:gd name="csY49" fmla="*/ 976684 h 2793519"/>
+                <a:gd name="csX50" fmla="*/ 1609480 w 2840252"/>
+                <a:gd name="csY50" fmla="*/ 970715 h 2793519"/>
+                <a:gd name="csX51" fmla="*/ 1472729 w 2840252"/>
+                <a:gd name="csY51" fmla="*/ 902339 h 2793519"/>
+                <a:gd name="csX52" fmla="*/ 1448309 w 2840252"/>
+                <a:gd name="csY52" fmla="*/ 829622 h 2793519"/>
+                <a:gd name="csX53" fmla="*/ 1971979 w 2840252"/>
+                <a:gd name="csY53" fmla="*/ 474178 h 2793519"/>
+                <a:gd name="csX54" fmla="*/ 1997484 w 2840252"/>
+                <a:gd name="csY54" fmla="*/ 546353 h 2793519"/>
+                <a:gd name="csX55" fmla="*/ 1945388 w 2840252"/>
+                <a:gd name="csY55" fmla="*/ 657056 h 2793519"/>
+                <a:gd name="csX56" fmla="*/ 1896006 w 2840252"/>
+                <a:gd name="csY56" fmla="*/ 687988 h 2793519"/>
+                <a:gd name="csX57" fmla="*/ 1872672 w 2840252"/>
+                <a:gd name="csY57" fmla="*/ 682561 h 2793519"/>
+                <a:gd name="csX58" fmla="*/ 1847166 w 2840252"/>
+                <a:gd name="csY58" fmla="*/ 610387 h 2793519"/>
+                <a:gd name="csX59" fmla="*/ 1899805 w 2840252"/>
+                <a:gd name="csY59" fmla="*/ 499684 h 2793519"/>
+                <a:gd name="csX60" fmla="*/ 1971979 w 2840252"/>
+                <a:gd name="csY60" fmla="*/ 474178 h 2793519"/>
+                <a:gd name="csX61" fmla="*/ 2277498 w 2840252"/>
+                <a:gd name="csY61" fmla="*/ 919704 h 2793519"/>
+                <a:gd name="csX62" fmla="*/ 2193385 w 2840252"/>
+                <a:gd name="csY62" fmla="*/ 801404 h 2793519"/>
+                <a:gd name="csX63" fmla="*/ 2205867 w 2840252"/>
+                <a:gd name="csY63" fmla="*/ 725974 h 2793519"/>
+                <a:gd name="csX64" fmla="*/ 2281839 w 2840252"/>
+                <a:gd name="csY64" fmla="*/ 738455 h 2793519"/>
+                <a:gd name="csX65" fmla="*/ 2365952 w 2840252"/>
+                <a:gd name="csY65" fmla="*/ 856756 h 2793519"/>
+                <a:gd name="csX66" fmla="*/ 2352928 w 2840252"/>
+                <a:gd name="csY66" fmla="*/ 932186 h 2793519"/>
+                <a:gd name="csX67" fmla="*/ 2321454 w 2840252"/>
+                <a:gd name="csY67" fmla="*/ 942496 h 2793519"/>
+                <a:gd name="csX68" fmla="*/ 2277498 w 2840252"/>
+                <a:gd name="csY68" fmla="*/ 919704 h 2793519"/>
+                <a:gd name="csX69" fmla="*/ 2307344 w 2840252"/>
+                <a:gd name="csY69" fmla="*/ 1226852 h 2793519"/>
+                <a:gd name="csX70" fmla="*/ 2253078 w 2840252"/>
+                <a:gd name="csY70" fmla="*/ 1281118 h 2793519"/>
+                <a:gd name="csX71" fmla="*/ 2196641 w 2840252"/>
+                <a:gd name="csY71" fmla="*/ 1226852 h 2793519"/>
+                <a:gd name="csX72" fmla="*/ 2248194 w 2840252"/>
+                <a:gd name="csY72" fmla="*/ 1172585 h 2793519"/>
+                <a:gd name="csX73" fmla="*/ 2253078 w 2840252"/>
+                <a:gd name="csY73" fmla="*/ 1172585 h 2793519"/>
+                <a:gd name="csX74" fmla="*/ 2307344 w 2840252"/>
+                <a:gd name="csY74" fmla="*/ 1226852 h 2793519"/>
+                <a:gd name="csX75" fmla="*/ 1923682 w 2840252"/>
+                <a:gd name="csY75" fmla="*/ 1254527 h 2793519"/>
+                <a:gd name="csX76" fmla="*/ 1891122 w 2840252"/>
+                <a:gd name="csY76" fmla="*/ 1265381 h 2793519"/>
+                <a:gd name="csX77" fmla="*/ 1847709 w 2840252"/>
+                <a:gd name="csY77" fmla="*/ 1243674 h 2793519"/>
+                <a:gd name="csX78" fmla="*/ 1800497 w 2840252"/>
+                <a:gd name="csY78" fmla="*/ 1180725 h 2793519"/>
+                <a:gd name="csX79" fmla="*/ 1811351 w 2840252"/>
+                <a:gd name="csY79" fmla="*/ 1104753 h 2793519"/>
+                <a:gd name="csX80" fmla="*/ 1887323 w 2840252"/>
+                <a:gd name="csY80" fmla="*/ 1115606 h 2793519"/>
+                <a:gd name="csX81" fmla="*/ 1934535 w 2840252"/>
+                <a:gd name="csY81" fmla="*/ 1178555 h 2793519"/>
+                <a:gd name="csX82" fmla="*/ 1923682 w 2840252"/>
+                <a:gd name="csY82" fmla="*/ 1254527 h 2793519"/>
+                <a:gd name="csX83" fmla="*/ 1559012 w 2840252"/>
+                <a:gd name="csY83" fmla="*/ 1944795 h 2793519"/>
+                <a:gd name="csX84" fmla="*/ 1648552 w 2840252"/>
+                <a:gd name="csY84" fmla="*/ 1934484 h 2793519"/>
+                <a:gd name="csX85" fmla="*/ 1708787 w 2840252"/>
+                <a:gd name="csY85" fmla="*/ 1982238 h 2793519"/>
+                <a:gd name="csX86" fmla="*/ 1661033 w 2840252"/>
+                <a:gd name="csY86" fmla="*/ 2042474 h 2793519"/>
+                <a:gd name="csX87" fmla="*/ 1571494 w 2840252"/>
+                <a:gd name="csY87" fmla="*/ 2052785 h 2793519"/>
+                <a:gd name="csX88" fmla="*/ 1565524 w 2840252"/>
+                <a:gd name="csY88" fmla="*/ 2053327 h 2793519"/>
+                <a:gd name="csX89" fmla="*/ 1511258 w 2840252"/>
+                <a:gd name="csY89" fmla="*/ 2005030 h 2793519"/>
+                <a:gd name="csX90" fmla="*/ 1559012 w 2840252"/>
+                <a:gd name="csY90" fmla="*/ 1944795 h 2793519"/>
+                <a:gd name="csX91" fmla="*/ 1555756 w 2840252"/>
+                <a:gd name="csY91" fmla="*/ 1458026 h 2793519"/>
+                <a:gd name="csX92" fmla="*/ 1555756 w 2840252"/>
+                <a:gd name="csY92" fmla="*/ 1396705 h 2793519"/>
+                <a:gd name="csX93" fmla="*/ 1610023 w 2840252"/>
+                <a:gd name="csY93" fmla="*/ 1342439 h 2793519"/>
+                <a:gd name="csX94" fmla="*/ 1664289 w 2840252"/>
+                <a:gd name="csY94" fmla="*/ 1396705 h 2793519"/>
+                <a:gd name="csX95" fmla="*/ 1664289 w 2840252"/>
+                <a:gd name="csY95" fmla="*/ 1458026 h 2793519"/>
+                <a:gd name="csX96" fmla="*/ 1610023 w 2840252"/>
+                <a:gd name="csY96" fmla="*/ 1512292 h 2793519"/>
+                <a:gd name="csX97" fmla="*/ 1555756 w 2840252"/>
+                <a:gd name="csY97" fmla="*/ 1458026 h 2793519"/>
+                <a:gd name="csX98" fmla="*/ 1916085 w 2840252"/>
+                <a:gd name="csY98" fmla="*/ 1753235 h 2793519"/>
+                <a:gd name="csX99" fmla="*/ 1905774 w 2840252"/>
+                <a:gd name="csY99" fmla="*/ 1677262 h 2793519"/>
+                <a:gd name="csX100" fmla="*/ 2005081 w 2840252"/>
+                <a:gd name="csY100" fmla="*/ 1545937 h 2793519"/>
+                <a:gd name="csX101" fmla="*/ 2081597 w 2840252"/>
+                <a:gd name="csY101" fmla="*/ 1535627 h 2793519"/>
+                <a:gd name="csX102" fmla="*/ 2091907 w 2840252"/>
+                <a:gd name="csY102" fmla="*/ 1611600 h 2793519"/>
+                <a:gd name="csX103" fmla="*/ 1992057 w 2840252"/>
+                <a:gd name="csY103" fmla="*/ 1742924 h 2793519"/>
+                <a:gd name="csX104" fmla="*/ 1948644 w 2840252"/>
+                <a:gd name="csY104" fmla="*/ 1764088 h 2793519"/>
+                <a:gd name="csX105" fmla="*/ 1916085 w 2840252"/>
+                <a:gd name="csY105" fmla="*/ 1753235 h 2793519"/>
+                <a:gd name="csX0" fmla="*/ 2559683 w 2840252"/>
+                <a:gd name="csY0" fmla="*/ 224011 h 2793519"/>
+                <a:gd name="csX1" fmla="*/ 2547201 w 2840252"/>
+                <a:gd name="csY1" fmla="*/ 213158 h 2793519"/>
+                <a:gd name="csX2" fmla="*/ 1886238 w 2840252"/>
+                <a:gd name="csY2" fmla="*/ 6403 h 2793519"/>
+                <a:gd name="csX3" fmla="*/ 1295821 w 2840252"/>
+                <a:gd name="csY3" fmla="*/ 366188 h 2793519"/>
+                <a:gd name="csX4" fmla="*/ 830759 w 2840252"/>
+                <a:gd name="csY4" fmla="*/ 914821 h 2793519"/>
+                <a:gd name="csX5" fmla="*/ 367867 w 2840252"/>
+                <a:gd name="csY5" fmla="*/ 1285459 h 2793519"/>
+                <a:gd name="csX6" fmla="*/ 3198 w 2840252"/>
+                <a:gd name="csY6" fmla="*/ 1897583 h 2793519"/>
+                <a:gd name="csX7" fmla="*/ 249024 w 2840252"/>
+                <a:gd name="csY7" fmla="*/ 2549321 h 2793519"/>
+                <a:gd name="csX8" fmla="*/ 249024 w 2840252"/>
+                <a:gd name="csY8" fmla="*/ 2549864 h 2793519"/>
+                <a:gd name="csX9" fmla="*/ 268560 w 2840252"/>
+                <a:gd name="csY9" fmla="*/ 2568314 h 2793519"/>
+                <a:gd name="csX10" fmla="*/ 828588 w 2840252"/>
+                <a:gd name="csY10" fmla="*/ 2793519 h 2793519"/>
+                <a:gd name="csX11" fmla="*/ 1199227 w 2840252"/>
+                <a:gd name="csY11" fmla="*/ 2702895 h 2793519"/>
+                <a:gd name="csX12" fmla="*/ 2031129 w 2840252"/>
+                <a:gd name="csY12" fmla="*/ 2120075 h 2793519"/>
+                <a:gd name="csX13" fmla="*/ 2715970 w 2840252"/>
+                <a:gd name="csY13" fmla="*/ 1289801 h 2793519"/>
+                <a:gd name="csX14" fmla="*/ 2559683 w 2840252"/>
+                <a:gd name="csY14" fmla="*/ 224011 h 2793519"/>
+                <a:gd name="csX15" fmla="*/ 641370 w 2840252"/>
+                <a:gd name="csY15" fmla="*/ 1742924 h 2793519"/>
+                <a:gd name="csX16" fmla="*/ 588731 w 2840252"/>
+                <a:gd name="csY16" fmla="*/ 1785252 h 2793519"/>
+                <a:gd name="csX17" fmla="*/ 576793 w 2840252"/>
+                <a:gd name="csY17" fmla="*/ 1784166 h 2793519"/>
+                <a:gd name="csX18" fmla="*/ 435158 w 2840252"/>
+                <a:gd name="csY18" fmla="*/ 1752692 h 2793519"/>
+                <a:gd name="csX19" fmla="*/ 393915 w 2840252"/>
+                <a:gd name="csY19" fmla="*/ 1687572 h 2793519"/>
+                <a:gd name="csX20" fmla="*/ 458492 w 2840252"/>
+                <a:gd name="csY20" fmla="*/ 1646330 h 2793519"/>
+                <a:gd name="csX21" fmla="*/ 600127 w 2840252"/>
+                <a:gd name="csY21" fmla="*/ 1677805 h 2793519"/>
+                <a:gd name="csX22" fmla="*/ 641370 w 2840252"/>
+                <a:gd name="csY22" fmla="*/ 1742924 h 2793519"/>
+                <a:gd name="csX23" fmla="*/ 881227 w 2840252"/>
+                <a:gd name="csY23" fmla="*/ 2280703 h 2793519"/>
+                <a:gd name="csX24" fmla="*/ 901848 w 2840252"/>
+                <a:gd name="csY24" fmla="*/ 2260082 h 2793519"/>
+                <a:gd name="csX25" fmla="*/ 978906 w 2840252"/>
+                <a:gd name="csY25" fmla="*/ 2260082 h 2793519"/>
+                <a:gd name="csX26" fmla="*/ 978906 w 2840252"/>
+                <a:gd name="csY26" fmla="*/ 2336597 h 2793519"/>
+                <a:gd name="csX27" fmla="*/ 957742 w 2840252"/>
+                <a:gd name="csY27" fmla="*/ 2357761 h 2793519"/>
+                <a:gd name="csX28" fmla="*/ 919213 w 2840252"/>
+                <a:gd name="csY28" fmla="*/ 2373498 h 2793519"/>
+                <a:gd name="csX29" fmla="*/ 881227 w 2840252"/>
+                <a:gd name="csY29" fmla="*/ 2357761 h 2793519"/>
+                <a:gd name="csX30" fmla="*/ 881227 w 2840252"/>
+                <a:gd name="csY30" fmla="*/ 2280703 h 2793519"/>
+                <a:gd name="csX31" fmla="*/ 1252408 w 2840252"/>
+                <a:gd name="csY31" fmla="*/ 1379340 h 2793519"/>
+                <a:gd name="csX32" fmla="*/ 1208452 w 2840252"/>
+                <a:gd name="csY32" fmla="*/ 1402132 h 2793519"/>
+                <a:gd name="csX33" fmla="*/ 1176978 w 2840252"/>
+                <a:gd name="csY33" fmla="*/ 1391821 h 2793519"/>
+                <a:gd name="csX34" fmla="*/ 1066275 w 2840252"/>
+                <a:gd name="csY34" fmla="*/ 1313135 h 2793519"/>
+                <a:gd name="csX35" fmla="*/ 1053793 w 2840252"/>
+                <a:gd name="csY35" fmla="*/ 1237162 h 2793519"/>
+                <a:gd name="csX36" fmla="*/ 1129766 w 2840252"/>
+                <a:gd name="csY36" fmla="*/ 1224681 h 2793519"/>
+                <a:gd name="csX37" fmla="*/ 1239927 w 2840252"/>
+                <a:gd name="csY37" fmla="*/ 1303367 h 2793519"/>
+                <a:gd name="csX38" fmla="*/ 1252408 w 2840252"/>
+                <a:gd name="csY38" fmla="*/ 1379340 h 2793519"/>
+                <a:gd name="csX39" fmla="*/ 1098834 w 2840252"/>
+                <a:gd name="csY39" fmla="*/ 1820525 h 2793519"/>
+                <a:gd name="csX40" fmla="*/ 1153101 w 2840252"/>
+                <a:gd name="csY40" fmla="*/ 1763545 h 2793519"/>
+                <a:gd name="csX41" fmla="*/ 1207367 w 2840252"/>
+                <a:gd name="csY41" fmla="*/ 1815098 h 2793519"/>
+                <a:gd name="csX42" fmla="*/ 1207367 w 2840252"/>
+                <a:gd name="csY42" fmla="*/ 1820525 h 2793519"/>
+                <a:gd name="csX43" fmla="*/ 1123833 w 2840252"/>
+                <a:gd name="csY43" fmla="*/ 2150212 h 2793519"/>
+                <a:gd name="csX44" fmla="*/ 1098834 w 2840252"/>
+                <a:gd name="csY44" fmla="*/ 1820525 h 2793519"/>
+                <a:gd name="csX45" fmla="*/ 1448309 w 2840252"/>
+                <a:gd name="csY45" fmla="*/ 829622 h 2793519"/>
+                <a:gd name="csX46" fmla="*/ 1521569 w 2840252"/>
+                <a:gd name="csY46" fmla="*/ 805745 h 2793519"/>
+                <a:gd name="csX47" fmla="*/ 1657777 w 2840252"/>
+                <a:gd name="csY47" fmla="*/ 873578 h 2793519"/>
+                <a:gd name="csX48" fmla="*/ 1682197 w 2840252"/>
+                <a:gd name="csY48" fmla="*/ 946838 h 2793519"/>
+                <a:gd name="csX49" fmla="*/ 1633357 w 2840252"/>
+                <a:gd name="csY49" fmla="*/ 976684 h 2793519"/>
+                <a:gd name="csX50" fmla="*/ 1609480 w 2840252"/>
+                <a:gd name="csY50" fmla="*/ 970715 h 2793519"/>
+                <a:gd name="csX51" fmla="*/ 1472729 w 2840252"/>
+                <a:gd name="csY51" fmla="*/ 902339 h 2793519"/>
+                <a:gd name="csX52" fmla="*/ 1448309 w 2840252"/>
+                <a:gd name="csY52" fmla="*/ 829622 h 2793519"/>
+                <a:gd name="csX53" fmla="*/ 1971979 w 2840252"/>
+                <a:gd name="csY53" fmla="*/ 474178 h 2793519"/>
+                <a:gd name="csX54" fmla="*/ 1997484 w 2840252"/>
+                <a:gd name="csY54" fmla="*/ 546353 h 2793519"/>
+                <a:gd name="csX55" fmla="*/ 1945388 w 2840252"/>
+                <a:gd name="csY55" fmla="*/ 657056 h 2793519"/>
+                <a:gd name="csX56" fmla="*/ 1896006 w 2840252"/>
+                <a:gd name="csY56" fmla="*/ 687988 h 2793519"/>
+                <a:gd name="csX57" fmla="*/ 1872672 w 2840252"/>
+                <a:gd name="csY57" fmla="*/ 682561 h 2793519"/>
+                <a:gd name="csX58" fmla="*/ 1847166 w 2840252"/>
+                <a:gd name="csY58" fmla="*/ 610387 h 2793519"/>
+                <a:gd name="csX59" fmla="*/ 1899805 w 2840252"/>
+                <a:gd name="csY59" fmla="*/ 499684 h 2793519"/>
+                <a:gd name="csX60" fmla="*/ 1971979 w 2840252"/>
+                <a:gd name="csY60" fmla="*/ 474178 h 2793519"/>
+                <a:gd name="csX61" fmla="*/ 2277498 w 2840252"/>
+                <a:gd name="csY61" fmla="*/ 919704 h 2793519"/>
+                <a:gd name="csX62" fmla="*/ 2193385 w 2840252"/>
+                <a:gd name="csY62" fmla="*/ 801404 h 2793519"/>
+                <a:gd name="csX63" fmla="*/ 2205867 w 2840252"/>
+                <a:gd name="csY63" fmla="*/ 725974 h 2793519"/>
+                <a:gd name="csX64" fmla="*/ 2281839 w 2840252"/>
+                <a:gd name="csY64" fmla="*/ 738455 h 2793519"/>
+                <a:gd name="csX65" fmla="*/ 2365952 w 2840252"/>
+                <a:gd name="csY65" fmla="*/ 856756 h 2793519"/>
+                <a:gd name="csX66" fmla="*/ 2352928 w 2840252"/>
+                <a:gd name="csY66" fmla="*/ 932186 h 2793519"/>
+                <a:gd name="csX67" fmla="*/ 2321454 w 2840252"/>
+                <a:gd name="csY67" fmla="*/ 942496 h 2793519"/>
+                <a:gd name="csX68" fmla="*/ 2277498 w 2840252"/>
+                <a:gd name="csY68" fmla="*/ 919704 h 2793519"/>
+                <a:gd name="csX69" fmla="*/ 2307344 w 2840252"/>
+                <a:gd name="csY69" fmla="*/ 1226852 h 2793519"/>
+                <a:gd name="csX70" fmla="*/ 2253078 w 2840252"/>
+                <a:gd name="csY70" fmla="*/ 1281118 h 2793519"/>
+                <a:gd name="csX71" fmla="*/ 2196641 w 2840252"/>
+                <a:gd name="csY71" fmla="*/ 1226852 h 2793519"/>
+                <a:gd name="csX72" fmla="*/ 2248194 w 2840252"/>
+                <a:gd name="csY72" fmla="*/ 1172585 h 2793519"/>
+                <a:gd name="csX73" fmla="*/ 2253078 w 2840252"/>
+                <a:gd name="csY73" fmla="*/ 1172585 h 2793519"/>
+                <a:gd name="csX74" fmla="*/ 2307344 w 2840252"/>
+                <a:gd name="csY74" fmla="*/ 1226852 h 2793519"/>
+                <a:gd name="csX75" fmla="*/ 1923682 w 2840252"/>
+                <a:gd name="csY75" fmla="*/ 1254527 h 2793519"/>
+                <a:gd name="csX76" fmla="*/ 1891122 w 2840252"/>
+                <a:gd name="csY76" fmla="*/ 1265381 h 2793519"/>
+                <a:gd name="csX77" fmla="*/ 1847709 w 2840252"/>
+                <a:gd name="csY77" fmla="*/ 1243674 h 2793519"/>
+                <a:gd name="csX78" fmla="*/ 1800497 w 2840252"/>
+                <a:gd name="csY78" fmla="*/ 1180725 h 2793519"/>
+                <a:gd name="csX79" fmla="*/ 1811351 w 2840252"/>
+                <a:gd name="csY79" fmla="*/ 1104753 h 2793519"/>
+                <a:gd name="csX80" fmla="*/ 1887323 w 2840252"/>
+                <a:gd name="csY80" fmla="*/ 1115606 h 2793519"/>
+                <a:gd name="csX81" fmla="*/ 1934535 w 2840252"/>
+                <a:gd name="csY81" fmla="*/ 1178555 h 2793519"/>
+                <a:gd name="csX82" fmla="*/ 1923682 w 2840252"/>
+                <a:gd name="csY82" fmla="*/ 1254527 h 2793519"/>
+                <a:gd name="csX83" fmla="*/ 1559012 w 2840252"/>
+                <a:gd name="csY83" fmla="*/ 1944795 h 2793519"/>
+                <a:gd name="csX84" fmla="*/ 1648552 w 2840252"/>
+                <a:gd name="csY84" fmla="*/ 1934484 h 2793519"/>
+                <a:gd name="csX85" fmla="*/ 1708787 w 2840252"/>
+                <a:gd name="csY85" fmla="*/ 1982238 h 2793519"/>
+                <a:gd name="csX86" fmla="*/ 1661033 w 2840252"/>
+                <a:gd name="csY86" fmla="*/ 2042474 h 2793519"/>
+                <a:gd name="csX87" fmla="*/ 1571494 w 2840252"/>
+                <a:gd name="csY87" fmla="*/ 2052785 h 2793519"/>
+                <a:gd name="csX88" fmla="*/ 1565524 w 2840252"/>
+                <a:gd name="csY88" fmla="*/ 2053327 h 2793519"/>
+                <a:gd name="csX89" fmla="*/ 1511258 w 2840252"/>
+                <a:gd name="csY89" fmla="*/ 2005030 h 2793519"/>
+                <a:gd name="csX90" fmla="*/ 1559012 w 2840252"/>
+                <a:gd name="csY90" fmla="*/ 1944795 h 2793519"/>
+                <a:gd name="csX91" fmla="*/ 1555756 w 2840252"/>
+                <a:gd name="csY91" fmla="*/ 1458026 h 2793519"/>
+                <a:gd name="csX92" fmla="*/ 1555756 w 2840252"/>
+                <a:gd name="csY92" fmla="*/ 1396705 h 2793519"/>
+                <a:gd name="csX93" fmla="*/ 1610023 w 2840252"/>
+                <a:gd name="csY93" fmla="*/ 1342439 h 2793519"/>
+                <a:gd name="csX94" fmla="*/ 1664289 w 2840252"/>
+                <a:gd name="csY94" fmla="*/ 1396705 h 2793519"/>
+                <a:gd name="csX95" fmla="*/ 1664289 w 2840252"/>
+                <a:gd name="csY95" fmla="*/ 1458026 h 2793519"/>
+                <a:gd name="csX96" fmla="*/ 1610023 w 2840252"/>
+                <a:gd name="csY96" fmla="*/ 1512292 h 2793519"/>
+                <a:gd name="csX97" fmla="*/ 1555756 w 2840252"/>
+                <a:gd name="csY97" fmla="*/ 1458026 h 2793519"/>
+                <a:gd name="csX98" fmla="*/ 1916085 w 2840252"/>
+                <a:gd name="csY98" fmla="*/ 1753235 h 2793519"/>
+                <a:gd name="csX99" fmla="*/ 1905774 w 2840252"/>
+                <a:gd name="csY99" fmla="*/ 1677262 h 2793519"/>
+                <a:gd name="csX100" fmla="*/ 2005081 w 2840252"/>
+                <a:gd name="csY100" fmla="*/ 1545937 h 2793519"/>
+                <a:gd name="csX101" fmla="*/ 2081597 w 2840252"/>
+                <a:gd name="csY101" fmla="*/ 1535627 h 2793519"/>
+                <a:gd name="csX102" fmla="*/ 2091907 w 2840252"/>
+                <a:gd name="csY102" fmla="*/ 1611600 h 2793519"/>
+                <a:gd name="csX103" fmla="*/ 1992057 w 2840252"/>
+                <a:gd name="csY103" fmla="*/ 1742924 h 2793519"/>
+                <a:gd name="csX104" fmla="*/ 1948644 w 2840252"/>
+                <a:gd name="csY104" fmla="*/ 1764088 h 2793519"/>
+                <a:gd name="csX105" fmla="*/ 1916085 w 2840252"/>
+                <a:gd name="csY105" fmla="*/ 1753235 h 2793519"/>
+                <a:gd name="csX0" fmla="*/ 2559683 w 2840252"/>
+                <a:gd name="csY0" fmla="*/ 224011 h 2793519"/>
+                <a:gd name="csX1" fmla="*/ 2547201 w 2840252"/>
+                <a:gd name="csY1" fmla="*/ 213158 h 2793519"/>
+                <a:gd name="csX2" fmla="*/ 1886238 w 2840252"/>
+                <a:gd name="csY2" fmla="*/ 6403 h 2793519"/>
+                <a:gd name="csX3" fmla="*/ 1295821 w 2840252"/>
+                <a:gd name="csY3" fmla="*/ 366188 h 2793519"/>
+                <a:gd name="csX4" fmla="*/ 830759 w 2840252"/>
+                <a:gd name="csY4" fmla="*/ 914821 h 2793519"/>
+                <a:gd name="csX5" fmla="*/ 367867 w 2840252"/>
+                <a:gd name="csY5" fmla="*/ 1285459 h 2793519"/>
+                <a:gd name="csX6" fmla="*/ 3198 w 2840252"/>
+                <a:gd name="csY6" fmla="*/ 1897583 h 2793519"/>
+                <a:gd name="csX7" fmla="*/ 249024 w 2840252"/>
+                <a:gd name="csY7" fmla="*/ 2549321 h 2793519"/>
+                <a:gd name="csX8" fmla="*/ 249024 w 2840252"/>
+                <a:gd name="csY8" fmla="*/ 2549864 h 2793519"/>
+                <a:gd name="csX9" fmla="*/ 268560 w 2840252"/>
+                <a:gd name="csY9" fmla="*/ 2568314 h 2793519"/>
+                <a:gd name="csX10" fmla="*/ 828588 w 2840252"/>
+                <a:gd name="csY10" fmla="*/ 2793519 h 2793519"/>
+                <a:gd name="csX11" fmla="*/ 1199227 w 2840252"/>
+                <a:gd name="csY11" fmla="*/ 2702895 h 2793519"/>
+                <a:gd name="csX12" fmla="*/ 2031129 w 2840252"/>
+                <a:gd name="csY12" fmla="*/ 2120075 h 2793519"/>
+                <a:gd name="csX13" fmla="*/ 2715970 w 2840252"/>
+                <a:gd name="csY13" fmla="*/ 1289801 h 2793519"/>
+                <a:gd name="csX14" fmla="*/ 2559683 w 2840252"/>
+                <a:gd name="csY14" fmla="*/ 224011 h 2793519"/>
+                <a:gd name="csX15" fmla="*/ 641370 w 2840252"/>
+                <a:gd name="csY15" fmla="*/ 1742924 h 2793519"/>
+                <a:gd name="csX16" fmla="*/ 588731 w 2840252"/>
+                <a:gd name="csY16" fmla="*/ 1785252 h 2793519"/>
+                <a:gd name="csX17" fmla="*/ 576793 w 2840252"/>
+                <a:gd name="csY17" fmla="*/ 1784166 h 2793519"/>
+                <a:gd name="csX18" fmla="*/ 435158 w 2840252"/>
+                <a:gd name="csY18" fmla="*/ 1752692 h 2793519"/>
+                <a:gd name="csX19" fmla="*/ 393915 w 2840252"/>
+                <a:gd name="csY19" fmla="*/ 1687572 h 2793519"/>
+                <a:gd name="csX20" fmla="*/ 458492 w 2840252"/>
+                <a:gd name="csY20" fmla="*/ 1646330 h 2793519"/>
+                <a:gd name="csX21" fmla="*/ 600127 w 2840252"/>
+                <a:gd name="csY21" fmla="*/ 1677805 h 2793519"/>
+                <a:gd name="csX22" fmla="*/ 641370 w 2840252"/>
+                <a:gd name="csY22" fmla="*/ 1742924 h 2793519"/>
+                <a:gd name="csX23" fmla="*/ 881227 w 2840252"/>
+                <a:gd name="csY23" fmla="*/ 2280703 h 2793519"/>
+                <a:gd name="csX24" fmla="*/ 901848 w 2840252"/>
+                <a:gd name="csY24" fmla="*/ 2260082 h 2793519"/>
+                <a:gd name="csX25" fmla="*/ 978906 w 2840252"/>
+                <a:gd name="csY25" fmla="*/ 2260082 h 2793519"/>
+                <a:gd name="csX26" fmla="*/ 978906 w 2840252"/>
+                <a:gd name="csY26" fmla="*/ 2336597 h 2793519"/>
+                <a:gd name="csX27" fmla="*/ 957742 w 2840252"/>
+                <a:gd name="csY27" fmla="*/ 2357761 h 2793519"/>
+                <a:gd name="csX28" fmla="*/ 919213 w 2840252"/>
+                <a:gd name="csY28" fmla="*/ 2373498 h 2793519"/>
+                <a:gd name="csX29" fmla="*/ 881227 w 2840252"/>
+                <a:gd name="csY29" fmla="*/ 2357761 h 2793519"/>
+                <a:gd name="csX30" fmla="*/ 881227 w 2840252"/>
+                <a:gd name="csY30" fmla="*/ 2280703 h 2793519"/>
+                <a:gd name="csX31" fmla="*/ 1252408 w 2840252"/>
+                <a:gd name="csY31" fmla="*/ 1379340 h 2793519"/>
+                <a:gd name="csX32" fmla="*/ 1208452 w 2840252"/>
+                <a:gd name="csY32" fmla="*/ 1402132 h 2793519"/>
+                <a:gd name="csX33" fmla="*/ 1176978 w 2840252"/>
+                <a:gd name="csY33" fmla="*/ 1391821 h 2793519"/>
+                <a:gd name="csX34" fmla="*/ 1066275 w 2840252"/>
+                <a:gd name="csY34" fmla="*/ 1313135 h 2793519"/>
+                <a:gd name="csX35" fmla="*/ 1053793 w 2840252"/>
+                <a:gd name="csY35" fmla="*/ 1237162 h 2793519"/>
+                <a:gd name="csX36" fmla="*/ 1129766 w 2840252"/>
+                <a:gd name="csY36" fmla="*/ 1224681 h 2793519"/>
+                <a:gd name="csX37" fmla="*/ 1239927 w 2840252"/>
+                <a:gd name="csY37" fmla="*/ 1303367 h 2793519"/>
+                <a:gd name="csX38" fmla="*/ 1252408 w 2840252"/>
+                <a:gd name="csY38" fmla="*/ 1379340 h 2793519"/>
+                <a:gd name="csX39" fmla="*/ 771827 w 2840252"/>
+                <a:gd name="csY39" fmla="*/ 2096222 h 2793519"/>
+                <a:gd name="csX40" fmla="*/ 1153101 w 2840252"/>
+                <a:gd name="csY40" fmla="*/ 1763545 h 2793519"/>
+                <a:gd name="csX41" fmla="*/ 1207367 w 2840252"/>
+                <a:gd name="csY41" fmla="*/ 1815098 h 2793519"/>
+                <a:gd name="csX42" fmla="*/ 1207367 w 2840252"/>
+                <a:gd name="csY42" fmla="*/ 1820525 h 2793519"/>
+                <a:gd name="csX43" fmla="*/ 1123833 w 2840252"/>
+                <a:gd name="csY43" fmla="*/ 2150212 h 2793519"/>
+                <a:gd name="csX44" fmla="*/ 771827 w 2840252"/>
+                <a:gd name="csY44" fmla="*/ 2096222 h 2793519"/>
+                <a:gd name="csX45" fmla="*/ 1448309 w 2840252"/>
+                <a:gd name="csY45" fmla="*/ 829622 h 2793519"/>
+                <a:gd name="csX46" fmla="*/ 1521569 w 2840252"/>
+                <a:gd name="csY46" fmla="*/ 805745 h 2793519"/>
+                <a:gd name="csX47" fmla="*/ 1657777 w 2840252"/>
+                <a:gd name="csY47" fmla="*/ 873578 h 2793519"/>
+                <a:gd name="csX48" fmla="*/ 1682197 w 2840252"/>
+                <a:gd name="csY48" fmla="*/ 946838 h 2793519"/>
+                <a:gd name="csX49" fmla="*/ 1633357 w 2840252"/>
+                <a:gd name="csY49" fmla="*/ 976684 h 2793519"/>
+                <a:gd name="csX50" fmla="*/ 1609480 w 2840252"/>
+                <a:gd name="csY50" fmla="*/ 970715 h 2793519"/>
+                <a:gd name="csX51" fmla="*/ 1472729 w 2840252"/>
+                <a:gd name="csY51" fmla="*/ 902339 h 2793519"/>
+                <a:gd name="csX52" fmla="*/ 1448309 w 2840252"/>
+                <a:gd name="csY52" fmla="*/ 829622 h 2793519"/>
+                <a:gd name="csX53" fmla="*/ 1971979 w 2840252"/>
+                <a:gd name="csY53" fmla="*/ 474178 h 2793519"/>
+                <a:gd name="csX54" fmla="*/ 1997484 w 2840252"/>
+                <a:gd name="csY54" fmla="*/ 546353 h 2793519"/>
+                <a:gd name="csX55" fmla="*/ 1945388 w 2840252"/>
+                <a:gd name="csY55" fmla="*/ 657056 h 2793519"/>
+                <a:gd name="csX56" fmla="*/ 1896006 w 2840252"/>
+                <a:gd name="csY56" fmla="*/ 687988 h 2793519"/>
+                <a:gd name="csX57" fmla="*/ 1872672 w 2840252"/>
+                <a:gd name="csY57" fmla="*/ 682561 h 2793519"/>
+                <a:gd name="csX58" fmla="*/ 1847166 w 2840252"/>
+                <a:gd name="csY58" fmla="*/ 610387 h 2793519"/>
+                <a:gd name="csX59" fmla="*/ 1899805 w 2840252"/>
+                <a:gd name="csY59" fmla="*/ 499684 h 2793519"/>
+                <a:gd name="csX60" fmla="*/ 1971979 w 2840252"/>
+                <a:gd name="csY60" fmla="*/ 474178 h 2793519"/>
+                <a:gd name="csX61" fmla="*/ 2277498 w 2840252"/>
+                <a:gd name="csY61" fmla="*/ 919704 h 2793519"/>
+                <a:gd name="csX62" fmla="*/ 2193385 w 2840252"/>
+                <a:gd name="csY62" fmla="*/ 801404 h 2793519"/>
+                <a:gd name="csX63" fmla="*/ 2205867 w 2840252"/>
+                <a:gd name="csY63" fmla="*/ 725974 h 2793519"/>
+                <a:gd name="csX64" fmla="*/ 2281839 w 2840252"/>
+                <a:gd name="csY64" fmla="*/ 738455 h 2793519"/>
+                <a:gd name="csX65" fmla="*/ 2365952 w 2840252"/>
+                <a:gd name="csY65" fmla="*/ 856756 h 2793519"/>
+                <a:gd name="csX66" fmla="*/ 2352928 w 2840252"/>
+                <a:gd name="csY66" fmla="*/ 932186 h 2793519"/>
+                <a:gd name="csX67" fmla="*/ 2321454 w 2840252"/>
+                <a:gd name="csY67" fmla="*/ 942496 h 2793519"/>
+                <a:gd name="csX68" fmla="*/ 2277498 w 2840252"/>
+                <a:gd name="csY68" fmla="*/ 919704 h 2793519"/>
+                <a:gd name="csX69" fmla="*/ 2307344 w 2840252"/>
+                <a:gd name="csY69" fmla="*/ 1226852 h 2793519"/>
+                <a:gd name="csX70" fmla="*/ 2253078 w 2840252"/>
+                <a:gd name="csY70" fmla="*/ 1281118 h 2793519"/>
+                <a:gd name="csX71" fmla="*/ 2196641 w 2840252"/>
+                <a:gd name="csY71" fmla="*/ 1226852 h 2793519"/>
+                <a:gd name="csX72" fmla="*/ 2248194 w 2840252"/>
+                <a:gd name="csY72" fmla="*/ 1172585 h 2793519"/>
+                <a:gd name="csX73" fmla="*/ 2253078 w 2840252"/>
+                <a:gd name="csY73" fmla="*/ 1172585 h 2793519"/>
+                <a:gd name="csX74" fmla="*/ 2307344 w 2840252"/>
+                <a:gd name="csY74" fmla="*/ 1226852 h 2793519"/>
+                <a:gd name="csX75" fmla="*/ 1923682 w 2840252"/>
+                <a:gd name="csY75" fmla="*/ 1254527 h 2793519"/>
+                <a:gd name="csX76" fmla="*/ 1891122 w 2840252"/>
+                <a:gd name="csY76" fmla="*/ 1265381 h 2793519"/>
+                <a:gd name="csX77" fmla="*/ 1847709 w 2840252"/>
+                <a:gd name="csY77" fmla="*/ 1243674 h 2793519"/>
+                <a:gd name="csX78" fmla="*/ 1800497 w 2840252"/>
+                <a:gd name="csY78" fmla="*/ 1180725 h 2793519"/>
+                <a:gd name="csX79" fmla="*/ 1811351 w 2840252"/>
+                <a:gd name="csY79" fmla="*/ 1104753 h 2793519"/>
+                <a:gd name="csX80" fmla="*/ 1887323 w 2840252"/>
+                <a:gd name="csY80" fmla="*/ 1115606 h 2793519"/>
+                <a:gd name="csX81" fmla="*/ 1934535 w 2840252"/>
+                <a:gd name="csY81" fmla="*/ 1178555 h 2793519"/>
+                <a:gd name="csX82" fmla="*/ 1923682 w 2840252"/>
+                <a:gd name="csY82" fmla="*/ 1254527 h 2793519"/>
+                <a:gd name="csX83" fmla="*/ 1559012 w 2840252"/>
+                <a:gd name="csY83" fmla="*/ 1944795 h 2793519"/>
+                <a:gd name="csX84" fmla="*/ 1648552 w 2840252"/>
+                <a:gd name="csY84" fmla="*/ 1934484 h 2793519"/>
+                <a:gd name="csX85" fmla="*/ 1708787 w 2840252"/>
+                <a:gd name="csY85" fmla="*/ 1982238 h 2793519"/>
+                <a:gd name="csX86" fmla="*/ 1661033 w 2840252"/>
+                <a:gd name="csY86" fmla="*/ 2042474 h 2793519"/>
+                <a:gd name="csX87" fmla="*/ 1571494 w 2840252"/>
+                <a:gd name="csY87" fmla="*/ 2052785 h 2793519"/>
+                <a:gd name="csX88" fmla="*/ 1565524 w 2840252"/>
+                <a:gd name="csY88" fmla="*/ 2053327 h 2793519"/>
+                <a:gd name="csX89" fmla="*/ 1511258 w 2840252"/>
+                <a:gd name="csY89" fmla="*/ 2005030 h 2793519"/>
+                <a:gd name="csX90" fmla="*/ 1559012 w 2840252"/>
+                <a:gd name="csY90" fmla="*/ 1944795 h 2793519"/>
+                <a:gd name="csX91" fmla="*/ 1555756 w 2840252"/>
+                <a:gd name="csY91" fmla="*/ 1458026 h 2793519"/>
+                <a:gd name="csX92" fmla="*/ 1555756 w 2840252"/>
+                <a:gd name="csY92" fmla="*/ 1396705 h 2793519"/>
+                <a:gd name="csX93" fmla="*/ 1610023 w 2840252"/>
+                <a:gd name="csY93" fmla="*/ 1342439 h 2793519"/>
+                <a:gd name="csX94" fmla="*/ 1664289 w 2840252"/>
+                <a:gd name="csY94" fmla="*/ 1396705 h 2793519"/>
+                <a:gd name="csX95" fmla="*/ 1664289 w 2840252"/>
+                <a:gd name="csY95" fmla="*/ 1458026 h 2793519"/>
+                <a:gd name="csX96" fmla="*/ 1610023 w 2840252"/>
+                <a:gd name="csY96" fmla="*/ 1512292 h 2793519"/>
+                <a:gd name="csX97" fmla="*/ 1555756 w 2840252"/>
+                <a:gd name="csY97" fmla="*/ 1458026 h 2793519"/>
+                <a:gd name="csX98" fmla="*/ 1916085 w 2840252"/>
+                <a:gd name="csY98" fmla="*/ 1753235 h 2793519"/>
+                <a:gd name="csX99" fmla="*/ 1905774 w 2840252"/>
+                <a:gd name="csY99" fmla="*/ 1677262 h 2793519"/>
+                <a:gd name="csX100" fmla="*/ 2005081 w 2840252"/>
+                <a:gd name="csY100" fmla="*/ 1545937 h 2793519"/>
+                <a:gd name="csX101" fmla="*/ 2081597 w 2840252"/>
+                <a:gd name="csY101" fmla="*/ 1535627 h 2793519"/>
+                <a:gd name="csX102" fmla="*/ 2091907 w 2840252"/>
+                <a:gd name="csY102" fmla="*/ 1611600 h 2793519"/>
+                <a:gd name="csX103" fmla="*/ 1992057 w 2840252"/>
+                <a:gd name="csY103" fmla="*/ 1742924 h 2793519"/>
+                <a:gd name="csX104" fmla="*/ 1948644 w 2840252"/>
+                <a:gd name="csY104" fmla="*/ 1764088 h 2793519"/>
+                <a:gd name="csX105" fmla="*/ 1916085 w 2840252"/>
+                <a:gd name="csY105" fmla="*/ 1753235 h 2793519"/>
+                <a:gd name="csX0" fmla="*/ 2559683 w 2840252"/>
+                <a:gd name="csY0" fmla="*/ 224011 h 2793519"/>
+                <a:gd name="csX1" fmla="*/ 2547201 w 2840252"/>
+                <a:gd name="csY1" fmla="*/ 213158 h 2793519"/>
+                <a:gd name="csX2" fmla="*/ 1886238 w 2840252"/>
+                <a:gd name="csY2" fmla="*/ 6403 h 2793519"/>
+                <a:gd name="csX3" fmla="*/ 1295821 w 2840252"/>
+                <a:gd name="csY3" fmla="*/ 366188 h 2793519"/>
+                <a:gd name="csX4" fmla="*/ 830759 w 2840252"/>
+                <a:gd name="csY4" fmla="*/ 914821 h 2793519"/>
+                <a:gd name="csX5" fmla="*/ 367867 w 2840252"/>
+                <a:gd name="csY5" fmla="*/ 1285459 h 2793519"/>
+                <a:gd name="csX6" fmla="*/ 3198 w 2840252"/>
+                <a:gd name="csY6" fmla="*/ 1897583 h 2793519"/>
+                <a:gd name="csX7" fmla="*/ 249024 w 2840252"/>
+                <a:gd name="csY7" fmla="*/ 2549321 h 2793519"/>
+                <a:gd name="csX8" fmla="*/ 249024 w 2840252"/>
+                <a:gd name="csY8" fmla="*/ 2549864 h 2793519"/>
+                <a:gd name="csX9" fmla="*/ 268560 w 2840252"/>
+                <a:gd name="csY9" fmla="*/ 2568314 h 2793519"/>
+                <a:gd name="csX10" fmla="*/ 828588 w 2840252"/>
+                <a:gd name="csY10" fmla="*/ 2793519 h 2793519"/>
+                <a:gd name="csX11" fmla="*/ 1199227 w 2840252"/>
+                <a:gd name="csY11" fmla="*/ 2702895 h 2793519"/>
+                <a:gd name="csX12" fmla="*/ 2031129 w 2840252"/>
+                <a:gd name="csY12" fmla="*/ 2120075 h 2793519"/>
+                <a:gd name="csX13" fmla="*/ 2715970 w 2840252"/>
+                <a:gd name="csY13" fmla="*/ 1289801 h 2793519"/>
+                <a:gd name="csX14" fmla="*/ 2559683 w 2840252"/>
+                <a:gd name="csY14" fmla="*/ 224011 h 2793519"/>
+                <a:gd name="csX15" fmla="*/ 641370 w 2840252"/>
+                <a:gd name="csY15" fmla="*/ 1742924 h 2793519"/>
+                <a:gd name="csX16" fmla="*/ 588731 w 2840252"/>
+                <a:gd name="csY16" fmla="*/ 1785252 h 2793519"/>
+                <a:gd name="csX17" fmla="*/ 576793 w 2840252"/>
+                <a:gd name="csY17" fmla="*/ 1784166 h 2793519"/>
+                <a:gd name="csX18" fmla="*/ 435158 w 2840252"/>
+                <a:gd name="csY18" fmla="*/ 1752692 h 2793519"/>
+                <a:gd name="csX19" fmla="*/ 393915 w 2840252"/>
+                <a:gd name="csY19" fmla="*/ 1687572 h 2793519"/>
+                <a:gd name="csX20" fmla="*/ 458492 w 2840252"/>
+                <a:gd name="csY20" fmla="*/ 1646330 h 2793519"/>
+                <a:gd name="csX21" fmla="*/ 600127 w 2840252"/>
+                <a:gd name="csY21" fmla="*/ 1677805 h 2793519"/>
+                <a:gd name="csX22" fmla="*/ 641370 w 2840252"/>
+                <a:gd name="csY22" fmla="*/ 1742924 h 2793519"/>
+                <a:gd name="csX23" fmla="*/ 881227 w 2840252"/>
+                <a:gd name="csY23" fmla="*/ 2280703 h 2793519"/>
+                <a:gd name="csX24" fmla="*/ 901848 w 2840252"/>
+                <a:gd name="csY24" fmla="*/ 2260082 h 2793519"/>
+                <a:gd name="csX25" fmla="*/ 978906 w 2840252"/>
+                <a:gd name="csY25" fmla="*/ 2260082 h 2793519"/>
+                <a:gd name="csX26" fmla="*/ 978906 w 2840252"/>
+                <a:gd name="csY26" fmla="*/ 2336597 h 2793519"/>
+                <a:gd name="csX27" fmla="*/ 957742 w 2840252"/>
+                <a:gd name="csY27" fmla="*/ 2357761 h 2793519"/>
+                <a:gd name="csX28" fmla="*/ 919213 w 2840252"/>
+                <a:gd name="csY28" fmla="*/ 2373498 h 2793519"/>
+                <a:gd name="csX29" fmla="*/ 881227 w 2840252"/>
+                <a:gd name="csY29" fmla="*/ 2357761 h 2793519"/>
+                <a:gd name="csX30" fmla="*/ 881227 w 2840252"/>
+                <a:gd name="csY30" fmla="*/ 2280703 h 2793519"/>
+                <a:gd name="csX31" fmla="*/ 1252408 w 2840252"/>
+                <a:gd name="csY31" fmla="*/ 1379340 h 2793519"/>
+                <a:gd name="csX32" fmla="*/ 1208452 w 2840252"/>
+                <a:gd name="csY32" fmla="*/ 1402132 h 2793519"/>
+                <a:gd name="csX33" fmla="*/ 1176978 w 2840252"/>
+                <a:gd name="csY33" fmla="*/ 1391821 h 2793519"/>
+                <a:gd name="csX34" fmla="*/ 1066275 w 2840252"/>
+                <a:gd name="csY34" fmla="*/ 1313135 h 2793519"/>
+                <a:gd name="csX35" fmla="*/ 1053793 w 2840252"/>
+                <a:gd name="csY35" fmla="*/ 1237162 h 2793519"/>
+                <a:gd name="csX36" fmla="*/ 1129766 w 2840252"/>
+                <a:gd name="csY36" fmla="*/ 1224681 h 2793519"/>
+                <a:gd name="csX37" fmla="*/ 1239927 w 2840252"/>
+                <a:gd name="csY37" fmla="*/ 1303367 h 2793519"/>
+                <a:gd name="csX38" fmla="*/ 1252408 w 2840252"/>
+                <a:gd name="csY38" fmla="*/ 1379340 h 2793519"/>
+                <a:gd name="csX39" fmla="*/ 771827 w 2840252"/>
+                <a:gd name="csY39" fmla="*/ 2096222 h 2793519"/>
+                <a:gd name="csX40" fmla="*/ 958738 w 2840252"/>
+                <a:gd name="csY40" fmla="*/ 1629685 h 2793519"/>
+                <a:gd name="csX41" fmla="*/ 1207367 w 2840252"/>
+                <a:gd name="csY41" fmla="*/ 1815098 h 2793519"/>
+                <a:gd name="csX42" fmla="*/ 1207367 w 2840252"/>
+                <a:gd name="csY42" fmla="*/ 1820525 h 2793519"/>
+                <a:gd name="csX43" fmla="*/ 1123833 w 2840252"/>
+                <a:gd name="csY43" fmla="*/ 2150212 h 2793519"/>
+                <a:gd name="csX44" fmla="*/ 771827 w 2840252"/>
+                <a:gd name="csY44" fmla="*/ 2096222 h 2793519"/>
+                <a:gd name="csX45" fmla="*/ 1448309 w 2840252"/>
+                <a:gd name="csY45" fmla="*/ 829622 h 2793519"/>
+                <a:gd name="csX46" fmla="*/ 1521569 w 2840252"/>
+                <a:gd name="csY46" fmla="*/ 805745 h 2793519"/>
+                <a:gd name="csX47" fmla="*/ 1657777 w 2840252"/>
+                <a:gd name="csY47" fmla="*/ 873578 h 2793519"/>
+                <a:gd name="csX48" fmla="*/ 1682197 w 2840252"/>
+                <a:gd name="csY48" fmla="*/ 946838 h 2793519"/>
+                <a:gd name="csX49" fmla="*/ 1633357 w 2840252"/>
+                <a:gd name="csY49" fmla="*/ 976684 h 2793519"/>
+                <a:gd name="csX50" fmla="*/ 1609480 w 2840252"/>
+                <a:gd name="csY50" fmla="*/ 970715 h 2793519"/>
+                <a:gd name="csX51" fmla="*/ 1472729 w 2840252"/>
+                <a:gd name="csY51" fmla="*/ 902339 h 2793519"/>
+                <a:gd name="csX52" fmla="*/ 1448309 w 2840252"/>
+                <a:gd name="csY52" fmla="*/ 829622 h 2793519"/>
+                <a:gd name="csX53" fmla="*/ 1971979 w 2840252"/>
+                <a:gd name="csY53" fmla="*/ 474178 h 2793519"/>
+                <a:gd name="csX54" fmla="*/ 1997484 w 2840252"/>
+                <a:gd name="csY54" fmla="*/ 546353 h 2793519"/>
+                <a:gd name="csX55" fmla="*/ 1945388 w 2840252"/>
+                <a:gd name="csY55" fmla="*/ 657056 h 2793519"/>
+                <a:gd name="csX56" fmla="*/ 1896006 w 2840252"/>
+                <a:gd name="csY56" fmla="*/ 687988 h 2793519"/>
+                <a:gd name="csX57" fmla="*/ 1872672 w 2840252"/>
+                <a:gd name="csY57" fmla="*/ 682561 h 2793519"/>
+                <a:gd name="csX58" fmla="*/ 1847166 w 2840252"/>
+                <a:gd name="csY58" fmla="*/ 610387 h 2793519"/>
+                <a:gd name="csX59" fmla="*/ 1899805 w 2840252"/>
+                <a:gd name="csY59" fmla="*/ 499684 h 2793519"/>
+                <a:gd name="csX60" fmla="*/ 1971979 w 2840252"/>
+                <a:gd name="csY60" fmla="*/ 474178 h 2793519"/>
+                <a:gd name="csX61" fmla="*/ 2277498 w 2840252"/>
+                <a:gd name="csY61" fmla="*/ 919704 h 2793519"/>
+                <a:gd name="csX62" fmla="*/ 2193385 w 2840252"/>
+                <a:gd name="csY62" fmla="*/ 801404 h 2793519"/>
+                <a:gd name="csX63" fmla="*/ 2205867 w 2840252"/>
+                <a:gd name="csY63" fmla="*/ 725974 h 2793519"/>
+                <a:gd name="csX64" fmla="*/ 2281839 w 2840252"/>
+                <a:gd name="csY64" fmla="*/ 738455 h 2793519"/>
+                <a:gd name="csX65" fmla="*/ 2365952 w 2840252"/>
+                <a:gd name="csY65" fmla="*/ 856756 h 2793519"/>
+                <a:gd name="csX66" fmla="*/ 2352928 w 2840252"/>
+                <a:gd name="csY66" fmla="*/ 932186 h 2793519"/>
+                <a:gd name="csX67" fmla="*/ 2321454 w 2840252"/>
+                <a:gd name="csY67" fmla="*/ 942496 h 2793519"/>
+                <a:gd name="csX68" fmla="*/ 2277498 w 2840252"/>
+                <a:gd name="csY68" fmla="*/ 919704 h 2793519"/>
+                <a:gd name="csX69" fmla="*/ 2307344 w 2840252"/>
+                <a:gd name="csY69" fmla="*/ 1226852 h 2793519"/>
+                <a:gd name="csX70" fmla="*/ 2253078 w 2840252"/>
+                <a:gd name="csY70" fmla="*/ 1281118 h 2793519"/>
+                <a:gd name="csX71" fmla="*/ 2196641 w 2840252"/>
+                <a:gd name="csY71" fmla="*/ 1226852 h 2793519"/>
+                <a:gd name="csX72" fmla="*/ 2248194 w 2840252"/>
+                <a:gd name="csY72" fmla="*/ 1172585 h 2793519"/>
+                <a:gd name="csX73" fmla="*/ 2253078 w 2840252"/>
+                <a:gd name="csY73" fmla="*/ 1172585 h 2793519"/>
+                <a:gd name="csX74" fmla="*/ 2307344 w 2840252"/>
+                <a:gd name="csY74" fmla="*/ 1226852 h 2793519"/>
+                <a:gd name="csX75" fmla="*/ 1923682 w 2840252"/>
+                <a:gd name="csY75" fmla="*/ 1254527 h 2793519"/>
+                <a:gd name="csX76" fmla="*/ 1891122 w 2840252"/>
+                <a:gd name="csY76" fmla="*/ 1265381 h 2793519"/>
+                <a:gd name="csX77" fmla="*/ 1847709 w 2840252"/>
+                <a:gd name="csY77" fmla="*/ 1243674 h 2793519"/>
+                <a:gd name="csX78" fmla="*/ 1800497 w 2840252"/>
+                <a:gd name="csY78" fmla="*/ 1180725 h 2793519"/>
+                <a:gd name="csX79" fmla="*/ 1811351 w 2840252"/>
+                <a:gd name="csY79" fmla="*/ 1104753 h 2793519"/>
+                <a:gd name="csX80" fmla="*/ 1887323 w 2840252"/>
+                <a:gd name="csY80" fmla="*/ 1115606 h 2793519"/>
+                <a:gd name="csX81" fmla="*/ 1934535 w 2840252"/>
+                <a:gd name="csY81" fmla="*/ 1178555 h 2793519"/>
+                <a:gd name="csX82" fmla="*/ 1923682 w 2840252"/>
+                <a:gd name="csY82" fmla="*/ 1254527 h 2793519"/>
+                <a:gd name="csX83" fmla="*/ 1559012 w 2840252"/>
+                <a:gd name="csY83" fmla="*/ 1944795 h 2793519"/>
+                <a:gd name="csX84" fmla="*/ 1648552 w 2840252"/>
+                <a:gd name="csY84" fmla="*/ 1934484 h 2793519"/>
+                <a:gd name="csX85" fmla="*/ 1708787 w 2840252"/>
+                <a:gd name="csY85" fmla="*/ 1982238 h 2793519"/>
+                <a:gd name="csX86" fmla="*/ 1661033 w 2840252"/>
+                <a:gd name="csY86" fmla="*/ 2042474 h 2793519"/>
+                <a:gd name="csX87" fmla="*/ 1571494 w 2840252"/>
+                <a:gd name="csY87" fmla="*/ 2052785 h 2793519"/>
+                <a:gd name="csX88" fmla="*/ 1565524 w 2840252"/>
+                <a:gd name="csY88" fmla="*/ 2053327 h 2793519"/>
+                <a:gd name="csX89" fmla="*/ 1511258 w 2840252"/>
+                <a:gd name="csY89" fmla="*/ 2005030 h 2793519"/>
+                <a:gd name="csX90" fmla="*/ 1559012 w 2840252"/>
+                <a:gd name="csY90" fmla="*/ 1944795 h 2793519"/>
+                <a:gd name="csX91" fmla="*/ 1555756 w 2840252"/>
+                <a:gd name="csY91" fmla="*/ 1458026 h 2793519"/>
+                <a:gd name="csX92" fmla="*/ 1555756 w 2840252"/>
+                <a:gd name="csY92" fmla="*/ 1396705 h 2793519"/>
+                <a:gd name="csX93" fmla="*/ 1610023 w 2840252"/>
+                <a:gd name="csY93" fmla="*/ 1342439 h 2793519"/>
+                <a:gd name="csX94" fmla="*/ 1664289 w 2840252"/>
+                <a:gd name="csY94" fmla="*/ 1396705 h 2793519"/>
+                <a:gd name="csX95" fmla="*/ 1664289 w 2840252"/>
+                <a:gd name="csY95" fmla="*/ 1458026 h 2793519"/>
+                <a:gd name="csX96" fmla="*/ 1610023 w 2840252"/>
+                <a:gd name="csY96" fmla="*/ 1512292 h 2793519"/>
+                <a:gd name="csX97" fmla="*/ 1555756 w 2840252"/>
+                <a:gd name="csY97" fmla="*/ 1458026 h 2793519"/>
+                <a:gd name="csX98" fmla="*/ 1916085 w 2840252"/>
+                <a:gd name="csY98" fmla="*/ 1753235 h 2793519"/>
+                <a:gd name="csX99" fmla="*/ 1905774 w 2840252"/>
+                <a:gd name="csY99" fmla="*/ 1677262 h 2793519"/>
+                <a:gd name="csX100" fmla="*/ 2005081 w 2840252"/>
+                <a:gd name="csY100" fmla="*/ 1545937 h 2793519"/>
+                <a:gd name="csX101" fmla="*/ 2081597 w 2840252"/>
+                <a:gd name="csY101" fmla="*/ 1535627 h 2793519"/>
+                <a:gd name="csX102" fmla="*/ 2091907 w 2840252"/>
+                <a:gd name="csY102" fmla="*/ 1611600 h 2793519"/>
+                <a:gd name="csX103" fmla="*/ 1992057 w 2840252"/>
+                <a:gd name="csY103" fmla="*/ 1742924 h 2793519"/>
+                <a:gd name="csX104" fmla="*/ 1948644 w 2840252"/>
+                <a:gd name="csY104" fmla="*/ 1764088 h 2793519"/>
+                <a:gd name="csX105" fmla="*/ 1916085 w 2840252"/>
+                <a:gd name="csY105" fmla="*/ 1753235 h 2793519"/>
+                <a:gd name="csX0" fmla="*/ 2559683 w 2840252"/>
+                <a:gd name="csY0" fmla="*/ 224011 h 2793519"/>
+                <a:gd name="csX1" fmla="*/ 2547201 w 2840252"/>
+                <a:gd name="csY1" fmla="*/ 213158 h 2793519"/>
+                <a:gd name="csX2" fmla="*/ 1886238 w 2840252"/>
+                <a:gd name="csY2" fmla="*/ 6403 h 2793519"/>
+                <a:gd name="csX3" fmla="*/ 1295821 w 2840252"/>
+                <a:gd name="csY3" fmla="*/ 366188 h 2793519"/>
+                <a:gd name="csX4" fmla="*/ 830759 w 2840252"/>
+                <a:gd name="csY4" fmla="*/ 914821 h 2793519"/>
+                <a:gd name="csX5" fmla="*/ 367867 w 2840252"/>
+                <a:gd name="csY5" fmla="*/ 1285459 h 2793519"/>
+                <a:gd name="csX6" fmla="*/ 3198 w 2840252"/>
+                <a:gd name="csY6" fmla="*/ 1897583 h 2793519"/>
+                <a:gd name="csX7" fmla="*/ 249024 w 2840252"/>
+                <a:gd name="csY7" fmla="*/ 2549321 h 2793519"/>
+                <a:gd name="csX8" fmla="*/ 249024 w 2840252"/>
+                <a:gd name="csY8" fmla="*/ 2549864 h 2793519"/>
+                <a:gd name="csX9" fmla="*/ 268560 w 2840252"/>
+                <a:gd name="csY9" fmla="*/ 2568314 h 2793519"/>
+                <a:gd name="csX10" fmla="*/ 828588 w 2840252"/>
+                <a:gd name="csY10" fmla="*/ 2793519 h 2793519"/>
+                <a:gd name="csX11" fmla="*/ 1199227 w 2840252"/>
+                <a:gd name="csY11" fmla="*/ 2702895 h 2793519"/>
+                <a:gd name="csX12" fmla="*/ 2031129 w 2840252"/>
+                <a:gd name="csY12" fmla="*/ 2120075 h 2793519"/>
+                <a:gd name="csX13" fmla="*/ 2715970 w 2840252"/>
+                <a:gd name="csY13" fmla="*/ 1289801 h 2793519"/>
+                <a:gd name="csX14" fmla="*/ 2559683 w 2840252"/>
+                <a:gd name="csY14" fmla="*/ 224011 h 2793519"/>
+                <a:gd name="csX15" fmla="*/ 641370 w 2840252"/>
+                <a:gd name="csY15" fmla="*/ 1742924 h 2793519"/>
+                <a:gd name="csX16" fmla="*/ 588731 w 2840252"/>
+                <a:gd name="csY16" fmla="*/ 1785252 h 2793519"/>
+                <a:gd name="csX17" fmla="*/ 576793 w 2840252"/>
+                <a:gd name="csY17" fmla="*/ 1784166 h 2793519"/>
+                <a:gd name="csX18" fmla="*/ 435158 w 2840252"/>
+                <a:gd name="csY18" fmla="*/ 1752692 h 2793519"/>
+                <a:gd name="csX19" fmla="*/ 393915 w 2840252"/>
+                <a:gd name="csY19" fmla="*/ 1687572 h 2793519"/>
+                <a:gd name="csX20" fmla="*/ 458492 w 2840252"/>
+                <a:gd name="csY20" fmla="*/ 1646330 h 2793519"/>
+                <a:gd name="csX21" fmla="*/ 600127 w 2840252"/>
+                <a:gd name="csY21" fmla="*/ 1677805 h 2793519"/>
+                <a:gd name="csX22" fmla="*/ 641370 w 2840252"/>
+                <a:gd name="csY22" fmla="*/ 1742924 h 2793519"/>
+                <a:gd name="csX23" fmla="*/ 881227 w 2840252"/>
+                <a:gd name="csY23" fmla="*/ 2280703 h 2793519"/>
+                <a:gd name="csX24" fmla="*/ 901848 w 2840252"/>
+                <a:gd name="csY24" fmla="*/ 2260082 h 2793519"/>
+                <a:gd name="csX25" fmla="*/ 978906 w 2840252"/>
+                <a:gd name="csY25" fmla="*/ 2260082 h 2793519"/>
+                <a:gd name="csX26" fmla="*/ 978906 w 2840252"/>
+                <a:gd name="csY26" fmla="*/ 2336597 h 2793519"/>
+                <a:gd name="csX27" fmla="*/ 957742 w 2840252"/>
+                <a:gd name="csY27" fmla="*/ 2357761 h 2793519"/>
+                <a:gd name="csX28" fmla="*/ 919213 w 2840252"/>
+                <a:gd name="csY28" fmla="*/ 2373498 h 2793519"/>
+                <a:gd name="csX29" fmla="*/ 881227 w 2840252"/>
+                <a:gd name="csY29" fmla="*/ 2357761 h 2793519"/>
+                <a:gd name="csX30" fmla="*/ 881227 w 2840252"/>
+                <a:gd name="csY30" fmla="*/ 2280703 h 2793519"/>
+                <a:gd name="csX31" fmla="*/ 1252408 w 2840252"/>
+                <a:gd name="csY31" fmla="*/ 1379340 h 2793519"/>
+                <a:gd name="csX32" fmla="*/ 1208452 w 2840252"/>
+                <a:gd name="csY32" fmla="*/ 1402132 h 2793519"/>
+                <a:gd name="csX33" fmla="*/ 1176978 w 2840252"/>
+                <a:gd name="csY33" fmla="*/ 1391821 h 2793519"/>
+                <a:gd name="csX34" fmla="*/ 1066275 w 2840252"/>
+                <a:gd name="csY34" fmla="*/ 1313135 h 2793519"/>
+                <a:gd name="csX35" fmla="*/ 1053793 w 2840252"/>
+                <a:gd name="csY35" fmla="*/ 1237162 h 2793519"/>
+                <a:gd name="csX36" fmla="*/ 1129766 w 2840252"/>
+                <a:gd name="csY36" fmla="*/ 1224681 h 2793519"/>
+                <a:gd name="csX37" fmla="*/ 1239927 w 2840252"/>
+                <a:gd name="csY37" fmla="*/ 1303367 h 2793519"/>
+                <a:gd name="csX38" fmla="*/ 1252408 w 2840252"/>
+                <a:gd name="csY38" fmla="*/ 1379340 h 2793519"/>
+                <a:gd name="csX39" fmla="*/ 771827 w 2840252"/>
+                <a:gd name="csY39" fmla="*/ 2096222 h 2793519"/>
+                <a:gd name="csX40" fmla="*/ 958738 w 2840252"/>
+                <a:gd name="csY40" fmla="*/ 1629685 h 2793519"/>
+                <a:gd name="csX41" fmla="*/ 1207367 w 2840252"/>
+                <a:gd name="csY41" fmla="*/ 1815098 h 2793519"/>
+                <a:gd name="csX42" fmla="*/ 1452747 w 2840252"/>
+                <a:gd name="csY42" fmla="*/ 1656497 h 2793519"/>
+                <a:gd name="csX43" fmla="*/ 1123833 w 2840252"/>
+                <a:gd name="csY43" fmla="*/ 2150212 h 2793519"/>
+                <a:gd name="csX44" fmla="*/ 771827 w 2840252"/>
+                <a:gd name="csY44" fmla="*/ 2096222 h 2793519"/>
+                <a:gd name="csX45" fmla="*/ 1448309 w 2840252"/>
+                <a:gd name="csY45" fmla="*/ 829622 h 2793519"/>
+                <a:gd name="csX46" fmla="*/ 1521569 w 2840252"/>
+                <a:gd name="csY46" fmla="*/ 805745 h 2793519"/>
+                <a:gd name="csX47" fmla="*/ 1657777 w 2840252"/>
+                <a:gd name="csY47" fmla="*/ 873578 h 2793519"/>
+                <a:gd name="csX48" fmla="*/ 1682197 w 2840252"/>
+                <a:gd name="csY48" fmla="*/ 946838 h 2793519"/>
+                <a:gd name="csX49" fmla="*/ 1633357 w 2840252"/>
+                <a:gd name="csY49" fmla="*/ 976684 h 2793519"/>
+                <a:gd name="csX50" fmla="*/ 1609480 w 2840252"/>
+                <a:gd name="csY50" fmla="*/ 970715 h 2793519"/>
+                <a:gd name="csX51" fmla="*/ 1472729 w 2840252"/>
+                <a:gd name="csY51" fmla="*/ 902339 h 2793519"/>
+                <a:gd name="csX52" fmla="*/ 1448309 w 2840252"/>
+                <a:gd name="csY52" fmla="*/ 829622 h 2793519"/>
+                <a:gd name="csX53" fmla="*/ 1971979 w 2840252"/>
+                <a:gd name="csY53" fmla="*/ 474178 h 2793519"/>
+                <a:gd name="csX54" fmla="*/ 1997484 w 2840252"/>
+                <a:gd name="csY54" fmla="*/ 546353 h 2793519"/>
+                <a:gd name="csX55" fmla="*/ 1945388 w 2840252"/>
+                <a:gd name="csY55" fmla="*/ 657056 h 2793519"/>
+                <a:gd name="csX56" fmla="*/ 1896006 w 2840252"/>
+                <a:gd name="csY56" fmla="*/ 687988 h 2793519"/>
+                <a:gd name="csX57" fmla="*/ 1872672 w 2840252"/>
+                <a:gd name="csY57" fmla="*/ 682561 h 2793519"/>
+                <a:gd name="csX58" fmla="*/ 1847166 w 2840252"/>
+                <a:gd name="csY58" fmla="*/ 610387 h 2793519"/>
+                <a:gd name="csX59" fmla="*/ 1899805 w 2840252"/>
+                <a:gd name="csY59" fmla="*/ 499684 h 2793519"/>
+                <a:gd name="csX60" fmla="*/ 1971979 w 2840252"/>
+                <a:gd name="csY60" fmla="*/ 474178 h 2793519"/>
+                <a:gd name="csX61" fmla="*/ 2277498 w 2840252"/>
+                <a:gd name="csY61" fmla="*/ 919704 h 2793519"/>
+                <a:gd name="csX62" fmla="*/ 2193385 w 2840252"/>
+                <a:gd name="csY62" fmla="*/ 801404 h 2793519"/>
+                <a:gd name="csX63" fmla="*/ 2205867 w 2840252"/>
+                <a:gd name="csY63" fmla="*/ 725974 h 2793519"/>
+                <a:gd name="csX64" fmla="*/ 2281839 w 2840252"/>
+                <a:gd name="csY64" fmla="*/ 738455 h 2793519"/>
+                <a:gd name="csX65" fmla="*/ 2365952 w 2840252"/>
+                <a:gd name="csY65" fmla="*/ 856756 h 2793519"/>
+                <a:gd name="csX66" fmla="*/ 2352928 w 2840252"/>
+                <a:gd name="csY66" fmla="*/ 932186 h 2793519"/>
+                <a:gd name="csX67" fmla="*/ 2321454 w 2840252"/>
+                <a:gd name="csY67" fmla="*/ 942496 h 2793519"/>
+                <a:gd name="csX68" fmla="*/ 2277498 w 2840252"/>
+                <a:gd name="csY68" fmla="*/ 919704 h 2793519"/>
+                <a:gd name="csX69" fmla="*/ 2307344 w 2840252"/>
+                <a:gd name="csY69" fmla="*/ 1226852 h 2793519"/>
+                <a:gd name="csX70" fmla="*/ 2253078 w 2840252"/>
+                <a:gd name="csY70" fmla="*/ 1281118 h 2793519"/>
+                <a:gd name="csX71" fmla="*/ 2196641 w 2840252"/>
+                <a:gd name="csY71" fmla="*/ 1226852 h 2793519"/>
+                <a:gd name="csX72" fmla="*/ 2248194 w 2840252"/>
+                <a:gd name="csY72" fmla="*/ 1172585 h 2793519"/>
+                <a:gd name="csX73" fmla="*/ 2253078 w 2840252"/>
+                <a:gd name="csY73" fmla="*/ 1172585 h 2793519"/>
+                <a:gd name="csX74" fmla="*/ 2307344 w 2840252"/>
+                <a:gd name="csY74" fmla="*/ 1226852 h 2793519"/>
+                <a:gd name="csX75" fmla="*/ 1923682 w 2840252"/>
+                <a:gd name="csY75" fmla="*/ 1254527 h 2793519"/>
+                <a:gd name="csX76" fmla="*/ 1891122 w 2840252"/>
+                <a:gd name="csY76" fmla="*/ 1265381 h 2793519"/>
+                <a:gd name="csX77" fmla="*/ 1847709 w 2840252"/>
+                <a:gd name="csY77" fmla="*/ 1243674 h 2793519"/>
+                <a:gd name="csX78" fmla="*/ 1800497 w 2840252"/>
+                <a:gd name="csY78" fmla="*/ 1180725 h 2793519"/>
+                <a:gd name="csX79" fmla="*/ 1811351 w 2840252"/>
+                <a:gd name="csY79" fmla="*/ 1104753 h 2793519"/>
+                <a:gd name="csX80" fmla="*/ 1887323 w 2840252"/>
+                <a:gd name="csY80" fmla="*/ 1115606 h 2793519"/>
+                <a:gd name="csX81" fmla="*/ 1934535 w 2840252"/>
+                <a:gd name="csY81" fmla="*/ 1178555 h 2793519"/>
+                <a:gd name="csX82" fmla="*/ 1923682 w 2840252"/>
+                <a:gd name="csY82" fmla="*/ 1254527 h 2793519"/>
+                <a:gd name="csX83" fmla="*/ 1559012 w 2840252"/>
+                <a:gd name="csY83" fmla="*/ 1944795 h 2793519"/>
+                <a:gd name="csX84" fmla="*/ 1648552 w 2840252"/>
+                <a:gd name="csY84" fmla="*/ 1934484 h 2793519"/>
+                <a:gd name="csX85" fmla="*/ 1708787 w 2840252"/>
+                <a:gd name="csY85" fmla="*/ 1982238 h 2793519"/>
+                <a:gd name="csX86" fmla="*/ 1661033 w 2840252"/>
+                <a:gd name="csY86" fmla="*/ 2042474 h 2793519"/>
+                <a:gd name="csX87" fmla="*/ 1571494 w 2840252"/>
+                <a:gd name="csY87" fmla="*/ 2052785 h 2793519"/>
+                <a:gd name="csX88" fmla="*/ 1565524 w 2840252"/>
+                <a:gd name="csY88" fmla="*/ 2053327 h 2793519"/>
+                <a:gd name="csX89" fmla="*/ 1511258 w 2840252"/>
+                <a:gd name="csY89" fmla="*/ 2005030 h 2793519"/>
+                <a:gd name="csX90" fmla="*/ 1559012 w 2840252"/>
+                <a:gd name="csY90" fmla="*/ 1944795 h 2793519"/>
+                <a:gd name="csX91" fmla="*/ 1555756 w 2840252"/>
+                <a:gd name="csY91" fmla="*/ 1458026 h 2793519"/>
+                <a:gd name="csX92" fmla="*/ 1555756 w 2840252"/>
+                <a:gd name="csY92" fmla="*/ 1396705 h 2793519"/>
+                <a:gd name="csX93" fmla="*/ 1610023 w 2840252"/>
+                <a:gd name="csY93" fmla="*/ 1342439 h 2793519"/>
+                <a:gd name="csX94" fmla="*/ 1664289 w 2840252"/>
+                <a:gd name="csY94" fmla="*/ 1396705 h 2793519"/>
+                <a:gd name="csX95" fmla="*/ 1664289 w 2840252"/>
+                <a:gd name="csY95" fmla="*/ 1458026 h 2793519"/>
+                <a:gd name="csX96" fmla="*/ 1610023 w 2840252"/>
+                <a:gd name="csY96" fmla="*/ 1512292 h 2793519"/>
+                <a:gd name="csX97" fmla="*/ 1555756 w 2840252"/>
+                <a:gd name="csY97" fmla="*/ 1458026 h 2793519"/>
+                <a:gd name="csX98" fmla="*/ 1916085 w 2840252"/>
+                <a:gd name="csY98" fmla="*/ 1753235 h 2793519"/>
+                <a:gd name="csX99" fmla="*/ 1905774 w 2840252"/>
+                <a:gd name="csY99" fmla="*/ 1677262 h 2793519"/>
+                <a:gd name="csX100" fmla="*/ 2005081 w 2840252"/>
+                <a:gd name="csY100" fmla="*/ 1545937 h 2793519"/>
+                <a:gd name="csX101" fmla="*/ 2081597 w 2840252"/>
+                <a:gd name="csY101" fmla="*/ 1535627 h 2793519"/>
+                <a:gd name="csX102" fmla="*/ 2091907 w 2840252"/>
+                <a:gd name="csY102" fmla="*/ 1611600 h 2793519"/>
+                <a:gd name="csX103" fmla="*/ 1992057 w 2840252"/>
+                <a:gd name="csY103" fmla="*/ 1742924 h 2793519"/>
+                <a:gd name="csX104" fmla="*/ 1948644 w 2840252"/>
+                <a:gd name="csY104" fmla="*/ 1764088 h 2793519"/>
+                <a:gd name="csX105" fmla="*/ 1916085 w 2840252"/>
+                <a:gd name="csY105" fmla="*/ 1753235 h 2793519"/>
+                <a:gd name="csX0" fmla="*/ 2559683 w 2840252"/>
+                <a:gd name="csY0" fmla="*/ 224011 h 2793519"/>
+                <a:gd name="csX1" fmla="*/ 2547201 w 2840252"/>
+                <a:gd name="csY1" fmla="*/ 213158 h 2793519"/>
+                <a:gd name="csX2" fmla="*/ 1886238 w 2840252"/>
+                <a:gd name="csY2" fmla="*/ 6403 h 2793519"/>
+                <a:gd name="csX3" fmla="*/ 1295821 w 2840252"/>
+                <a:gd name="csY3" fmla="*/ 366188 h 2793519"/>
+                <a:gd name="csX4" fmla="*/ 830759 w 2840252"/>
+                <a:gd name="csY4" fmla="*/ 914821 h 2793519"/>
+                <a:gd name="csX5" fmla="*/ 367867 w 2840252"/>
+                <a:gd name="csY5" fmla="*/ 1285459 h 2793519"/>
+                <a:gd name="csX6" fmla="*/ 3198 w 2840252"/>
+                <a:gd name="csY6" fmla="*/ 1897583 h 2793519"/>
+                <a:gd name="csX7" fmla="*/ 249024 w 2840252"/>
+                <a:gd name="csY7" fmla="*/ 2549321 h 2793519"/>
+                <a:gd name="csX8" fmla="*/ 249024 w 2840252"/>
+                <a:gd name="csY8" fmla="*/ 2549864 h 2793519"/>
+                <a:gd name="csX9" fmla="*/ 268560 w 2840252"/>
+                <a:gd name="csY9" fmla="*/ 2568314 h 2793519"/>
+                <a:gd name="csX10" fmla="*/ 828588 w 2840252"/>
+                <a:gd name="csY10" fmla="*/ 2793519 h 2793519"/>
+                <a:gd name="csX11" fmla="*/ 1199227 w 2840252"/>
+                <a:gd name="csY11" fmla="*/ 2702895 h 2793519"/>
+                <a:gd name="csX12" fmla="*/ 2031129 w 2840252"/>
+                <a:gd name="csY12" fmla="*/ 2120075 h 2793519"/>
+                <a:gd name="csX13" fmla="*/ 2715970 w 2840252"/>
+                <a:gd name="csY13" fmla="*/ 1289801 h 2793519"/>
+                <a:gd name="csX14" fmla="*/ 2559683 w 2840252"/>
+                <a:gd name="csY14" fmla="*/ 224011 h 2793519"/>
+                <a:gd name="csX15" fmla="*/ 641370 w 2840252"/>
+                <a:gd name="csY15" fmla="*/ 1742924 h 2793519"/>
+                <a:gd name="csX16" fmla="*/ 588731 w 2840252"/>
+                <a:gd name="csY16" fmla="*/ 1785252 h 2793519"/>
+                <a:gd name="csX17" fmla="*/ 576793 w 2840252"/>
+                <a:gd name="csY17" fmla="*/ 1784166 h 2793519"/>
+                <a:gd name="csX18" fmla="*/ 435158 w 2840252"/>
+                <a:gd name="csY18" fmla="*/ 1752692 h 2793519"/>
+                <a:gd name="csX19" fmla="*/ 393915 w 2840252"/>
+                <a:gd name="csY19" fmla="*/ 1687572 h 2793519"/>
+                <a:gd name="csX20" fmla="*/ 458492 w 2840252"/>
+                <a:gd name="csY20" fmla="*/ 1646330 h 2793519"/>
+                <a:gd name="csX21" fmla="*/ 600127 w 2840252"/>
+                <a:gd name="csY21" fmla="*/ 1677805 h 2793519"/>
+                <a:gd name="csX22" fmla="*/ 641370 w 2840252"/>
+                <a:gd name="csY22" fmla="*/ 1742924 h 2793519"/>
+                <a:gd name="csX23" fmla="*/ 881227 w 2840252"/>
+                <a:gd name="csY23" fmla="*/ 2280703 h 2793519"/>
+                <a:gd name="csX24" fmla="*/ 901848 w 2840252"/>
+                <a:gd name="csY24" fmla="*/ 2260082 h 2793519"/>
+                <a:gd name="csX25" fmla="*/ 978906 w 2840252"/>
+                <a:gd name="csY25" fmla="*/ 2260082 h 2793519"/>
+                <a:gd name="csX26" fmla="*/ 978906 w 2840252"/>
+                <a:gd name="csY26" fmla="*/ 2336597 h 2793519"/>
+                <a:gd name="csX27" fmla="*/ 957742 w 2840252"/>
+                <a:gd name="csY27" fmla="*/ 2357761 h 2793519"/>
+                <a:gd name="csX28" fmla="*/ 919213 w 2840252"/>
+                <a:gd name="csY28" fmla="*/ 2373498 h 2793519"/>
+                <a:gd name="csX29" fmla="*/ 881227 w 2840252"/>
+                <a:gd name="csY29" fmla="*/ 2357761 h 2793519"/>
+                <a:gd name="csX30" fmla="*/ 881227 w 2840252"/>
+                <a:gd name="csY30" fmla="*/ 2280703 h 2793519"/>
+                <a:gd name="csX31" fmla="*/ 1252408 w 2840252"/>
+                <a:gd name="csY31" fmla="*/ 1379340 h 2793519"/>
+                <a:gd name="csX32" fmla="*/ 1208452 w 2840252"/>
+                <a:gd name="csY32" fmla="*/ 1402132 h 2793519"/>
+                <a:gd name="csX33" fmla="*/ 1176978 w 2840252"/>
+                <a:gd name="csY33" fmla="*/ 1391821 h 2793519"/>
+                <a:gd name="csX34" fmla="*/ 1066275 w 2840252"/>
+                <a:gd name="csY34" fmla="*/ 1313135 h 2793519"/>
+                <a:gd name="csX35" fmla="*/ 1053793 w 2840252"/>
+                <a:gd name="csY35" fmla="*/ 1237162 h 2793519"/>
+                <a:gd name="csX36" fmla="*/ 1129766 w 2840252"/>
+                <a:gd name="csY36" fmla="*/ 1224681 h 2793519"/>
+                <a:gd name="csX37" fmla="*/ 1239927 w 2840252"/>
+                <a:gd name="csY37" fmla="*/ 1303367 h 2793519"/>
+                <a:gd name="csX38" fmla="*/ 1252408 w 2840252"/>
+                <a:gd name="csY38" fmla="*/ 1379340 h 2793519"/>
+                <a:gd name="csX39" fmla="*/ 771827 w 2840252"/>
+                <a:gd name="csY39" fmla="*/ 2096222 h 2793519"/>
+                <a:gd name="csX40" fmla="*/ 958738 w 2840252"/>
+                <a:gd name="csY40" fmla="*/ 1629685 h 2793519"/>
+                <a:gd name="csX41" fmla="*/ 1297530 w 2840252"/>
+                <a:gd name="csY41" fmla="*/ 1597279 h 2793519"/>
+                <a:gd name="csX42" fmla="*/ 1452747 w 2840252"/>
+                <a:gd name="csY42" fmla="*/ 1656497 h 2793519"/>
+                <a:gd name="csX43" fmla="*/ 1123833 w 2840252"/>
+                <a:gd name="csY43" fmla="*/ 2150212 h 2793519"/>
+                <a:gd name="csX44" fmla="*/ 771827 w 2840252"/>
+                <a:gd name="csY44" fmla="*/ 2096222 h 2793519"/>
+                <a:gd name="csX45" fmla="*/ 1448309 w 2840252"/>
+                <a:gd name="csY45" fmla="*/ 829622 h 2793519"/>
+                <a:gd name="csX46" fmla="*/ 1521569 w 2840252"/>
+                <a:gd name="csY46" fmla="*/ 805745 h 2793519"/>
+                <a:gd name="csX47" fmla="*/ 1657777 w 2840252"/>
+                <a:gd name="csY47" fmla="*/ 873578 h 2793519"/>
+                <a:gd name="csX48" fmla="*/ 1682197 w 2840252"/>
+                <a:gd name="csY48" fmla="*/ 946838 h 2793519"/>
+                <a:gd name="csX49" fmla="*/ 1633357 w 2840252"/>
+                <a:gd name="csY49" fmla="*/ 976684 h 2793519"/>
+                <a:gd name="csX50" fmla="*/ 1609480 w 2840252"/>
+                <a:gd name="csY50" fmla="*/ 970715 h 2793519"/>
+                <a:gd name="csX51" fmla="*/ 1472729 w 2840252"/>
+                <a:gd name="csY51" fmla="*/ 902339 h 2793519"/>
+                <a:gd name="csX52" fmla="*/ 1448309 w 2840252"/>
+                <a:gd name="csY52" fmla="*/ 829622 h 2793519"/>
+                <a:gd name="csX53" fmla="*/ 1971979 w 2840252"/>
+                <a:gd name="csY53" fmla="*/ 474178 h 2793519"/>
+                <a:gd name="csX54" fmla="*/ 1997484 w 2840252"/>
+                <a:gd name="csY54" fmla="*/ 546353 h 2793519"/>
+                <a:gd name="csX55" fmla="*/ 1945388 w 2840252"/>
+                <a:gd name="csY55" fmla="*/ 657056 h 2793519"/>
+                <a:gd name="csX56" fmla="*/ 1896006 w 2840252"/>
+                <a:gd name="csY56" fmla="*/ 687988 h 2793519"/>
+                <a:gd name="csX57" fmla="*/ 1872672 w 2840252"/>
+                <a:gd name="csY57" fmla="*/ 682561 h 2793519"/>
+                <a:gd name="csX58" fmla="*/ 1847166 w 2840252"/>
+                <a:gd name="csY58" fmla="*/ 610387 h 2793519"/>
+                <a:gd name="csX59" fmla="*/ 1899805 w 2840252"/>
+                <a:gd name="csY59" fmla="*/ 499684 h 2793519"/>
+                <a:gd name="csX60" fmla="*/ 1971979 w 2840252"/>
+                <a:gd name="csY60" fmla="*/ 474178 h 2793519"/>
+                <a:gd name="csX61" fmla="*/ 2277498 w 2840252"/>
+                <a:gd name="csY61" fmla="*/ 919704 h 2793519"/>
+                <a:gd name="csX62" fmla="*/ 2193385 w 2840252"/>
+                <a:gd name="csY62" fmla="*/ 801404 h 2793519"/>
+                <a:gd name="csX63" fmla="*/ 2205867 w 2840252"/>
+                <a:gd name="csY63" fmla="*/ 725974 h 2793519"/>
+                <a:gd name="csX64" fmla="*/ 2281839 w 2840252"/>
+                <a:gd name="csY64" fmla="*/ 738455 h 2793519"/>
+                <a:gd name="csX65" fmla="*/ 2365952 w 2840252"/>
+                <a:gd name="csY65" fmla="*/ 856756 h 2793519"/>
+                <a:gd name="csX66" fmla="*/ 2352928 w 2840252"/>
+                <a:gd name="csY66" fmla="*/ 932186 h 2793519"/>
+                <a:gd name="csX67" fmla="*/ 2321454 w 2840252"/>
+                <a:gd name="csY67" fmla="*/ 942496 h 2793519"/>
+                <a:gd name="csX68" fmla="*/ 2277498 w 2840252"/>
+                <a:gd name="csY68" fmla="*/ 919704 h 2793519"/>
+                <a:gd name="csX69" fmla="*/ 2307344 w 2840252"/>
+                <a:gd name="csY69" fmla="*/ 1226852 h 2793519"/>
+                <a:gd name="csX70" fmla="*/ 2253078 w 2840252"/>
+                <a:gd name="csY70" fmla="*/ 1281118 h 2793519"/>
+                <a:gd name="csX71" fmla="*/ 2196641 w 2840252"/>
+                <a:gd name="csY71" fmla="*/ 1226852 h 2793519"/>
+                <a:gd name="csX72" fmla="*/ 2248194 w 2840252"/>
+                <a:gd name="csY72" fmla="*/ 1172585 h 2793519"/>
+                <a:gd name="csX73" fmla="*/ 2253078 w 2840252"/>
+                <a:gd name="csY73" fmla="*/ 1172585 h 2793519"/>
+                <a:gd name="csX74" fmla="*/ 2307344 w 2840252"/>
+                <a:gd name="csY74" fmla="*/ 1226852 h 2793519"/>
+                <a:gd name="csX75" fmla="*/ 1923682 w 2840252"/>
+                <a:gd name="csY75" fmla="*/ 1254527 h 2793519"/>
+                <a:gd name="csX76" fmla="*/ 1891122 w 2840252"/>
+                <a:gd name="csY76" fmla="*/ 1265381 h 2793519"/>
+                <a:gd name="csX77" fmla="*/ 1847709 w 2840252"/>
+                <a:gd name="csY77" fmla="*/ 1243674 h 2793519"/>
+                <a:gd name="csX78" fmla="*/ 1800497 w 2840252"/>
+                <a:gd name="csY78" fmla="*/ 1180725 h 2793519"/>
+                <a:gd name="csX79" fmla="*/ 1811351 w 2840252"/>
+                <a:gd name="csY79" fmla="*/ 1104753 h 2793519"/>
+                <a:gd name="csX80" fmla="*/ 1887323 w 2840252"/>
+                <a:gd name="csY80" fmla="*/ 1115606 h 2793519"/>
+                <a:gd name="csX81" fmla="*/ 1934535 w 2840252"/>
+                <a:gd name="csY81" fmla="*/ 1178555 h 2793519"/>
+                <a:gd name="csX82" fmla="*/ 1923682 w 2840252"/>
+                <a:gd name="csY82" fmla="*/ 1254527 h 2793519"/>
+                <a:gd name="csX83" fmla="*/ 1559012 w 2840252"/>
+                <a:gd name="csY83" fmla="*/ 1944795 h 2793519"/>
+                <a:gd name="csX84" fmla="*/ 1648552 w 2840252"/>
+                <a:gd name="csY84" fmla="*/ 1934484 h 2793519"/>
+                <a:gd name="csX85" fmla="*/ 1708787 w 2840252"/>
+                <a:gd name="csY85" fmla="*/ 1982238 h 2793519"/>
+                <a:gd name="csX86" fmla="*/ 1661033 w 2840252"/>
+                <a:gd name="csY86" fmla="*/ 2042474 h 2793519"/>
+                <a:gd name="csX87" fmla="*/ 1571494 w 2840252"/>
+                <a:gd name="csY87" fmla="*/ 2052785 h 2793519"/>
+                <a:gd name="csX88" fmla="*/ 1565524 w 2840252"/>
+                <a:gd name="csY88" fmla="*/ 2053327 h 2793519"/>
+                <a:gd name="csX89" fmla="*/ 1511258 w 2840252"/>
+                <a:gd name="csY89" fmla="*/ 2005030 h 2793519"/>
+                <a:gd name="csX90" fmla="*/ 1559012 w 2840252"/>
+                <a:gd name="csY90" fmla="*/ 1944795 h 2793519"/>
+                <a:gd name="csX91" fmla="*/ 1555756 w 2840252"/>
+                <a:gd name="csY91" fmla="*/ 1458026 h 2793519"/>
+                <a:gd name="csX92" fmla="*/ 1555756 w 2840252"/>
+                <a:gd name="csY92" fmla="*/ 1396705 h 2793519"/>
+                <a:gd name="csX93" fmla="*/ 1610023 w 2840252"/>
+                <a:gd name="csY93" fmla="*/ 1342439 h 2793519"/>
+                <a:gd name="csX94" fmla="*/ 1664289 w 2840252"/>
+                <a:gd name="csY94" fmla="*/ 1396705 h 2793519"/>
+                <a:gd name="csX95" fmla="*/ 1664289 w 2840252"/>
+                <a:gd name="csY95" fmla="*/ 1458026 h 2793519"/>
+                <a:gd name="csX96" fmla="*/ 1610023 w 2840252"/>
+                <a:gd name="csY96" fmla="*/ 1512292 h 2793519"/>
+                <a:gd name="csX97" fmla="*/ 1555756 w 2840252"/>
+                <a:gd name="csY97" fmla="*/ 1458026 h 2793519"/>
+                <a:gd name="csX98" fmla="*/ 1916085 w 2840252"/>
+                <a:gd name="csY98" fmla="*/ 1753235 h 2793519"/>
+                <a:gd name="csX99" fmla="*/ 1905774 w 2840252"/>
+                <a:gd name="csY99" fmla="*/ 1677262 h 2793519"/>
+                <a:gd name="csX100" fmla="*/ 2005081 w 2840252"/>
+                <a:gd name="csY100" fmla="*/ 1545937 h 2793519"/>
+                <a:gd name="csX101" fmla="*/ 2081597 w 2840252"/>
+                <a:gd name="csY101" fmla="*/ 1535627 h 2793519"/>
+                <a:gd name="csX102" fmla="*/ 2091907 w 2840252"/>
+                <a:gd name="csY102" fmla="*/ 1611600 h 2793519"/>
+                <a:gd name="csX103" fmla="*/ 1992057 w 2840252"/>
+                <a:gd name="csY103" fmla="*/ 1742924 h 2793519"/>
+                <a:gd name="csX104" fmla="*/ 1948644 w 2840252"/>
+                <a:gd name="csY104" fmla="*/ 1764088 h 2793519"/>
+                <a:gd name="csX105" fmla="*/ 1916085 w 2840252"/>
+                <a:gd name="csY105" fmla="*/ 1753235 h 2793519"/>
+                <a:gd name="csX0" fmla="*/ 2559683 w 2840252"/>
+                <a:gd name="csY0" fmla="*/ 224011 h 2793519"/>
+                <a:gd name="csX1" fmla="*/ 2547201 w 2840252"/>
+                <a:gd name="csY1" fmla="*/ 213158 h 2793519"/>
+                <a:gd name="csX2" fmla="*/ 1886238 w 2840252"/>
+                <a:gd name="csY2" fmla="*/ 6403 h 2793519"/>
+                <a:gd name="csX3" fmla="*/ 1295821 w 2840252"/>
+                <a:gd name="csY3" fmla="*/ 366188 h 2793519"/>
+                <a:gd name="csX4" fmla="*/ 830759 w 2840252"/>
+                <a:gd name="csY4" fmla="*/ 914821 h 2793519"/>
+                <a:gd name="csX5" fmla="*/ 367867 w 2840252"/>
+                <a:gd name="csY5" fmla="*/ 1285459 h 2793519"/>
+                <a:gd name="csX6" fmla="*/ 3198 w 2840252"/>
+                <a:gd name="csY6" fmla="*/ 1897583 h 2793519"/>
+                <a:gd name="csX7" fmla="*/ 249024 w 2840252"/>
+                <a:gd name="csY7" fmla="*/ 2549321 h 2793519"/>
+                <a:gd name="csX8" fmla="*/ 249024 w 2840252"/>
+                <a:gd name="csY8" fmla="*/ 2549864 h 2793519"/>
+                <a:gd name="csX9" fmla="*/ 268560 w 2840252"/>
+                <a:gd name="csY9" fmla="*/ 2568314 h 2793519"/>
+                <a:gd name="csX10" fmla="*/ 828588 w 2840252"/>
+                <a:gd name="csY10" fmla="*/ 2793519 h 2793519"/>
+                <a:gd name="csX11" fmla="*/ 1199227 w 2840252"/>
+                <a:gd name="csY11" fmla="*/ 2702895 h 2793519"/>
+                <a:gd name="csX12" fmla="*/ 2031129 w 2840252"/>
+                <a:gd name="csY12" fmla="*/ 2120075 h 2793519"/>
+                <a:gd name="csX13" fmla="*/ 2715970 w 2840252"/>
+                <a:gd name="csY13" fmla="*/ 1289801 h 2793519"/>
+                <a:gd name="csX14" fmla="*/ 2559683 w 2840252"/>
+                <a:gd name="csY14" fmla="*/ 224011 h 2793519"/>
+                <a:gd name="csX15" fmla="*/ 641370 w 2840252"/>
+                <a:gd name="csY15" fmla="*/ 1742924 h 2793519"/>
+                <a:gd name="csX16" fmla="*/ 588731 w 2840252"/>
+                <a:gd name="csY16" fmla="*/ 1785252 h 2793519"/>
+                <a:gd name="csX17" fmla="*/ 576793 w 2840252"/>
+                <a:gd name="csY17" fmla="*/ 1784166 h 2793519"/>
+                <a:gd name="csX18" fmla="*/ 435158 w 2840252"/>
+                <a:gd name="csY18" fmla="*/ 1752692 h 2793519"/>
+                <a:gd name="csX19" fmla="*/ 393915 w 2840252"/>
+                <a:gd name="csY19" fmla="*/ 1687572 h 2793519"/>
+                <a:gd name="csX20" fmla="*/ 458492 w 2840252"/>
+                <a:gd name="csY20" fmla="*/ 1646330 h 2793519"/>
+                <a:gd name="csX21" fmla="*/ 600127 w 2840252"/>
+                <a:gd name="csY21" fmla="*/ 1677805 h 2793519"/>
+                <a:gd name="csX22" fmla="*/ 641370 w 2840252"/>
+                <a:gd name="csY22" fmla="*/ 1742924 h 2793519"/>
+                <a:gd name="csX23" fmla="*/ 881227 w 2840252"/>
+                <a:gd name="csY23" fmla="*/ 2280703 h 2793519"/>
+                <a:gd name="csX24" fmla="*/ 901848 w 2840252"/>
+                <a:gd name="csY24" fmla="*/ 2260082 h 2793519"/>
+                <a:gd name="csX25" fmla="*/ 978906 w 2840252"/>
+                <a:gd name="csY25" fmla="*/ 2260082 h 2793519"/>
+                <a:gd name="csX26" fmla="*/ 978906 w 2840252"/>
+                <a:gd name="csY26" fmla="*/ 2336597 h 2793519"/>
+                <a:gd name="csX27" fmla="*/ 957742 w 2840252"/>
+                <a:gd name="csY27" fmla="*/ 2357761 h 2793519"/>
+                <a:gd name="csX28" fmla="*/ 919213 w 2840252"/>
+                <a:gd name="csY28" fmla="*/ 2373498 h 2793519"/>
+                <a:gd name="csX29" fmla="*/ 881227 w 2840252"/>
+                <a:gd name="csY29" fmla="*/ 2357761 h 2793519"/>
+                <a:gd name="csX30" fmla="*/ 881227 w 2840252"/>
+                <a:gd name="csY30" fmla="*/ 2280703 h 2793519"/>
+                <a:gd name="csX31" fmla="*/ 1252408 w 2840252"/>
+                <a:gd name="csY31" fmla="*/ 1379340 h 2793519"/>
+                <a:gd name="csX32" fmla="*/ 1208452 w 2840252"/>
+                <a:gd name="csY32" fmla="*/ 1402132 h 2793519"/>
+                <a:gd name="csX33" fmla="*/ 1176978 w 2840252"/>
+                <a:gd name="csY33" fmla="*/ 1391821 h 2793519"/>
+                <a:gd name="csX34" fmla="*/ 1066275 w 2840252"/>
+                <a:gd name="csY34" fmla="*/ 1313135 h 2793519"/>
+                <a:gd name="csX35" fmla="*/ 1053793 w 2840252"/>
+                <a:gd name="csY35" fmla="*/ 1237162 h 2793519"/>
+                <a:gd name="csX36" fmla="*/ 1129766 w 2840252"/>
+                <a:gd name="csY36" fmla="*/ 1224681 h 2793519"/>
+                <a:gd name="csX37" fmla="*/ 1239927 w 2840252"/>
+                <a:gd name="csY37" fmla="*/ 1303367 h 2793519"/>
+                <a:gd name="csX38" fmla="*/ 1252408 w 2840252"/>
+                <a:gd name="csY38" fmla="*/ 1379340 h 2793519"/>
+                <a:gd name="csX39" fmla="*/ 771827 w 2840252"/>
+                <a:gd name="csY39" fmla="*/ 2096222 h 2793519"/>
+                <a:gd name="csX40" fmla="*/ 958738 w 2840252"/>
+                <a:gd name="csY40" fmla="*/ 1629685 h 2793519"/>
+                <a:gd name="csX41" fmla="*/ 1297530 w 2840252"/>
+                <a:gd name="csY41" fmla="*/ 1597279 h 2793519"/>
+                <a:gd name="csX42" fmla="*/ 1477639 w 2840252"/>
+                <a:gd name="csY42" fmla="*/ 1701233 h 2793519"/>
+                <a:gd name="csX43" fmla="*/ 1123833 w 2840252"/>
+                <a:gd name="csY43" fmla="*/ 2150212 h 2793519"/>
+                <a:gd name="csX44" fmla="*/ 771827 w 2840252"/>
+                <a:gd name="csY44" fmla="*/ 2096222 h 2793519"/>
+                <a:gd name="csX45" fmla="*/ 1448309 w 2840252"/>
+                <a:gd name="csY45" fmla="*/ 829622 h 2793519"/>
+                <a:gd name="csX46" fmla="*/ 1521569 w 2840252"/>
+                <a:gd name="csY46" fmla="*/ 805745 h 2793519"/>
+                <a:gd name="csX47" fmla="*/ 1657777 w 2840252"/>
+                <a:gd name="csY47" fmla="*/ 873578 h 2793519"/>
+                <a:gd name="csX48" fmla="*/ 1682197 w 2840252"/>
+                <a:gd name="csY48" fmla="*/ 946838 h 2793519"/>
+                <a:gd name="csX49" fmla="*/ 1633357 w 2840252"/>
+                <a:gd name="csY49" fmla="*/ 976684 h 2793519"/>
+                <a:gd name="csX50" fmla="*/ 1609480 w 2840252"/>
+                <a:gd name="csY50" fmla="*/ 970715 h 2793519"/>
+                <a:gd name="csX51" fmla="*/ 1472729 w 2840252"/>
+                <a:gd name="csY51" fmla="*/ 902339 h 2793519"/>
+                <a:gd name="csX52" fmla="*/ 1448309 w 2840252"/>
+                <a:gd name="csY52" fmla="*/ 829622 h 2793519"/>
+                <a:gd name="csX53" fmla="*/ 1971979 w 2840252"/>
+                <a:gd name="csY53" fmla="*/ 474178 h 2793519"/>
+                <a:gd name="csX54" fmla="*/ 1997484 w 2840252"/>
+                <a:gd name="csY54" fmla="*/ 546353 h 2793519"/>
+                <a:gd name="csX55" fmla="*/ 1945388 w 2840252"/>
+                <a:gd name="csY55" fmla="*/ 657056 h 2793519"/>
+                <a:gd name="csX56" fmla="*/ 1896006 w 2840252"/>
+                <a:gd name="csY56" fmla="*/ 687988 h 2793519"/>
+                <a:gd name="csX57" fmla="*/ 1872672 w 2840252"/>
+                <a:gd name="csY57" fmla="*/ 682561 h 2793519"/>
+                <a:gd name="csX58" fmla="*/ 1847166 w 2840252"/>
+                <a:gd name="csY58" fmla="*/ 610387 h 2793519"/>
+                <a:gd name="csX59" fmla="*/ 1899805 w 2840252"/>
+                <a:gd name="csY59" fmla="*/ 499684 h 2793519"/>
+                <a:gd name="csX60" fmla="*/ 1971979 w 2840252"/>
+                <a:gd name="csY60" fmla="*/ 474178 h 2793519"/>
+                <a:gd name="csX61" fmla="*/ 2277498 w 2840252"/>
+                <a:gd name="csY61" fmla="*/ 919704 h 2793519"/>
+                <a:gd name="csX62" fmla="*/ 2193385 w 2840252"/>
+                <a:gd name="csY62" fmla="*/ 801404 h 2793519"/>
+                <a:gd name="csX63" fmla="*/ 2205867 w 2840252"/>
+                <a:gd name="csY63" fmla="*/ 725974 h 2793519"/>
+                <a:gd name="csX64" fmla="*/ 2281839 w 2840252"/>
+                <a:gd name="csY64" fmla="*/ 738455 h 2793519"/>
+                <a:gd name="csX65" fmla="*/ 2365952 w 2840252"/>
+                <a:gd name="csY65" fmla="*/ 856756 h 2793519"/>
+                <a:gd name="csX66" fmla="*/ 2352928 w 2840252"/>
+                <a:gd name="csY66" fmla="*/ 932186 h 2793519"/>
+                <a:gd name="csX67" fmla="*/ 2321454 w 2840252"/>
+                <a:gd name="csY67" fmla="*/ 942496 h 2793519"/>
+                <a:gd name="csX68" fmla="*/ 2277498 w 2840252"/>
+                <a:gd name="csY68" fmla="*/ 919704 h 2793519"/>
+                <a:gd name="csX69" fmla="*/ 2307344 w 2840252"/>
+                <a:gd name="csY69" fmla="*/ 1226852 h 2793519"/>
+                <a:gd name="csX70" fmla="*/ 2253078 w 2840252"/>
+                <a:gd name="csY70" fmla="*/ 1281118 h 2793519"/>
+                <a:gd name="csX71" fmla="*/ 2196641 w 2840252"/>
+                <a:gd name="csY71" fmla="*/ 1226852 h 2793519"/>
+                <a:gd name="csX72" fmla="*/ 2248194 w 2840252"/>
+                <a:gd name="csY72" fmla="*/ 1172585 h 2793519"/>
+                <a:gd name="csX73" fmla="*/ 2253078 w 2840252"/>
+                <a:gd name="csY73" fmla="*/ 1172585 h 2793519"/>
+                <a:gd name="csX74" fmla="*/ 2307344 w 2840252"/>
+                <a:gd name="csY74" fmla="*/ 1226852 h 2793519"/>
+                <a:gd name="csX75" fmla="*/ 1923682 w 2840252"/>
+                <a:gd name="csY75" fmla="*/ 1254527 h 2793519"/>
+                <a:gd name="csX76" fmla="*/ 1891122 w 2840252"/>
+                <a:gd name="csY76" fmla="*/ 1265381 h 2793519"/>
+                <a:gd name="csX77" fmla="*/ 1847709 w 2840252"/>
+                <a:gd name="csY77" fmla="*/ 1243674 h 2793519"/>
+                <a:gd name="csX78" fmla="*/ 1800497 w 2840252"/>
+                <a:gd name="csY78" fmla="*/ 1180725 h 2793519"/>
+                <a:gd name="csX79" fmla="*/ 1811351 w 2840252"/>
+                <a:gd name="csY79" fmla="*/ 1104753 h 2793519"/>
+                <a:gd name="csX80" fmla="*/ 1887323 w 2840252"/>
+                <a:gd name="csY80" fmla="*/ 1115606 h 2793519"/>
+                <a:gd name="csX81" fmla="*/ 1934535 w 2840252"/>
+                <a:gd name="csY81" fmla="*/ 1178555 h 2793519"/>
+                <a:gd name="csX82" fmla="*/ 1923682 w 2840252"/>
+                <a:gd name="csY82" fmla="*/ 1254527 h 2793519"/>
+                <a:gd name="csX83" fmla="*/ 1559012 w 2840252"/>
+                <a:gd name="csY83" fmla="*/ 1944795 h 2793519"/>
+                <a:gd name="csX84" fmla="*/ 1648552 w 2840252"/>
+                <a:gd name="csY84" fmla="*/ 1934484 h 2793519"/>
+                <a:gd name="csX85" fmla="*/ 1708787 w 2840252"/>
+                <a:gd name="csY85" fmla="*/ 1982238 h 2793519"/>
+                <a:gd name="csX86" fmla="*/ 1661033 w 2840252"/>
+                <a:gd name="csY86" fmla="*/ 2042474 h 2793519"/>
+                <a:gd name="csX87" fmla="*/ 1571494 w 2840252"/>
+                <a:gd name="csY87" fmla="*/ 2052785 h 2793519"/>
+                <a:gd name="csX88" fmla="*/ 1565524 w 2840252"/>
+                <a:gd name="csY88" fmla="*/ 2053327 h 2793519"/>
+                <a:gd name="csX89" fmla="*/ 1511258 w 2840252"/>
+                <a:gd name="csY89" fmla="*/ 2005030 h 2793519"/>
+                <a:gd name="csX90" fmla="*/ 1559012 w 2840252"/>
+                <a:gd name="csY90" fmla="*/ 1944795 h 2793519"/>
+                <a:gd name="csX91" fmla="*/ 1555756 w 2840252"/>
+                <a:gd name="csY91" fmla="*/ 1458026 h 2793519"/>
+                <a:gd name="csX92" fmla="*/ 1555756 w 2840252"/>
+                <a:gd name="csY92" fmla="*/ 1396705 h 2793519"/>
+                <a:gd name="csX93" fmla="*/ 1610023 w 2840252"/>
+                <a:gd name="csY93" fmla="*/ 1342439 h 2793519"/>
+                <a:gd name="csX94" fmla="*/ 1664289 w 2840252"/>
+                <a:gd name="csY94" fmla="*/ 1396705 h 2793519"/>
+                <a:gd name="csX95" fmla="*/ 1664289 w 2840252"/>
+                <a:gd name="csY95" fmla="*/ 1458026 h 2793519"/>
+                <a:gd name="csX96" fmla="*/ 1610023 w 2840252"/>
+                <a:gd name="csY96" fmla="*/ 1512292 h 2793519"/>
+                <a:gd name="csX97" fmla="*/ 1555756 w 2840252"/>
+                <a:gd name="csY97" fmla="*/ 1458026 h 2793519"/>
+                <a:gd name="csX98" fmla="*/ 1916085 w 2840252"/>
+                <a:gd name="csY98" fmla="*/ 1753235 h 2793519"/>
+                <a:gd name="csX99" fmla="*/ 1905774 w 2840252"/>
+                <a:gd name="csY99" fmla="*/ 1677262 h 2793519"/>
+                <a:gd name="csX100" fmla="*/ 2005081 w 2840252"/>
+                <a:gd name="csY100" fmla="*/ 1545937 h 2793519"/>
+                <a:gd name="csX101" fmla="*/ 2081597 w 2840252"/>
+                <a:gd name="csY101" fmla="*/ 1535627 h 2793519"/>
+                <a:gd name="csX102" fmla="*/ 2091907 w 2840252"/>
+                <a:gd name="csY102" fmla="*/ 1611600 h 2793519"/>
+                <a:gd name="csX103" fmla="*/ 1992057 w 2840252"/>
+                <a:gd name="csY103" fmla="*/ 1742924 h 2793519"/>
+                <a:gd name="csX104" fmla="*/ 1948644 w 2840252"/>
+                <a:gd name="csY104" fmla="*/ 1764088 h 2793519"/>
+                <a:gd name="csX105" fmla="*/ 1916085 w 2840252"/>
+                <a:gd name="csY105" fmla="*/ 1753235 h 2793519"/>
+                <a:gd name="csX0" fmla="*/ 2559683 w 2840252"/>
+                <a:gd name="csY0" fmla="*/ 224011 h 2793519"/>
+                <a:gd name="csX1" fmla="*/ 2547201 w 2840252"/>
+                <a:gd name="csY1" fmla="*/ 213158 h 2793519"/>
+                <a:gd name="csX2" fmla="*/ 1886238 w 2840252"/>
+                <a:gd name="csY2" fmla="*/ 6403 h 2793519"/>
+                <a:gd name="csX3" fmla="*/ 1295821 w 2840252"/>
+                <a:gd name="csY3" fmla="*/ 366188 h 2793519"/>
+                <a:gd name="csX4" fmla="*/ 830759 w 2840252"/>
+                <a:gd name="csY4" fmla="*/ 914821 h 2793519"/>
+                <a:gd name="csX5" fmla="*/ 367867 w 2840252"/>
+                <a:gd name="csY5" fmla="*/ 1285459 h 2793519"/>
+                <a:gd name="csX6" fmla="*/ 3198 w 2840252"/>
+                <a:gd name="csY6" fmla="*/ 1897583 h 2793519"/>
+                <a:gd name="csX7" fmla="*/ 249024 w 2840252"/>
+                <a:gd name="csY7" fmla="*/ 2549321 h 2793519"/>
+                <a:gd name="csX8" fmla="*/ 249024 w 2840252"/>
+                <a:gd name="csY8" fmla="*/ 2549864 h 2793519"/>
+                <a:gd name="csX9" fmla="*/ 268560 w 2840252"/>
+                <a:gd name="csY9" fmla="*/ 2568314 h 2793519"/>
+                <a:gd name="csX10" fmla="*/ 828588 w 2840252"/>
+                <a:gd name="csY10" fmla="*/ 2793519 h 2793519"/>
+                <a:gd name="csX11" fmla="*/ 1199227 w 2840252"/>
+                <a:gd name="csY11" fmla="*/ 2702895 h 2793519"/>
+                <a:gd name="csX12" fmla="*/ 2031129 w 2840252"/>
+                <a:gd name="csY12" fmla="*/ 2120075 h 2793519"/>
+                <a:gd name="csX13" fmla="*/ 2715970 w 2840252"/>
+                <a:gd name="csY13" fmla="*/ 1289801 h 2793519"/>
+                <a:gd name="csX14" fmla="*/ 2559683 w 2840252"/>
+                <a:gd name="csY14" fmla="*/ 224011 h 2793519"/>
+                <a:gd name="csX15" fmla="*/ 641370 w 2840252"/>
+                <a:gd name="csY15" fmla="*/ 1742924 h 2793519"/>
+                <a:gd name="csX16" fmla="*/ 588731 w 2840252"/>
+                <a:gd name="csY16" fmla="*/ 1785252 h 2793519"/>
+                <a:gd name="csX17" fmla="*/ 576793 w 2840252"/>
+                <a:gd name="csY17" fmla="*/ 1784166 h 2793519"/>
+                <a:gd name="csX18" fmla="*/ 435158 w 2840252"/>
+                <a:gd name="csY18" fmla="*/ 1752692 h 2793519"/>
+                <a:gd name="csX19" fmla="*/ 393915 w 2840252"/>
+                <a:gd name="csY19" fmla="*/ 1687572 h 2793519"/>
+                <a:gd name="csX20" fmla="*/ 458492 w 2840252"/>
+                <a:gd name="csY20" fmla="*/ 1646330 h 2793519"/>
+                <a:gd name="csX21" fmla="*/ 600127 w 2840252"/>
+                <a:gd name="csY21" fmla="*/ 1677805 h 2793519"/>
+                <a:gd name="csX22" fmla="*/ 641370 w 2840252"/>
+                <a:gd name="csY22" fmla="*/ 1742924 h 2793519"/>
+                <a:gd name="csX23" fmla="*/ 881227 w 2840252"/>
+                <a:gd name="csY23" fmla="*/ 2280703 h 2793519"/>
+                <a:gd name="csX24" fmla="*/ 901848 w 2840252"/>
+                <a:gd name="csY24" fmla="*/ 2260082 h 2793519"/>
+                <a:gd name="csX25" fmla="*/ 978906 w 2840252"/>
+                <a:gd name="csY25" fmla="*/ 2260082 h 2793519"/>
+                <a:gd name="csX26" fmla="*/ 978906 w 2840252"/>
+                <a:gd name="csY26" fmla="*/ 2336597 h 2793519"/>
+                <a:gd name="csX27" fmla="*/ 957742 w 2840252"/>
+                <a:gd name="csY27" fmla="*/ 2357761 h 2793519"/>
+                <a:gd name="csX28" fmla="*/ 919213 w 2840252"/>
+                <a:gd name="csY28" fmla="*/ 2373498 h 2793519"/>
+                <a:gd name="csX29" fmla="*/ 881227 w 2840252"/>
+                <a:gd name="csY29" fmla="*/ 2357761 h 2793519"/>
+                <a:gd name="csX30" fmla="*/ 881227 w 2840252"/>
+                <a:gd name="csY30" fmla="*/ 2280703 h 2793519"/>
+                <a:gd name="csX31" fmla="*/ 1252408 w 2840252"/>
+                <a:gd name="csY31" fmla="*/ 1379340 h 2793519"/>
+                <a:gd name="csX32" fmla="*/ 1208452 w 2840252"/>
+                <a:gd name="csY32" fmla="*/ 1402132 h 2793519"/>
+                <a:gd name="csX33" fmla="*/ 1176978 w 2840252"/>
+                <a:gd name="csY33" fmla="*/ 1391821 h 2793519"/>
+                <a:gd name="csX34" fmla="*/ 1066275 w 2840252"/>
+                <a:gd name="csY34" fmla="*/ 1313135 h 2793519"/>
+                <a:gd name="csX35" fmla="*/ 1053793 w 2840252"/>
+                <a:gd name="csY35" fmla="*/ 1237162 h 2793519"/>
+                <a:gd name="csX36" fmla="*/ 1129766 w 2840252"/>
+                <a:gd name="csY36" fmla="*/ 1224681 h 2793519"/>
+                <a:gd name="csX37" fmla="*/ 1239927 w 2840252"/>
+                <a:gd name="csY37" fmla="*/ 1303367 h 2793519"/>
+                <a:gd name="csX38" fmla="*/ 1252408 w 2840252"/>
+                <a:gd name="csY38" fmla="*/ 1379340 h 2793519"/>
+                <a:gd name="csX39" fmla="*/ 771827 w 2840252"/>
+                <a:gd name="csY39" fmla="*/ 2096222 h 2793519"/>
+                <a:gd name="csX40" fmla="*/ 958738 w 2840252"/>
+                <a:gd name="csY40" fmla="*/ 1629685 h 2793519"/>
+                <a:gd name="csX41" fmla="*/ 1297530 w 2840252"/>
+                <a:gd name="csY41" fmla="*/ 1597279 h 2793519"/>
+                <a:gd name="csX42" fmla="*/ 1477639 w 2840252"/>
+                <a:gd name="csY42" fmla="*/ 1701233 h 2793519"/>
+                <a:gd name="csX43" fmla="*/ 1123833 w 2840252"/>
+                <a:gd name="csY43" fmla="*/ 2150212 h 2793519"/>
+                <a:gd name="csX44" fmla="*/ 771827 w 2840252"/>
+                <a:gd name="csY44" fmla="*/ 2096222 h 2793519"/>
+                <a:gd name="csX45" fmla="*/ 1448309 w 2840252"/>
+                <a:gd name="csY45" fmla="*/ 829622 h 2793519"/>
+                <a:gd name="csX46" fmla="*/ 1521569 w 2840252"/>
+                <a:gd name="csY46" fmla="*/ 805745 h 2793519"/>
+                <a:gd name="csX47" fmla="*/ 1657777 w 2840252"/>
+                <a:gd name="csY47" fmla="*/ 873578 h 2793519"/>
+                <a:gd name="csX48" fmla="*/ 1682197 w 2840252"/>
+                <a:gd name="csY48" fmla="*/ 946838 h 2793519"/>
+                <a:gd name="csX49" fmla="*/ 1633357 w 2840252"/>
+                <a:gd name="csY49" fmla="*/ 976684 h 2793519"/>
+                <a:gd name="csX50" fmla="*/ 1609480 w 2840252"/>
+                <a:gd name="csY50" fmla="*/ 970715 h 2793519"/>
+                <a:gd name="csX51" fmla="*/ 1472729 w 2840252"/>
+                <a:gd name="csY51" fmla="*/ 902339 h 2793519"/>
+                <a:gd name="csX52" fmla="*/ 1448309 w 2840252"/>
+                <a:gd name="csY52" fmla="*/ 829622 h 2793519"/>
+                <a:gd name="csX53" fmla="*/ 1971979 w 2840252"/>
+                <a:gd name="csY53" fmla="*/ 474178 h 2793519"/>
+                <a:gd name="csX54" fmla="*/ 1997484 w 2840252"/>
+                <a:gd name="csY54" fmla="*/ 546353 h 2793519"/>
+                <a:gd name="csX55" fmla="*/ 1945388 w 2840252"/>
+                <a:gd name="csY55" fmla="*/ 657056 h 2793519"/>
+                <a:gd name="csX56" fmla="*/ 1896006 w 2840252"/>
+                <a:gd name="csY56" fmla="*/ 687988 h 2793519"/>
+                <a:gd name="csX57" fmla="*/ 1872672 w 2840252"/>
+                <a:gd name="csY57" fmla="*/ 682561 h 2793519"/>
+                <a:gd name="csX58" fmla="*/ 1847166 w 2840252"/>
+                <a:gd name="csY58" fmla="*/ 610387 h 2793519"/>
+                <a:gd name="csX59" fmla="*/ 1899805 w 2840252"/>
+                <a:gd name="csY59" fmla="*/ 499684 h 2793519"/>
+                <a:gd name="csX60" fmla="*/ 1971979 w 2840252"/>
+                <a:gd name="csY60" fmla="*/ 474178 h 2793519"/>
+                <a:gd name="csX61" fmla="*/ 2277498 w 2840252"/>
+                <a:gd name="csY61" fmla="*/ 919704 h 2793519"/>
+                <a:gd name="csX62" fmla="*/ 2193385 w 2840252"/>
+                <a:gd name="csY62" fmla="*/ 801404 h 2793519"/>
+                <a:gd name="csX63" fmla="*/ 2205867 w 2840252"/>
+                <a:gd name="csY63" fmla="*/ 725974 h 2793519"/>
+                <a:gd name="csX64" fmla="*/ 2281839 w 2840252"/>
+                <a:gd name="csY64" fmla="*/ 738455 h 2793519"/>
+                <a:gd name="csX65" fmla="*/ 2365952 w 2840252"/>
+                <a:gd name="csY65" fmla="*/ 856756 h 2793519"/>
+                <a:gd name="csX66" fmla="*/ 2352928 w 2840252"/>
+                <a:gd name="csY66" fmla="*/ 932186 h 2793519"/>
+                <a:gd name="csX67" fmla="*/ 2321454 w 2840252"/>
+                <a:gd name="csY67" fmla="*/ 942496 h 2793519"/>
+                <a:gd name="csX68" fmla="*/ 2277498 w 2840252"/>
+                <a:gd name="csY68" fmla="*/ 919704 h 2793519"/>
+                <a:gd name="csX69" fmla="*/ 2307344 w 2840252"/>
+                <a:gd name="csY69" fmla="*/ 1226852 h 2793519"/>
+                <a:gd name="csX70" fmla="*/ 2253078 w 2840252"/>
+                <a:gd name="csY70" fmla="*/ 1281118 h 2793519"/>
+                <a:gd name="csX71" fmla="*/ 2196641 w 2840252"/>
+                <a:gd name="csY71" fmla="*/ 1226852 h 2793519"/>
+                <a:gd name="csX72" fmla="*/ 2248194 w 2840252"/>
+                <a:gd name="csY72" fmla="*/ 1172585 h 2793519"/>
+                <a:gd name="csX73" fmla="*/ 2253078 w 2840252"/>
+                <a:gd name="csY73" fmla="*/ 1172585 h 2793519"/>
+                <a:gd name="csX74" fmla="*/ 2307344 w 2840252"/>
+                <a:gd name="csY74" fmla="*/ 1226852 h 2793519"/>
+                <a:gd name="csX75" fmla="*/ 1923682 w 2840252"/>
+                <a:gd name="csY75" fmla="*/ 1254527 h 2793519"/>
+                <a:gd name="csX76" fmla="*/ 1891122 w 2840252"/>
+                <a:gd name="csY76" fmla="*/ 1265381 h 2793519"/>
+                <a:gd name="csX77" fmla="*/ 1847709 w 2840252"/>
+                <a:gd name="csY77" fmla="*/ 1243674 h 2793519"/>
+                <a:gd name="csX78" fmla="*/ 1800497 w 2840252"/>
+                <a:gd name="csY78" fmla="*/ 1180725 h 2793519"/>
+                <a:gd name="csX79" fmla="*/ 1811351 w 2840252"/>
+                <a:gd name="csY79" fmla="*/ 1104753 h 2793519"/>
+                <a:gd name="csX80" fmla="*/ 1887323 w 2840252"/>
+                <a:gd name="csY80" fmla="*/ 1115606 h 2793519"/>
+                <a:gd name="csX81" fmla="*/ 1934535 w 2840252"/>
+                <a:gd name="csY81" fmla="*/ 1178555 h 2793519"/>
+                <a:gd name="csX82" fmla="*/ 1923682 w 2840252"/>
+                <a:gd name="csY82" fmla="*/ 1254527 h 2793519"/>
+                <a:gd name="csX83" fmla="*/ 1559012 w 2840252"/>
+                <a:gd name="csY83" fmla="*/ 1944795 h 2793519"/>
+                <a:gd name="csX84" fmla="*/ 1648552 w 2840252"/>
+                <a:gd name="csY84" fmla="*/ 1934484 h 2793519"/>
+                <a:gd name="csX85" fmla="*/ 1708787 w 2840252"/>
+                <a:gd name="csY85" fmla="*/ 1982238 h 2793519"/>
+                <a:gd name="csX86" fmla="*/ 1661033 w 2840252"/>
+                <a:gd name="csY86" fmla="*/ 2042474 h 2793519"/>
+                <a:gd name="csX87" fmla="*/ 1571494 w 2840252"/>
+                <a:gd name="csY87" fmla="*/ 2052785 h 2793519"/>
+                <a:gd name="csX88" fmla="*/ 1565524 w 2840252"/>
+                <a:gd name="csY88" fmla="*/ 2053327 h 2793519"/>
+                <a:gd name="csX89" fmla="*/ 1511258 w 2840252"/>
+                <a:gd name="csY89" fmla="*/ 2005030 h 2793519"/>
+                <a:gd name="csX90" fmla="*/ 1559012 w 2840252"/>
+                <a:gd name="csY90" fmla="*/ 1944795 h 2793519"/>
+                <a:gd name="csX91" fmla="*/ 1555756 w 2840252"/>
+                <a:gd name="csY91" fmla="*/ 1458026 h 2793519"/>
+                <a:gd name="csX92" fmla="*/ 1555756 w 2840252"/>
+                <a:gd name="csY92" fmla="*/ 1396705 h 2793519"/>
+                <a:gd name="csX93" fmla="*/ 1610023 w 2840252"/>
+                <a:gd name="csY93" fmla="*/ 1342439 h 2793519"/>
+                <a:gd name="csX94" fmla="*/ 1664289 w 2840252"/>
+                <a:gd name="csY94" fmla="*/ 1396705 h 2793519"/>
+                <a:gd name="csX95" fmla="*/ 1664289 w 2840252"/>
+                <a:gd name="csY95" fmla="*/ 1458026 h 2793519"/>
+                <a:gd name="csX96" fmla="*/ 1610023 w 2840252"/>
+                <a:gd name="csY96" fmla="*/ 1512292 h 2793519"/>
+                <a:gd name="csX97" fmla="*/ 1555756 w 2840252"/>
+                <a:gd name="csY97" fmla="*/ 1458026 h 2793519"/>
+                <a:gd name="csX98" fmla="*/ 1916085 w 2840252"/>
+                <a:gd name="csY98" fmla="*/ 1753235 h 2793519"/>
+                <a:gd name="csX99" fmla="*/ 1905774 w 2840252"/>
+                <a:gd name="csY99" fmla="*/ 1677262 h 2793519"/>
+                <a:gd name="csX100" fmla="*/ 2005081 w 2840252"/>
+                <a:gd name="csY100" fmla="*/ 1545937 h 2793519"/>
+                <a:gd name="csX101" fmla="*/ 2081597 w 2840252"/>
+                <a:gd name="csY101" fmla="*/ 1535627 h 2793519"/>
+                <a:gd name="csX102" fmla="*/ 2091907 w 2840252"/>
+                <a:gd name="csY102" fmla="*/ 1611600 h 2793519"/>
+                <a:gd name="csX103" fmla="*/ 1992057 w 2840252"/>
+                <a:gd name="csY103" fmla="*/ 1742924 h 2793519"/>
+                <a:gd name="csX104" fmla="*/ 1948644 w 2840252"/>
+                <a:gd name="csY104" fmla="*/ 1764088 h 2793519"/>
+                <a:gd name="csX105" fmla="*/ 1916085 w 2840252"/>
+                <a:gd name="csY105" fmla="*/ 1753235 h 2793519"/>
+                <a:gd name="csX0" fmla="*/ 2559683 w 2840252"/>
+                <a:gd name="csY0" fmla="*/ 224011 h 2793519"/>
+                <a:gd name="csX1" fmla="*/ 2547201 w 2840252"/>
+                <a:gd name="csY1" fmla="*/ 213158 h 2793519"/>
+                <a:gd name="csX2" fmla="*/ 1886238 w 2840252"/>
+                <a:gd name="csY2" fmla="*/ 6403 h 2793519"/>
+                <a:gd name="csX3" fmla="*/ 1295821 w 2840252"/>
+                <a:gd name="csY3" fmla="*/ 366188 h 2793519"/>
+                <a:gd name="csX4" fmla="*/ 830759 w 2840252"/>
+                <a:gd name="csY4" fmla="*/ 914821 h 2793519"/>
+                <a:gd name="csX5" fmla="*/ 367867 w 2840252"/>
+                <a:gd name="csY5" fmla="*/ 1285459 h 2793519"/>
+                <a:gd name="csX6" fmla="*/ 3198 w 2840252"/>
+                <a:gd name="csY6" fmla="*/ 1897583 h 2793519"/>
+                <a:gd name="csX7" fmla="*/ 249024 w 2840252"/>
+                <a:gd name="csY7" fmla="*/ 2549321 h 2793519"/>
+                <a:gd name="csX8" fmla="*/ 249024 w 2840252"/>
+                <a:gd name="csY8" fmla="*/ 2549864 h 2793519"/>
+                <a:gd name="csX9" fmla="*/ 268560 w 2840252"/>
+                <a:gd name="csY9" fmla="*/ 2568314 h 2793519"/>
+                <a:gd name="csX10" fmla="*/ 828588 w 2840252"/>
+                <a:gd name="csY10" fmla="*/ 2793519 h 2793519"/>
+                <a:gd name="csX11" fmla="*/ 1199227 w 2840252"/>
+                <a:gd name="csY11" fmla="*/ 2702895 h 2793519"/>
+                <a:gd name="csX12" fmla="*/ 2031129 w 2840252"/>
+                <a:gd name="csY12" fmla="*/ 2120075 h 2793519"/>
+                <a:gd name="csX13" fmla="*/ 2715970 w 2840252"/>
+                <a:gd name="csY13" fmla="*/ 1289801 h 2793519"/>
+                <a:gd name="csX14" fmla="*/ 2559683 w 2840252"/>
+                <a:gd name="csY14" fmla="*/ 224011 h 2793519"/>
+                <a:gd name="csX15" fmla="*/ 641370 w 2840252"/>
+                <a:gd name="csY15" fmla="*/ 1742924 h 2793519"/>
+                <a:gd name="csX16" fmla="*/ 588731 w 2840252"/>
+                <a:gd name="csY16" fmla="*/ 1785252 h 2793519"/>
+                <a:gd name="csX17" fmla="*/ 576793 w 2840252"/>
+                <a:gd name="csY17" fmla="*/ 1784166 h 2793519"/>
+                <a:gd name="csX18" fmla="*/ 435158 w 2840252"/>
+                <a:gd name="csY18" fmla="*/ 1752692 h 2793519"/>
+                <a:gd name="csX19" fmla="*/ 393915 w 2840252"/>
+                <a:gd name="csY19" fmla="*/ 1687572 h 2793519"/>
+                <a:gd name="csX20" fmla="*/ 458492 w 2840252"/>
+                <a:gd name="csY20" fmla="*/ 1646330 h 2793519"/>
+                <a:gd name="csX21" fmla="*/ 600127 w 2840252"/>
+                <a:gd name="csY21" fmla="*/ 1677805 h 2793519"/>
+                <a:gd name="csX22" fmla="*/ 641370 w 2840252"/>
+                <a:gd name="csY22" fmla="*/ 1742924 h 2793519"/>
+                <a:gd name="csX23" fmla="*/ 881227 w 2840252"/>
+                <a:gd name="csY23" fmla="*/ 2280703 h 2793519"/>
+                <a:gd name="csX24" fmla="*/ 901848 w 2840252"/>
+                <a:gd name="csY24" fmla="*/ 2260082 h 2793519"/>
+                <a:gd name="csX25" fmla="*/ 978906 w 2840252"/>
+                <a:gd name="csY25" fmla="*/ 2260082 h 2793519"/>
+                <a:gd name="csX26" fmla="*/ 978906 w 2840252"/>
+                <a:gd name="csY26" fmla="*/ 2336597 h 2793519"/>
+                <a:gd name="csX27" fmla="*/ 957742 w 2840252"/>
+                <a:gd name="csY27" fmla="*/ 2357761 h 2793519"/>
+                <a:gd name="csX28" fmla="*/ 919213 w 2840252"/>
+                <a:gd name="csY28" fmla="*/ 2373498 h 2793519"/>
+                <a:gd name="csX29" fmla="*/ 881227 w 2840252"/>
+                <a:gd name="csY29" fmla="*/ 2357761 h 2793519"/>
+                <a:gd name="csX30" fmla="*/ 881227 w 2840252"/>
+                <a:gd name="csY30" fmla="*/ 2280703 h 2793519"/>
+                <a:gd name="csX31" fmla="*/ 1252408 w 2840252"/>
+                <a:gd name="csY31" fmla="*/ 1379340 h 2793519"/>
+                <a:gd name="csX32" fmla="*/ 1208452 w 2840252"/>
+                <a:gd name="csY32" fmla="*/ 1402132 h 2793519"/>
+                <a:gd name="csX33" fmla="*/ 1176978 w 2840252"/>
+                <a:gd name="csY33" fmla="*/ 1391821 h 2793519"/>
+                <a:gd name="csX34" fmla="*/ 1066275 w 2840252"/>
+                <a:gd name="csY34" fmla="*/ 1313135 h 2793519"/>
+                <a:gd name="csX35" fmla="*/ 1053793 w 2840252"/>
+                <a:gd name="csY35" fmla="*/ 1237162 h 2793519"/>
+                <a:gd name="csX36" fmla="*/ 1129766 w 2840252"/>
+                <a:gd name="csY36" fmla="*/ 1224681 h 2793519"/>
+                <a:gd name="csX37" fmla="*/ 1239927 w 2840252"/>
+                <a:gd name="csY37" fmla="*/ 1303367 h 2793519"/>
+                <a:gd name="csX38" fmla="*/ 1252408 w 2840252"/>
+                <a:gd name="csY38" fmla="*/ 1379340 h 2793519"/>
+                <a:gd name="csX39" fmla="*/ 771827 w 2840252"/>
+                <a:gd name="csY39" fmla="*/ 2096222 h 2793519"/>
+                <a:gd name="csX40" fmla="*/ 958738 w 2840252"/>
+                <a:gd name="csY40" fmla="*/ 1629685 h 2793519"/>
+                <a:gd name="csX41" fmla="*/ 1297530 w 2840252"/>
+                <a:gd name="csY41" fmla="*/ 1597279 h 2793519"/>
+                <a:gd name="csX42" fmla="*/ 1477639 w 2840252"/>
+                <a:gd name="csY42" fmla="*/ 1701233 h 2793519"/>
+                <a:gd name="csX43" fmla="*/ 1123833 w 2840252"/>
+                <a:gd name="csY43" fmla="*/ 2150212 h 2793519"/>
+                <a:gd name="csX44" fmla="*/ 771827 w 2840252"/>
+                <a:gd name="csY44" fmla="*/ 2096222 h 2793519"/>
+                <a:gd name="csX45" fmla="*/ 1448309 w 2840252"/>
+                <a:gd name="csY45" fmla="*/ 829622 h 2793519"/>
+                <a:gd name="csX46" fmla="*/ 1521569 w 2840252"/>
+                <a:gd name="csY46" fmla="*/ 805745 h 2793519"/>
+                <a:gd name="csX47" fmla="*/ 1657777 w 2840252"/>
+                <a:gd name="csY47" fmla="*/ 873578 h 2793519"/>
+                <a:gd name="csX48" fmla="*/ 1682197 w 2840252"/>
+                <a:gd name="csY48" fmla="*/ 946838 h 2793519"/>
+                <a:gd name="csX49" fmla="*/ 1633357 w 2840252"/>
+                <a:gd name="csY49" fmla="*/ 976684 h 2793519"/>
+                <a:gd name="csX50" fmla="*/ 1609480 w 2840252"/>
+                <a:gd name="csY50" fmla="*/ 970715 h 2793519"/>
+                <a:gd name="csX51" fmla="*/ 1472729 w 2840252"/>
+                <a:gd name="csY51" fmla="*/ 902339 h 2793519"/>
+                <a:gd name="csX52" fmla="*/ 1448309 w 2840252"/>
+                <a:gd name="csY52" fmla="*/ 829622 h 2793519"/>
+                <a:gd name="csX53" fmla="*/ 1971979 w 2840252"/>
+                <a:gd name="csY53" fmla="*/ 474178 h 2793519"/>
+                <a:gd name="csX54" fmla="*/ 1997484 w 2840252"/>
+                <a:gd name="csY54" fmla="*/ 546353 h 2793519"/>
+                <a:gd name="csX55" fmla="*/ 1945388 w 2840252"/>
+                <a:gd name="csY55" fmla="*/ 657056 h 2793519"/>
+                <a:gd name="csX56" fmla="*/ 1896006 w 2840252"/>
+                <a:gd name="csY56" fmla="*/ 687988 h 2793519"/>
+                <a:gd name="csX57" fmla="*/ 1872672 w 2840252"/>
+                <a:gd name="csY57" fmla="*/ 682561 h 2793519"/>
+                <a:gd name="csX58" fmla="*/ 1847166 w 2840252"/>
+                <a:gd name="csY58" fmla="*/ 610387 h 2793519"/>
+                <a:gd name="csX59" fmla="*/ 1899805 w 2840252"/>
+                <a:gd name="csY59" fmla="*/ 499684 h 2793519"/>
+                <a:gd name="csX60" fmla="*/ 1971979 w 2840252"/>
+                <a:gd name="csY60" fmla="*/ 474178 h 2793519"/>
+                <a:gd name="csX61" fmla="*/ 2277498 w 2840252"/>
+                <a:gd name="csY61" fmla="*/ 919704 h 2793519"/>
+                <a:gd name="csX62" fmla="*/ 2193385 w 2840252"/>
+                <a:gd name="csY62" fmla="*/ 801404 h 2793519"/>
+                <a:gd name="csX63" fmla="*/ 2205867 w 2840252"/>
+                <a:gd name="csY63" fmla="*/ 725974 h 2793519"/>
+                <a:gd name="csX64" fmla="*/ 2281839 w 2840252"/>
+                <a:gd name="csY64" fmla="*/ 738455 h 2793519"/>
+                <a:gd name="csX65" fmla="*/ 2365952 w 2840252"/>
+                <a:gd name="csY65" fmla="*/ 856756 h 2793519"/>
+                <a:gd name="csX66" fmla="*/ 2352928 w 2840252"/>
+                <a:gd name="csY66" fmla="*/ 932186 h 2793519"/>
+                <a:gd name="csX67" fmla="*/ 2321454 w 2840252"/>
+                <a:gd name="csY67" fmla="*/ 942496 h 2793519"/>
+                <a:gd name="csX68" fmla="*/ 2277498 w 2840252"/>
+                <a:gd name="csY68" fmla="*/ 919704 h 2793519"/>
+                <a:gd name="csX69" fmla="*/ 2307344 w 2840252"/>
+                <a:gd name="csY69" fmla="*/ 1226852 h 2793519"/>
+                <a:gd name="csX70" fmla="*/ 2253078 w 2840252"/>
+                <a:gd name="csY70" fmla="*/ 1281118 h 2793519"/>
+                <a:gd name="csX71" fmla="*/ 2196641 w 2840252"/>
+                <a:gd name="csY71" fmla="*/ 1226852 h 2793519"/>
+                <a:gd name="csX72" fmla="*/ 2248194 w 2840252"/>
+                <a:gd name="csY72" fmla="*/ 1172585 h 2793519"/>
+                <a:gd name="csX73" fmla="*/ 2253078 w 2840252"/>
+                <a:gd name="csY73" fmla="*/ 1172585 h 2793519"/>
+                <a:gd name="csX74" fmla="*/ 2307344 w 2840252"/>
+                <a:gd name="csY74" fmla="*/ 1226852 h 2793519"/>
+                <a:gd name="csX75" fmla="*/ 1923682 w 2840252"/>
+                <a:gd name="csY75" fmla="*/ 1254527 h 2793519"/>
+                <a:gd name="csX76" fmla="*/ 1891122 w 2840252"/>
+                <a:gd name="csY76" fmla="*/ 1265381 h 2793519"/>
+                <a:gd name="csX77" fmla="*/ 1847709 w 2840252"/>
+                <a:gd name="csY77" fmla="*/ 1243674 h 2793519"/>
+                <a:gd name="csX78" fmla="*/ 1800497 w 2840252"/>
+                <a:gd name="csY78" fmla="*/ 1180725 h 2793519"/>
+                <a:gd name="csX79" fmla="*/ 1811351 w 2840252"/>
+                <a:gd name="csY79" fmla="*/ 1104753 h 2793519"/>
+                <a:gd name="csX80" fmla="*/ 1887323 w 2840252"/>
+                <a:gd name="csY80" fmla="*/ 1115606 h 2793519"/>
+                <a:gd name="csX81" fmla="*/ 1934535 w 2840252"/>
+                <a:gd name="csY81" fmla="*/ 1178555 h 2793519"/>
+                <a:gd name="csX82" fmla="*/ 1923682 w 2840252"/>
+                <a:gd name="csY82" fmla="*/ 1254527 h 2793519"/>
+                <a:gd name="csX83" fmla="*/ 1559012 w 2840252"/>
+                <a:gd name="csY83" fmla="*/ 1944795 h 2793519"/>
+                <a:gd name="csX84" fmla="*/ 1648552 w 2840252"/>
+                <a:gd name="csY84" fmla="*/ 1934484 h 2793519"/>
+                <a:gd name="csX85" fmla="*/ 1708787 w 2840252"/>
+                <a:gd name="csY85" fmla="*/ 1982238 h 2793519"/>
+                <a:gd name="csX86" fmla="*/ 1661033 w 2840252"/>
+                <a:gd name="csY86" fmla="*/ 2042474 h 2793519"/>
+                <a:gd name="csX87" fmla="*/ 1571494 w 2840252"/>
+                <a:gd name="csY87" fmla="*/ 2052785 h 2793519"/>
+                <a:gd name="csX88" fmla="*/ 1565524 w 2840252"/>
+                <a:gd name="csY88" fmla="*/ 2053327 h 2793519"/>
+                <a:gd name="csX89" fmla="*/ 1511258 w 2840252"/>
+                <a:gd name="csY89" fmla="*/ 2005030 h 2793519"/>
+                <a:gd name="csX90" fmla="*/ 1559012 w 2840252"/>
+                <a:gd name="csY90" fmla="*/ 1944795 h 2793519"/>
+                <a:gd name="csX91" fmla="*/ 1555756 w 2840252"/>
+                <a:gd name="csY91" fmla="*/ 1458026 h 2793519"/>
+                <a:gd name="csX92" fmla="*/ 1555756 w 2840252"/>
+                <a:gd name="csY92" fmla="*/ 1396705 h 2793519"/>
+                <a:gd name="csX93" fmla="*/ 1610023 w 2840252"/>
+                <a:gd name="csY93" fmla="*/ 1342439 h 2793519"/>
+                <a:gd name="csX94" fmla="*/ 1664289 w 2840252"/>
+                <a:gd name="csY94" fmla="*/ 1396705 h 2793519"/>
+                <a:gd name="csX95" fmla="*/ 1664289 w 2840252"/>
+                <a:gd name="csY95" fmla="*/ 1458026 h 2793519"/>
+                <a:gd name="csX96" fmla="*/ 1610023 w 2840252"/>
+                <a:gd name="csY96" fmla="*/ 1512292 h 2793519"/>
+                <a:gd name="csX97" fmla="*/ 1555756 w 2840252"/>
+                <a:gd name="csY97" fmla="*/ 1458026 h 2793519"/>
+                <a:gd name="csX98" fmla="*/ 1916085 w 2840252"/>
+                <a:gd name="csY98" fmla="*/ 1753235 h 2793519"/>
+                <a:gd name="csX99" fmla="*/ 1905774 w 2840252"/>
+                <a:gd name="csY99" fmla="*/ 1677262 h 2793519"/>
+                <a:gd name="csX100" fmla="*/ 2005081 w 2840252"/>
+                <a:gd name="csY100" fmla="*/ 1545937 h 2793519"/>
+                <a:gd name="csX101" fmla="*/ 2081597 w 2840252"/>
+                <a:gd name="csY101" fmla="*/ 1535627 h 2793519"/>
+                <a:gd name="csX102" fmla="*/ 2091907 w 2840252"/>
+                <a:gd name="csY102" fmla="*/ 1611600 h 2793519"/>
+                <a:gd name="csX103" fmla="*/ 1992057 w 2840252"/>
+                <a:gd name="csY103" fmla="*/ 1742924 h 2793519"/>
+                <a:gd name="csX104" fmla="*/ 1948644 w 2840252"/>
+                <a:gd name="csY104" fmla="*/ 1764088 h 2793519"/>
+                <a:gd name="csX105" fmla="*/ 1916085 w 2840252"/>
+                <a:gd name="csY105" fmla="*/ 1753235 h 2793519"/>
+                <a:gd name="csX0" fmla="*/ 2559683 w 2840252"/>
+                <a:gd name="csY0" fmla="*/ 224011 h 2793519"/>
+                <a:gd name="csX1" fmla="*/ 2547201 w 2840252"/>
+                <a:gd name="csY1" fmla="*/ 213158 h 2793519"/>
+                <a:gd name="csX2" fmla="*/ 1886238 w 2840252"/>
+                <a:gd name="csY2" fmla="*/ 6403 h 2793519"/>
+                <a:gd name="csX3" fmla="*/ 1295821 w 2840252"/>
+                <a:gd name="csY3" fmla="*/ 366188 h 2793519"/>
+                <a:gd name="csX4" fmla="*/ 830759 w 2840252"/>
+                <a:gd name="csY4" fmla="*/ 914821 h 2793519"/>
+                <a:gd name="csX5" fmla="*/ 367867 w 2840252"/>
+                <a:gd name="csY5" fmla="*/ 1285459 h 2793519"/>
+                <a:gd name="csX6" fmla="*/ 3198 w 2840252"/>
+                <a:gd name="csY6" fmla="*/ 1897583 h 2793519"/>
+                <a:gd name="csX7" fmla="*/ 249024 w 2840252"/>
+                <a:gd name="csY7" fmla="*/ 2549321 h 2793519"/>
+                <a:gd name="csX8" fmla="*/ 249024 w 2840252"/>
+                <a:gd name="csY8" fmla="*/ 2549864 h 2793519"/>
+                <a:gd name="csX9" fmla="*/ 268560 w 2840252"/>
+                <a:gd name="csY9" fmla="*/ 2568314 h 2793519"/>
+                <a:gd name="csX10" fmla="*/ 828588 w 2840252"/>
+                <a:gd name="csY10" fmla="*/ 2793519 h 2793519"/>
+                <a:gd name="csX11" fmla="*/ 1199227 w 2840252"/>
+                <a:gd name="csY11" fmla="*/ 2702895 h 2793519"/>
+                <a:gd name="csX12" fmla="*/ 2031129 w 2840252"/>
+                <a:gd name="csY12" fmla="*/ 2120075 h 2793519"/>
+                <a:gd name="csX13" fmla="*/ 2715970 w 2840252"/>
+                <a:gd name="csY13" fmla="*/ 1289801 h 2793519"/>
+                <a:gd name="csX14" fmla="*/ 2559683 w 2840252"/>
+                <a:gd name="csY14" fmla="*/ 224011 h 2793519"/>
+                <a:gd name="csX15" fmla="*/ 641370 w 2840252"/>
+                <a:gd name="csY15" fmla="*/ 1742924 h 2793519"/>
+                <a:gd name="csX16" fmla="*/ 588731 w 2840252"/>
+                <a:gd name="csY16" fmla="*/ 1785252 h 2793519"/>
+                <a:gd name="csX17" fmla="*/ 576793 w 2840252"/>
+                <a:gd name="csY17" fmla="*/ 1784166 h 2793519"/>
+                <a:gd name="csX18" fmla="*/ 435158 w 2840252"/>
+                <a:gd name="csY18" fmla="*/ 1752692 h 2793519"/>
+                <a:gd name="csX19" fmla="*/ 393915 w 2840252"/>
+                <a:gd name="csY19" fmla="*/ 1687572 h 2793519"/>
+                <a:gd name="csX20" fmla="*/ 458492 w 2840252"/>
+                <a:gd name="csY20" fmla="*/ 1646330 h 2793519"/>
+                <a:gd name="csX21" fmla="*/ 600127 w 2840252"/>
+                <a:gd name="csY21" fmla="*/ 1677805 h 2793519"/>
+                <a:gd name="csX22" fmla="*/ 641370 w 2840252"/>
+                <a:gd name="csY22" fmla="*/ 1742924 h 2793519"/>
+                <a:gd name="csX23" fmla="*/ 881227 w 2840252"/>
+                <a:gd name="csY23" fmla="*/ 2280703 h 2793519"/>
+                <a:gd name="csX24" fmla="*/ 901848 w 2840252"/>
+                <a:gd name="csY24" fmla="*/ 2260082 h 2793519"/>
+                <a:gd name="csX25" fmla="*/ 978906 w 2840252"/>
+                <a:gd name="csY25" fmla="*/ 2260082 h 2793519"/>
+                <a:gd name="csX26" fmla="*/ 978906 w 2840252"/>
+                <a:gd name="csY26" fmla="*/ 2336597 h 2793519"/>
+                <a:gd name="csX27" fmla="*/ 957742 w 2840252"/>
+                <a:gd name="csY27" fmla="*/ 2357761 h 2793519"/>
+                <a:gd name="csX28" fmla="*/ 919213 w 2840252"/>
+                <a:gd name="csY28" fmla="*/ 2373498 h 2793519"/>
+                <a:gd name="csX29" fmla="*/ 881227 w 2840252"/>
+                <a:gd name="csY29" fmla="*/ 2357761 h 2793519"/>
+                <a:gd name="csX30" fmla="*/ 881227 w 2840252"/>
+                <a:gd name="csY30" fmla="*/ 2280703 h 2793519"/>
+                <a:gd name="csX31" fmla="*/ 1252408 w 2840252"/>
+                <a:gd name="csY31" fmla="*/ 1379340 h 2793519"/>
+                <a:gd name="csX32" fmla="*/ 1208452 w 2840252"/>
+                <a:gd name="csY32" fmla="*/ 1402132 h 2793519"/>
+                <a:gd name="csX33" fmla="*/ 1176978 w 2840252"/>
+                <a:gd name="csY33" fmla="*/ 1391821 h 2793519"/>
+                <a:gd name="csX34" fmla="*/ 1066275 w 2840252"/>
+                <a:gd name="csY34" fmla="*/ 1313135 h 2793519"/>
+                <a:gd name="csX35" fmla="*/ 1053793 w 2840252"/>
+                <a:gd name="csY35" fmla="*/ 1237162 h 2793519"/>
+                <a:gd name="csX36" fmla="*/ 1129766 w 2840252"/>
+                <a:gd name="csY36" fmla="*/ 1224681 h 2793519"/>
+                <a:gd name="csX37" fmla="*/ 1239927 w 2840252"/>
+                <a:gd name="csY37" fmla="*/ 1303367 h 2793519"/>
+                <a:gd name="csX38" fmla="*/ 1252408 w 2840252"/>
+                <a:gd name="csY38" fmla="*/ 1379340 h 2793519"/>
+                <a:gd name="csX39" fmla="*/ 771827 w 2840252"/>
+                <a:gd name="csY39" fmla="*/ 2096222 h 2793519"/>
+                <a:gd name="csX40" fmla="*/ 958738 w 2840252"/>
+                <a:gd name="csY40" fmla="*/ 1629685 h 2793519"/>
+                <a:gd name="csX41" fmla="*/ 1297530 w 2840252"/>
+                <a:gd name="csY41" fmla="*/ 1597279 h 2793519"/>
+                <a:gd name="csX42" fmla="*/ 1485434 w 2840252"/>
+                <a:gd name="csY42" fmla="*/ 1746019 h 2793519"/>
+                <a:gd name="csX43" fmla="*/ 1123833 w 2840252"/>
+                <a:gd name="csY43" fmla="*/ 2150212 h 2793519"/>
+                <a:gd name="csX44" fmla="*/ 771827 w 2840252"/>
+                <a:gd name="csY44" fmla="*/ 2096222 h 2793519"/>
+                <a:gd name="csX45" fmla="*/ 1448309 w 2840252"/>
+                <a:gd name="csY45" fmla="*/ 829622 h 2793519"/>
+                <a:gd name="csX46" fmla="*/ 1521569 w 2840252"/>
+                <a:gd name="csY46" fmla="*/ 805745 h 2793519"/>
+                <a:gd name="csX47" fmla="*/ 1657777 w 2840252"/>
+                <a:gd name="csY47" fmla="*/ 873578 h 2793519"/>
+                <a:gd name="csX48" fmla="*/ 1682197 w 2840252"/>
+                <a:gd name="csY48" fmla="*/ 946838 h 2793519"/>
+                <a:gd name="csX49" fmla="*/ 1633357 w 2840252"/>
+                <a:gd name="csY49" fmla="*/ 976684 h 2793519"/>
+                <a:gd name="csX50" fmla="*/ 1609480 w 2840252"/>
+                <a:gd name="csY50" fmla="*/ 970715 h 2793519"/>
+                <a:gd name="csX51" fmla="*/ 1472729 w 2840252"/>
+                <a:gd name="csY51" fmla="*/ 902339 h 2793519"/>
+                <a:gd name="csX52" fmla="*/ 1448309 w 2840252"/>
+                <a:gd name="csY52" fmla="*/ 829622 h 2793519"/>
+                <a:gd name="csX53" fmla="*/ 1971979 w 2840252"/>
+                <a:gd name="csY53" fmla="*/ 474178 h 2793519"/>
+                <a:gd name="csX54" fmla="*/ 1997484 w 2840252"/>
+                <a:gd name="csY54" fmla="*/ 546353 h 2793519"/>
+                <a:gd name="csX55" fmla="*/ 1945388 w 2840252"/>
+                <a:gd name="csY55" fmla="*/ 657056 h 2793519"/>
+                <a:gd name="csX56" fmla="*/ 1896006 w 2840252"/>
+                <a:gd name="csY56" fmla="*/ 687988 h 2793519"/>
+                <a:gd name="csX57" fmla="*/ 1872672 w 2840252"/>
+                <a:gd name="csY57" fmla="*/ 682561 h 2793519"/>
+                <a:gd name="csX58" fmla="*/ 1847166 w 2840252"/>
+                <a:gd name="csY58" fmla="*/ 610387 h 2793519"/>
+                <a:gd name="csX59" fmla="*/ 1899805 w 2840252"/>
+                <a:gd name="csY59" fmla="*/ 499684 h 2793519"/>
+                <a:gd name="csX60" fmla="*/ 1971979 w 2840252"/>
+                <a:gd name="csY60" fmla="*/ 474178 h 2793519"/>
+                <a:gd name="csX61" fmla="*/ 2277498 w 2840252"/>
+                <a:gd name="csY61" fmla="*/ 919704 h 2793519"/>
+                <a:gd name="csX62" fmla="*/ 2193385 w 2840252"/>
+                <a:gd name="csY62" fmla="*/ 801404 h 2793519"/>
+                <a:gd name="csX63" fmla="*/ 2205867 w 2840252"/>
+                <a:gd name="csY63" fmla="*/ 725974 h 2793519"/>
+                <a:gd name="csX64" fmla="*/ 2281839 w 2840252"/>
+                <a:gd name="csY64" fmla="*/ 738455 h 2793519"/>
+                <a:gd name="csX65" fmla="*/ 2365952 w 2840252"/>
+                <a:gd name="csY65" fmla="*/ 856756 h 2793519"/>
+                <a:gd name="csX66" fmla="*/ 2352928 w 2840252"/>
+                <a:gd name="csY66" fmla="*/ 932186 h 2793519"/>
+                <a:gd name="csX67" fmla="*/ 2321454 w 2840252"/>
+                <a:gd name="csY67" fmla="*/ 942496 h 2793519"/>
+                <a:gd name="csX68" fmla="*/ 2277498 w 2840252"/>
+                <a:gd name="csY68" fmla="*/ 919704 h 2793519"/>
+                <a:gd name="csX69" fmla="*/ 2307344 w 2840252"/>
+                <a:gd name="csY69" fmla="*/ 1226852 h 2793519"/>
+                <a:gd name="csX70" fmla="*/ 2253078 w 2840252"/>
+                <a:gd name="csY70" fmla="*/ 1281118 h 2793519"/>
+                <a:gd name="csX71" fmla="*/ 2196641 w 2840252"/>
+                <a:gd name="csY71" fmla="*/ 1226852 h 2793519"/>
+                <a:gd name="csX72" fmla="*/ 2248194 w 2840252"/>
+                <a:gd name="csY72" fmla="*/ 1172585 h 2793519"/>
+                <a:gd name="csX73" fmla="*/ 2253078 w 2840252"/>
+                <a:gd name="csY73" fmla="*/ 1172585 h 2793519"/>
+                <a:gd name="csX74" fmla="*/ 2307344 w 2840252"/>
+                <a:gd name="csY74" fmla="*/ 1226852 h 2793519"/>
+                <a:gd name="csX75" fmla="*/ 1923682 w 2840252"/>
+                <a:gd name="csY75" fmla="*/ 1254527 h 2793519"/>
+                <a:gd name="csX76" fmla="*/ 1891122 w 2840252"/>
+                <a:gd name="csY76" fmla="*/ 1265381 h 2793519"/>
+                <a:gd name="csX77" fmla="*/ 1847709 w 2840252"/>
+                <a:gd name="csY77" fmla="*/ 1243674 h 2793519"/>
+                <a:gd name="csX78" fmla="*/ 1800497 w 2840252"/>
+                <a:gd name="csY78" fmla="*/ 1180725 h 2793519"/>
+                <a:gd name="csX79" fmla="*/ 1811351 w 2840252"/>
+                <a:gd name="csY79" fmla="*/ 1104753 h 2793519"/>
+                <a:gd name="csX80" fmla="*/ 1887323 w 2840252"/>
+                <a:gd name="csY80" fmla="*/ 1115606 h 2793519"/>
+                <a:gd name="csX81" fmla="*/ 1934535 w 2840252"/>
+                <a:gd name="csY81" fmla="*/ 1178555 h 2793519"/>
+                <a:gd name="csX82" fmla="*/ 1923682 w 2840252"/>
+                <a:gd name="csY82" fmla="*/ 1254527 h 2793519"/>
+                <a:gd name="csX83" fmla="*/ 1559012 w 2840252"/>
+                <a:gd name="csY83" fmla="*/ 1944795 h 2793519"/>
+                <a:gd name="csX84" fmla="*/ 1648552 w 2840252"/>
+                <a:gd name="csY84" fmla="*/ 1934484 h 2793519"/>
+                <a:gd name="csX85" fmla="*/ 1708787 w 2840252"/>
+                <a:gd name="csY85" fmla="*/ 1982238 h 2793519"/>
+                <a:gd name="csX86" fmla="*/ 1661033 w 2840252"/>
+                <a:gd name="csY86" fmla="*/ 2042474 h 2793519"/>
+                <a:gd name="csX87" fmla="*/ 1571494 w 2840252"/>
+                <a:gd name="csY87" fmla="*/ 2052785 h 2793519"/>
+                <a:gd name="csX88" fmla="*/ 1565524 w 2840252"/>
+                <a:gd name="csY88" fmla="*/ 2053327 h 2793519"/>
+                <a:gd name="csX89" fmla="*/ 1511258 w 2840252"/>
+                <a:gd name="csY89" fmla="*/ 2005030 h 2793519"/>
+                <a:gd name="csX90" fmla="*/ 1559012 w 2840252"/>
+                <a:gd name="csY90" fmla="*/ 1944795 h 2793519"/>
+                <a:gd name="csX91" fmla="*/ 1555756 w 2840252"/>
+                <a:gd name="csY91" fmla="*/ 1458026 h 2793519"/>
+                <a:gd name="csX92" fmla="*/ 1555756 w 2840252"/>
+                <a:gd name="csY92" fmla="*/ 1396705 h 2793519"/>
+                <a:gd name="csX93" fmla="*/ 1610023 w 2840252"/>
+                <a:gd name="csY93" fmla="*/ 1342439 h 2793519"/>
+                <a:gd name="csX94" fmla="*/ 1664289 w 2840252"/>
+                <a:gd name="csY94" fmla="*/ 1396705 h 2793519"/>
+                <a:gd name="csX95" fmla="*/ 1664289 w 2840252"/>
+                <a:gd name="csY95" fmla="*/ 1458026 h 2793519"/>
+                <a:gd name="csX96" fmla="*/ 1610023 w 2840252"/>
+                <a:gd name="csY96" fmla="*/ 1512292 h 2793519"/>
+                <a:gd name="csX97" fmla="*/ 1555756 w 2840252"/>
+                <a:gd name="csY97" fmla="*/ 1458026 h 2793519"/>
+                <a:gd name="csX98" fmla="*/ 1916085 w 2840252"/>
+                <a:gd name="csY98" fmla="*/ 1753235 h 2793519"/>
+                <a:gd name="csX99" fmla="*/ 1905774 w 2840252"/>
+                <a:gd name="csY99" fmla="*/ 1677262 h 2793519"/>
+                <a:gd name="csX100" fmla="*/ 2005081 w 2840252"/>
+                <a:gd name="csY100" fmla="*/ 1545937 h 2793519"/>
+                <a:gd name="csX101" fmla="*/ 2081597 w 2840252"/>
+                <a:gd name="csY101" fmla="*/ 1535627 h 2793519"/>
+                <a:gd name="csX102" fmla="*/ 2091907 w 2840252"/>
+                <a:gd name="csY102" fmla="*/ 1611600 h 2793519"/>
+                <a:gd name="csX103" fmla="*/ 1992057 w 2840252"/>
+                <a:gd name="csY103" fmla="*/ 1742924 h 2793519"/>
+                <a:gd name="csX104" fmla="*/ 1948644 w 2840252"/>
+                <a:gd name="csY104" fmla="*/ 1764088 h 2793519"/>
+                <a:gd name="csX105" fmla="*/ 1916085 w 2840252"/>
+                <a:gd name="csY105" fmla="*/ 1753235 h 2793519"/>
+                <a:gd name="csX0" fmla="*/ 2559683 w 2840252"/>
+                <a:gd name="csY0" fmla="*/ 224011 h 2793519"/>
+                <a:gd name="csX1" fmla="*/ 2547201 w 2840252"/>
+                <a:gd name="csY1" fmla="*/ 213158 h 2793519"/>
+                <a:gd name="csX2" fmla="*/ 1886238 w 2840252"/>
+                <a:gd name="csY2" fmla="*/ 6403 h 2793519"/>
+                <a:gd name="csX3" fmla="*/ 1295821 w 2840252"/>
+                <a:gd name="csY3" fmla="*/ 366188 h 2793519"/>
+                <a:gd name="csX4" fmla="*/ 830759 w 2840252"/>
+                <a:gd name="csY4" fmla="*/ 914821 h 2793519"/>
+                <a:gd name="csX5" fmla="*/ 367867 w 2840252"/>
+                <a:gd name="csY5" fmla="*/ 1285459 h 2793519"/>
+                <a:gd name="csX6" fmla="*/ 3198 w 2840252"/>
+                <a:gd name="csY6" fmla="*/ 1897583 h 2793519"/>
+                <a:gd name="csX7" fmla="*/ 249024 w 2840252"/>
+                <a:gd name="csY7" fmla="*/ 2549321 h 2793519"/>
+                <a:gd name="csX8" fmla="*/ 249024 w 2840252"/>
+                <a:gd name="csY8" fmla="*/ 2549864 h 2793519"/>
+                <a:gd name="csX9" fmla="*/ 268560 w 2840252"/>
+                <a:gd name="csY9" fmla="*/ 2568314 h 2793519"/>
+                <a:gd name="csX10" fmla="*/ 828588 w 2840252"/>
+                <a:gd name="csY10" fmla="*/ 2793519 h 2793519"/>
+                <a:gd name="csX11" fmla="*/ 1199227 w 2840252"/>
+                <a:gd name="csY11" fmla="*/ 2702895 h 2793519"/>
+                <a:gd name="csX12" fmla="*/ 2031129 w 2840252"/>
+                <a:gd name="csY12" fmla="*/ 2120075 h 2793519"/>
+                <a:gd name="csX13" fmla="*/ 2715970 w 2840252"/>
+                <a:gd name="csY13" fmla="*/ 1289801 h 2793519"/>
+                <a:gd name="csX14" fmla="*/ 2559683 w 2840252"/>
+                <a:gd name="csY14" fmla="*/ 224011 h 2793519"/>
+                <a:gd name="csX15" fmla="*/ 641370 w 2840252"/>
+                <a:gd name="csY15" fmla="*/ 1742924 h 2793519"/>
+                <a:gd name="csX16" fmla="*/ 588731 w 2840252"/>
+                <a:gd name="csY16" fmla="*/ 1785252 h 2793519"/>
+                <a:gd name="csX17" fmla="*/ 576793 w 2840252"/>
+                <a:gd name="csY17" fmla="*/ 1784166 h 2793519"/>
+                <a:gd name="csX18" fmla="*/ 435158 w 2840252"/>
+                <a:gd name="csY18" fmla="*/ 1752692 h 2793519"/>
+                <a:gd name="csX19" fmla="*/ 393915 w 2840252"/>
+                <a:gd name="csY19" fmla="*/ 1687572 h 2793519"/>
+                <a:gd name="csX20" fmla="*/ 458492 w 2840252"/>
+                <a:gd name="csY20" fmla="*/ 1646330 h 2793519"/>
+                <a:gd name="csX21" fmla="*/ 600127 w 2840252"/>
+                <a:gd name="csY21" fmla="*/ 1677805 h 2793519"/>
+                <a:gd name="csX22" fmla="*/ 641370 w 2840252"/>
+                <a:gd name="csY22" fmla="*/ 1742924 h 2793519"/>
+                <a:gd name="csX23" fmla="*/ 881227 w 2840252"/>
+                <a:gd name="csY23" fmla="*/ 2280703 h 2793519"/>
+                <a:gd name="csX24" fmla="*/ 901848 w 2840252"/>
+                <a:gd name="csY24" fmla="*/ 2260082 h 2793519"/>
+                <a:gd name="csX25" fmla="*/ 978906 w 2840252"/>
+                <a:gd name="csY25" fmla="*/ 2260082 h 2793519"/>
+                <a:gd name="csX26" fmla="*/ 978906 w 2840252"/>
+                <a:gd name="csY26" fmla="*/ 2336597 h 2793519"/>
+                <a:gd name="csX27" fmla="*/ 957742 w 2840252"/>
+                <a:gd name="csY27" fmla="*/ 2357761 h 2793519"/>
+                <a:gd name="csX28" fmla="*/ 919213 w 2840252"/>
+                <a:gd name="csY28" fmla="*/ 2373498 h 2793519"/>
+                <a:gd name="csX29" fmla="*/ 881227 w 2840252"/>
+                <a:gd name="csY29" fmla="*/ 2357761 h 2793519"/>
+                <a:gd name="csX30" fmla="*/ 881227 w 2840252"/>
+                <a:gd name="csY30" fmla="*/ 2280703 h 2793519"/>
+                <a:gd name="csX31" fmla="*/ 1252408 w 2840252"/>
+                <a:gd name="csY31" fmla="*/ 1379340 h 2793519"/>
+                <a:gd name="csX32" fmla="*/ 1208452 w 2840252"/>
+                <a:gd name="csY32" fmla="*/ 1402132 h 2793519"/>
+                <a:gd name="csX33" fmla="*/ 1176978 w 2840252"/>
+                <a:gd name="csY33" fmla="*/ 1391821 h 2793519"/>
+                <a:gd name="csX34" fmla="*/ 1066275 w 2840252"/>
+                <a:gd name="csY34" fmla="*/ 1313135 h 2793519"/>
+                <a:gd name="csX35" fmla="*/ 1053793 w 2840252"/>
+                <a:gd name="csY35" fmla="*/ 1237162 h 2793519"/>
+                <a:gd name="csX36" fmla="*/ 1129766 w 2840252"/>
+                <a:gd name="csY36" fmla="*/ 1224681 h 2793519"/>
+                <a:gd name="csX37" fmla="*/ 1239927 w 2840252"/>
+                <a:gd name="csY37" fmla="*/ 1303367 h 2793519"/>
+                <a:gd name="csX38" fmla="*/ 1252408 w 2840252"/>
+                <a:gd name="csY38" fmla="*/ 1379340 h 2793519"/>
+                <a:gd name="csX39" fmla="*/ 771827 w 2840252"/>
+                <a:gd name="csY39" fmla="*/ 2096222 h 2793519"/>
+                <a:gd name="csX40" fmla="*/ 958738 w 2840252"/>
+                <a:gd name="csY40" fmla="*/ 1629685 h 2793519"/>
+                <a:gd name="csX41" fmla="*/ 1297530 w 2840252"/>
+                <a:gd name="csY41" fmla="*/ 1597279 h 2793519"/>
+                <a:gd name="csX42" fmla="*/ 1485434 w 2840252"/>
+                <a:gd name="csY42" fmla="*/ 1746019 h 2793519"/>
+                <a:gd name="csX43" fmla="*/ 1123833 w 2840252"/>
+                <a:gd name="csY43" fmla="*/ 2150212 h 2793519"/>
+                <a:gd name="csX44" fmla="*/ 771827 w 2840252"/>
+                <a:gd name="csY44" fmla="*/ 2096222 h 2793519"/>
+                <a:gd name="csX45" fmla="*/ 1448309 w 2840252"/>
+                <a:gd name="csY45" fmla="*/ 829622 h 2793519"/>
+                <a:gd name="csX46" fmla="*/ 1521569 w 2840252"/>
+                <a:gd name="csY46" fmla="*/ 805745 h 2793519"/>
+                <a:gd name="csX47" fmla="*/ 1657777 w 2840252"/>
+                <a:gd name="csY47" fmla="*/ 873578 h 2793519"/>
+                <a:gd name="csX48" fmla="*/ 1682197 w 2840252"/>
+                <a:gd name="csY48" fmla="*/ 946838 h 2793519"/>
+                <a:gd name="csX49" fmla="*/ 1633357 w 2840252"/>
+                <a:gd name="csY49" fmla="*/ 976684 h 2793519"/>
+                <a:gd name="csX50" fmla="*/ 1609480 w 2840252"/>
+                <a:gd name="csY50" fmla="*/ 970715 h 2793519"/>
+                <a:gd name="csX51" fmla="*/ 1472729 w 2840252"/>
+                <a:gd name="csY51" fmla="*/ 902339 h 2793519"/>
+                <a:gd name="csX52" fmla="*/ 1448309 w 2840252"/>
+                <a:gd name="csY52" fmla="*/ 829622 h 2793519"/>
+                <a:gd name="csX53" fmla="*/ 1971979 w 2840252"/>
+                <a:gd name="csY53" fmla="*/ 474178 h 2793519"/>
+                <a:gd name="csX54" fmla="*/ 1997484 w 2840252"/>
+                <a:gd name="csY54" fmla="*/ 546353 h 2793519"/>
+                <a:gd name="csX55" fmla="*/ 1945388 w 2840252"/>
+                <a:gd name="csY55" fmla="*/ 657056 h 2793519"/>
+                <a:gd name="csX56" fmla="*/ 1896006 w 2840252"/>
+                <a:gd name="csY56" fmla="*/ 687988 h 2793519"/>
+                <a:gd name="csX57" fmla="*/ 1872672 w 2840252"/>
+                <a:gd name="csY57" fmla="*/ 682561 h 2793519"/>
+                <a:gd name="csX58" fmla="*/ 1847166 w 2840252"/>
+                <a:gd name="csY58" fmla="*/ 610387 h 2793519"/>
+                <a:gd name="csX59" fmla="*/ 1899805 w 2840252"/>
+                <a:gd name="csY59" fmla="*/ 499684 h 2793519"/>
+                <a:gd name="csX60" fmla="*/ 1971979 w 2840252"/>
+                <a:gd name="csY60" fmla="*/ 474178 h 2793519"/>
+                <a:gd name="csX61" fmla="*/ 2277498 w 2840252"/>
+                <a:gd name="csY61" fmla="*/ 919704 h 2793519"/>
+                <a:gd name="csX62" fmla="*/ 2193385 w 2840252"/>
+                <a:gd name="csY62" fmla="*/ 801404 h 2793519"/>
+                <a:gd name="csX63" fmla="*/ 2205867 w 2840252"/>
+                <a:gd name="csY63" fmla="*/ 725974 h 2793519"/>
+                <a:gd name="csX64" fmla="*/ 2281839 w 2840252"/>
+                <a:gd name="csY64" fmla="*/ 738455 h 2793519"/>
+                <a:gd name="csX65" fmla="*/ 2365952 w 2840252"/>
+                <a:gd name="csY65" fmla="*/ 856756 h 2793519"/>
+                <a:gd name="csX66" fmla="*/ 2352928 w 2840252"/>
+                <a:gd name="csY66" fmla="*/ 932186 h 2793519"/>
+                <a:gd name="csX67" fmla="*/ 2321454 w 2840252"/>
+                <a:gd name="csY67" fmla="*/ 942496 h 2793519"/>
+                <a:gd name="csX68" fmla="*/ 2277498 w 2840252"/>
+                <a:gd name="csY68" fmla="*/ 919704 h 2793519"/>
+                <a:gd name="csX69" fmla="*/ 2307344 w 2840252"/>
+                <a:gd name="csY69" fmla="*/ 1226852 h 2793519"/>
+                <a:gd name="csX70" fmla="*/ 2253078 w 2840252"/>
+                <a:gd name="csY70" fmla="*/ 1281118 h 2793519"/>
+                <a:gd name="csX71" fmla="*/ 2196641 w 2840252"/>
+                <a:gd name="csY71" fmla="*/ 1226852 h 2793519"/>
+                <a:gd name="csX72" fmla="*/ 2248194 w 2840252"/>
+                <a:gd name="csY72" fmla="*/ 1172585 h 2793519"/>
+                <a:gd name="csX73" fmla="*/ 2253078 w 2840252"/>
+                <a:gd name="csY73" fmla="*/ 1172585 h 2793519"/>
+                <a:gd name="csX74" fmla="*/ 2307344 w 2840252"/>
+                <a:gd name="csY74" fmla="*/ 1226852 h 2793519"/>
+                <a:gd name="csX75" fmla="*/ 1923682 w 2840252"/>
+                <a:gd name="csY75" fmla="*/ 1254527 h 2793519"/>
+                <a:gd name="csX76" fmla="*/ 1891122 w 2840252"/>
+                <a:gd name="csY76" fmla="*/ 1265381 h 2793519"/>
+                <a:gd name="csX77" fmla="*/ 1847709 w 2840252"/>
+                <a:gd name="csY77" fmla="*/ 1243674 h 2793519"/>
+                <a:gd name="csX78" fmla="*/ 1800497 w 2840252"/>
+                <a:gd name="csY78" fmla="*/ 1180725 h 2793519"/>
+                <a:gd name="csX79" fmla="*/ 1811351 w 2840252"/>
+                <a:gd name="csY79" fmla="*/ 1104753 h 2793519"/>
+                <a:gd name="csX80" fmla="*/ 1887323 w 2840252"/>
+                <a:gd name="csY80" fmla="*/ 1115606 h 2793519"/>
+                <a:gd name="csX81" fmla="*/ 1934535 w 2840252"/>
+                <a:gd name="csY81" fmla="*/ 1178555 h 2793519"/>
+                <a:gd name="csX82" fmla="*/ 1923682 w 2840252"/>
+                <a:gd name="csY82" fmla="*/ 1254527 h 2793519"/>
+                <a:gd name="csX83" fmla="*/ 1559012 w 2840252"/>
+                <a:gd name="csY83" fmla="*/ 1944795 h 2793519"/>
+                <a:gd name="csX84" fmla="*/ 1648552 w 2840252"/>
+                <a:gd name="csY84" fmla="*/ 1934484 h 2793519"/>
+                <a:gd name="csX85" fmla="*/ 1708787 w 2840252"/>
+                <a:gd name="csY85" fmla="*/ 1982238 h 2793519"/>
+                <a:gd name="csX86" fmla="*/ 1661033 w 2840252"/>
+                <a:gd name="csY86" fmla="*/ 2042474 h 2793519"/>
+                <a:gd name="csX87" fmla="*/ 1571494 w 2840252"/>
+                <a:gd name="csY87" fmla="*/ 2052785 h 2793519"/>
+                <a:gd name="csX88" fmla="*/ 1565524 w 2840252"/>
+                <a:gd name="csY88" fmla="*/ 2053327 h 2793519"/>
+                <a:gd name="csX89" fmla="*/ 1511258 w 2840252"/>
+                <a:gd name="csY89" fmla="*/ 2005030 h 2793519"/>
+                <a:gd name="csX90" fmla="*/ 1559012 w 2840252"/>
+                <a:gd name="csY90" fmla="*/ 1944795 h 2793519"/>
+                <a:gd name="csX91" fmla="*/ 1555756 w 2840252"/>
+                <a:gd name="csY91" fmla="*/ 1458026 h 2793519"/>
+                <a:gd name="csX92" fmla="*/ 1555756 w 2840252"/>
+                <a:gd name="csY92" fmla="*/ 1396705 h 2793519"/>
+                <a:gd name="csX93" fmla="*/ 1610023 w 2840252"/>
+                <a:gd name="csY93" fmla="*/ 1342439 h 2793519"/>
+                <a:gd name="csX94" fmla="*/ 1664289 w 2840252"/>
+                <a:gd name="csY94" fmla="*/ 1396705 h 2793519"/>
+                <a:gd name="csX95" fmla="*/ 1664289 w 2840252"/>
+                <a:gd name="csY95" fmla="*/ 1458026 h 2793519"/>
+                <a:gd name="csX96" fmla="*/ 1610023 w 2840252"/>
+                <a:gd name="csY96" fmla="*/ 1512292 h 2793519"/>
+                <a:gd name="csX97" fmla="*/ 1555756 w 2840252"/>
+                <a:gd name="csY97" fmla="*/ 1458026 h 2793519"/>
+                <a:gd name="csX98" fmla="*/ 1916085 w 2840252"/>
+                <a:gd name="csY98" fmla="*/ 1753235 h 2793519"/>
+                <a:gd name="csX99" fmla="*/ 1905774 w 2840252"/>
+                <a:gd name="csY99" fmla="*/ 1677262 h 2793519"/>
+                <a:gd name="csX100" fmla="*/ 2005081 w 2840252"/>
+                <a:gd name="csY100" fmla="*/ 1545937 h 2793519"/>
+                <a:gd name="csX101" fmla="*/ 2081597 w 2840252"/>
+                <a:gd name="csY101" fmla="*/ 1535627 h 2793519"/>
+                <a:gd name="csX102" fmla="*/ 2091907 w 2840252"/>
+                <a:gd name="csY102" fmla="*/ 1611600 h 2793519"/>
+                <a:gd name="csX103" fmla="*/ 1992057 w 2840252"/>
+                <a:gd name="csY103" fmla="*/ 1742924 h 2793519"/>
+                <a:gd name="csX104" fmla="*/ 1948644 w 2840252"/>
+                <a:gd name="csY104" fmla="*/ 1764088 h 2793519"/>
+                <a:gd name="csX105" fmla="*/ 1916085 w 2840252"/>
+                <a:gd name="csY105" fmla="*/ 1753235 h 2793519"/>
+                <a:gd name="csX0" fmla="*/ 2559683 w 2840252"/>
+                <a:gd name="csY0" fmla="*/ 224011 h 2793519"/>
+                <a:gd name="csX1" fmla="*/ 2547201 w 2840252"/>
+                <a:gd name="csY1" fmla="*/ 213158 h 2793519"/>
+                <a:gd name="csX2" fmla="*/ 1886238 w 2840252"/>
+                <a:gd name="csY2" fmla="*/ 6403 h 2793519"/>
+                <a:gd name="csX3" fmla="*/ 1295821 w 2840252"/>
+                <a:gd name="csY3" fmla="*/ 366188 h 2793519"/>
+                <a:gd name="csX4" fmla="*/ 830759 w 2840252"/>
+                <a:gd name="csY4" fmla="*/ 914821 h 2793519"/>
+                <a:gd name="csX5" fmla="*/ 367867 w 2840252"/>
+                <a:gd name="csY5" fmla="*/ 1285459 h 2793519"/>
+                <a:gd name="csX6" fmla="*/ 3198 w 2840252"/>
+                <a:gd name="csY6" fmla="*/ 1897583 h 2793519"/>
+                <a:gd name="csX7" fmla="*/ 249024 w 2840252"/>
+                <a:gd name="csY7" fmla="*/ 2549321 h 2793519"/>
+                <a:gd name="csX8" fmla="*/ 249024 w 2840252"/>
+                <a:gd name="csY8" fmla="*/ 2549864 h 2793519"/>
+                <a:gd name="csX9" fmla="*/ 268560 w 2840252"/>
+                <a:gd name="csY9" fmla="*/ 2568314 h 2793519"/>
+                <a:gd name="csX10" fmla="*/ 828588 w 2840252"/>
+                <a:gd name="csY10" fmla="*/ 2793519 h 2793519"/>
+                <a:gd name="csX11" fmla="*/ 1199227 w 2840252"/>
+                <a:gd name="csY11" fmla="*/ 2702895 h 2793519"/>
+                <a:gd name="csX12" fmla="*/ 2031129 w 2840252"/>
+                <a:gd name="csY12" fmla="*/ 2120075 h 2793519"/>
+                <a:gd name="csX13" fmla="*/ 2715970 w 2840252"/>
+                <a:gd name="csY13" fmla="*/ 1289801 h 2793519"/>
+                <a:gd name="csX14" fmla="*/ 2559683 w 2840252"/>
+                <a:gd name="csY14" fmla="*/ 224011 h 2793519"/>
+                <a:gd name="csX15" fmla="*/ 641370 w 2840252"/>
+                <a:gd name="csY15" fmla="*/ 1742924 h 2793519"/>
+                <a:gd name="csX16" fmla="*/ 588731 w 2840252"/>
+                <a:gd name="csY16" fmla="*/ 1785252 h 2793519"/>
+                <a:gd name="csX17" fmla="*/ 576793 w 2840252"/>
+                <a:gd name="csY17" fmla="*/ 1784166 h 2793519"/>
+                <a:gd name="csX18" fmla="*/ 435158 w 2840252"/>
+                <a:gd name="csY18" fmla="*/ 1752692 h 2793519"/>
+                <a:gd name="csX19" fmla="*/ 393915 w 2840252"/>
+                <a:gd name="csY19" fmla="*/ 1687572 h 2793519"/>
+                <a:gd name="csX20" fmla="*/ 458492 w 2840252"/>
+                <a:gd name="csY20" fmla="*/ 1646330 h 2793519"/>
+                <a:gd name="csX21" fmla="*/ 600127 w 2840252"/>
+                <a:gd name="csY21" fmla="*/ 1677805 h 2793519"/>
+                <a:gd name="csX22" fmla="*/ 641370 w 2840252"/>
+                <a:gd name="csY22" fmla="*/ 1742924 h 2793519"/>
+                <a:gd name="csX23" fmla="*/ 881227 w 2840252"/>
+                <a:gd name="csY23" fmla="*/ 2280703 h 2793519"/>
+                <a:gd name="csX24" fmla="*/ 901848 w 2840252"/>
+                <a:gd name="csY24" fmla="*/ 2260082 h 2793519"/>
+                <a:gd name="csX25" fmla="*/ 978906 w 2840252"/>
+                <a:gd name="csY25" fmla="*/ 2260082 h 2793519"/>
+                <a:gd name="csX26" fmla="*/ 978906 w 2840252"/>
+                <a:gd name="csY26" fmla="*/ 2336597 h 2793519"/>
+                <a:gd name="csX27" fmla="*/ 957742 w 2840252"/>
+                <a:gd name="csY27" fmla="*/ 2357761 h 2793519"/>
+                <a:gd name="csX28" fmla="*/ 919213 w 2840252"/>
+                <a:gd name="csY28" fmla="*/ 2373498 h 2793519"/>
+                <a:gd name="csX29" fmla="*/ 881227 w 2840252"/>
+                <a:gd name="csY29" fmla="*/ 2357761 h 2793519"/>
+                <a:gd name="csX30" fmla="*/ 881227 w 2840252"/>
+                <a:gd name="csY30" fmla="*/ 2280703 h 2793519"/>
+                <a:gd name="csX31" fmla="*/ 1252408 w 2840252"/>
+                <a:gd name="csY31" fmla="*/ 1379340 h 2793519"/>
+                <a:gd name="csX32" fmla="*/ 1208452 w 2840252"/>
+                <a:gd name="csY32" fmla="*/ 1402132 h 2793519"/>
+                <a:gd name="csX33" fmla="*/ 1176978 w 2840252"/>
+                <a:gd name="csY33" fmla="*/ 1391821 h 2793519"/>
+                <a:gd name="csX34" fmla="*/ 1066275 w 2840252"/>
+                <a:gd name="csY34" fmla="*/ 1313135 h 2793519"/>
+                <a:gd name="csX35" fmla="*/ 1053793 w 2840252"/>
+                <a:gd name="csY35" fmla="*/ 1237162 h 2793519"/>
+                <a:gd name="csX36" fmla="*/ 1129766 w 2840252"/>
+                <a:gd name="csY36" fmla="*/ 1224681 h 2793519"/>
+                <a:gd name="csX37" fmla="*/ 1239927 w 2840252"/>
+                <a:gd name="csY37" fmla="*/ 1303367 h 2793519"/>
+                <a:gd name="csX38" fmla="*/ 1252408 w 2840252"/>
+                <a:gd name="csY38" fmla="*/ 1379340 h 2793519"/>
+                <a:gd name="csX39" fmla="*/ 771827 w 2840252"/>
+                <a:gd name="csY39" fmla="*/ 2096222 h 2793519"/>
+                <a:gd name="csX40" fmla="*/ 958738 w 2840252"/>
+                <a:gd name="csY40" fmla="*/ 1629685 h 2793519"/>
+                <a:gd name="csX41" fmla="*/ 1297530 w 2840252"/>
+                <a:gd name="csY41" fmla="*/ 1597279 h 2793519"/>
+                <a:gd name="csX42" fmla="*/ 1485434 w 2840252"/>
+                <a:gd name="csY42" fmla="*/ 1746019 h 2793519"/>
+                <a:gd name="csX43" fmla="*/ 1123833 w 2840252"/>
+                <a:gd name="csY43" fmla="*/ 2150212 h 2793519"/>
+                <a:gd name="csX44" fmla="*/ 771827 w 2840252"/>
+                <a:gd name="csY44" fmla="*/ 2096222 h 2793519"/>
+                <a:gd name="csX45" fmla="*/ 1448309 w 2840252"/>
+                <a:gd name="csY45" fmla="*/ 829622 h 2793519"/>
+                <a:gd name="csX46" fmla="*/ 1521569 w 2840252"/>
+                <a:gd name="csY46" fmla="*/ 805745 h 2793519"/>
+                <a:gd name="csX47" fmla="*/ 1657777 w 2840252"/>
+                <a:gd name="csY47" fmla="*/ 873578 h 2793519"/>
+                <a:gd name="csX48" fmla="*/ 1682197 w 2840252"/>
+                <a:gd name="csY48" fmla="*/ 946838 h 2793519"/>
+                <a:gd name="csX49" fmla="*/ 1633357 w 2840252"/>
+                <a:gd name="csY49" fmla="*/ 976684 h 2793519"/>
+                <a:gd name="csX50" fmla="*/ 1609480 w 2840252"/>
+                <a:gd name="csY50" fmla="*/ 970715 h 2793519"/>
+                <a:gd name="csX51" fmla="*/ 1472729 w 2840252"/>
+                <a:gd name="csY51" fmla="*/ 902339 h 2793519"/>
+                <a:gd name="csX52" fmla="*/ 1448309 w 2840252"/>
+                <a:gd name="csY52" fmla="*/ 829622 h 2793519"/>
+                <a:gd name="csX53" fmla="*/ 1971979 w 2840252"/>
+                <a:gd name="csY53" fmla="*/ 474178 h 2793519"/>
+                <a:gd name="csX54" fmla="*/ 1997484 w 2840252"/>
+                <a:gd name="csY54" fmla="*/ 546353 h 2793519"/>
+                <a:gd name="csX55" fmla="*/ 1945388 w 2840252"/>
+                <a:gd name="csY55" fmla="*/ 657056 h 2793519"/>
+                <a:gd name="csX56" fmla="*/ 1896006 w 2840252"/>
+                <a:gd name="csY56" fmla="*/ 687988 h 2793519"/>
+                <a:gd name="csX57" fmla="*/ 1872672 w 2840252"/>
+                <a:gd name="csY57" fmla="*/ 682561 h 2793519"/>
+                <a:gd name="csX58" fmla="*/ 1847166 w 2840252"/>
+                <a:gd name="csY58" fmla="*/ 610387 h 2793519"/>
+                <a:gd name="csX59" fmla="*/ 1899805 w 2840252"/>
+                <a:gd name="csY59" fmla="*/ 499684 h 2793519"/>
+                <a:gd name="csX60" fmla="*/ 1971979 w 2840252"/>
+                <a:gd name="csY60" fmla="*/ 474178 h 2793519"/>
+                <a:gd name="csX61" fmla="*/ 2277498 w 2840252"/>
+                <a:gd name="csY61" fmla="*/ 919704 h 2793519"/>
+                <a:gd name="csX62" fmla="*/ 2193385 w 2840252"/>
+                <a:gd name="csY62" fmla="*/ 801404 h 2793519"/>
+                <a:gd name="csX63" fmla="*/ 2205867 w 2840252"/>
+                <a:gd name="csY63" fmla="*/ 725974 h 2793519"/>
+                <a:gd name="csX64" fmla="*/ 2281839 w 2840252"/>
+                <a:gd name="csY64" fmla="*/ 738455 h 2793519"/>
+                <a:gd name="csX65" fmla="*/ 2365952 w 2840252"/>
+                <a:gd name="csY65" fmla="*/ 856756 h 2793519"/>
+                <a:gd name="csX66" fmla="*/ 2352928 w 2840252"/>
+                <a:gd name="csY66" fmla="*/ 932186 h 2793519"/>
+                <a:gd name="csX67" fmla="*/ 2321454 w 2840252"/>
+                <a:gd name="csY67" fmla="*/ 942496 h 2793519"/>
+                <a:gd name="csX68" fmla="*/ 2277498 w 2840252"/>
+                <a:gd name="csY68" fmla="*/ 919704 h 2793519"/>
+                <a:gd name="csX69" fmla="*/ 2307344 w 2840252"/>
+                <a:gd name="csY69" fmla="*/ 1226852 h 2793519"/>
+                <a:gd name="csX70" fmla="*/ 2253078 w 2840252"/>
+                <a:gd name="csY70" fmla="*/ 1281118 h 2793519"/>
+                <a:gd name="csX71" fmla="*/ 2196641 w 2840252"/>
+                <a:gd name="csY71" fmla="*/ 1226852 h 2793519"/>
+                <a:gd name="csX72" fmla="*/ 2248194 w 2840252"/>
+                <a:gd name="csY72" fmla="*/ 1172585 h 2793519"/>
+                <a:gd name="csX73" fmla="*/ 2253078 w 2840252"/>
+                <a:gd name="csY73" fmla="*/ 1172585 h 2793519"/>
+                <a:gd name="csX74" fmla="*/ 2307344 w 2840252"/>
+                <a:gd name="csY74" fmla="*/ 1226852 h 2793519"/>
+                <a:gd name="csX75" fmla="*/ 1923682 w 2840252"/>
+                <a:gd name="csY75" fmla="*/ 1254527 h 2793519"/>
+                <a:gd name="csX76" fmla="*/ 1891122 w 2840252"/>
+                <a:gd name="csY76" fmla="*/ 1265381 h 2793519"/>
+                <a:gd name="csX77" fmla="*/ 1847709 w 2840252"/>
+                <a:gd name="csY77" fmla="*/ 1243674 h 2793519"/>
+                <a:gd name="csX78" fmla="*/ 1800497 w 2840252"/>
+                <a:gd name="csY78" fmla="*/ 1180725 h 2793519"/>
+                <a:gd name="csX79" fmla="*/ 1811351 w 2840252"/>
+                <a:gd name="csY79" fmla="*/ 1104753 h 2793519"/>
+                <a:gd name="csX80" fmla="*/ 1887323 w 2840252"/>
+                <a:gd name="csY80" fmla="*/ 1115606 h 2793519"/>
+                <a:gd name="csX81" fmla="*/ 1934535 w 2840252"/>
+                <a:gd name="csY81" fmla="*/ 1178555 h 2793519"/>
+                <a:gd name="csX82" fmla="*/ 1923682 w 2840252"/>
+                <a:gd name="csY82" fmla="*/ 1254527 h 2793519"/>
+                <a:gd name="csX83" fmla="*/ 1559012 w 2840252"/>
+                <a:gd name="csY83" fmla="*/ 1944795 h 2793519"/>
+                <a:gd name="csX84" fmla="*/ 1648552 w 2840252"/>
+                <a:gd name="csY84" fmla="*/ 1934484 h 2793519"/>
+                <a:gd name="csX85" fmla="*/ 1708787 w 2840252"/>
+                <a:gd name="csY85" fmla="*/ 1982238 h 2793519"/>
+                <a:gd name="csX86" fmla="*/ 1661033 w 2840252"/>
+                <a:gd name="csY86" fmla="*/ 2042474 h 2793519"/>
+                <a:gd name="csX87" fmla="*/ 1571494 w 2840252"/>
+                <a:gd name="csY87" fmla="*/ 2052785 h 2793519"/>
+                <a:gd name="csX88" fmla="*/ 1565524 w 2840252"/>
+                <a:gd name="csY88" fmla="*/ 2053327 h 2793519"/>
+                <a:gd name="csX89" fmla="*/ 1511258 w 2840252"/>
+                <a:gd name="csY89" fmla="*/ 2005030 h 2793519"/>
+                <a:gd name="csX90" fmla="*/ 1559012 w 2840252"/>
+                <a:gd name="csY90" fmla="*/ 1944795 h 2793519"/>
+                <a:gd name="csX91" fmla="*/ 1555756 w 2840252"/>
+                <a:gd name="csY91" fmla="*/ 1458026 h 2793519"/>
+                <a:gd name="csX92" fmla="*/ 1555756 w 2840252"/>
+                <a:gd name="csY92" fmla="*/ 1396705 h 2793519"/>
+                <a:gd name="csX93" fmla="*/ 1610023 w 2840252"/>
+                <a:gd name="csY93" fmla="*/ 1342439 h 2793519"/>
+                <a:gd name="csX94" fmla="*/ 1664289 w 2840252"/>
+                <a:gd name="csY94" fmla="*/ 1396705 h 2793519"/>
+                <a:gd name="csX95" fmla="*/ 1664289 w 2840252"/>
+                <a:gd name="csY95" fmla="*/ 1458026 h 2793519"/>
+                <a:gd name="csX96" fmla="*/ 1610023 w 2840252"/>
+                <a:gd name="csY96" fmla="*/ 1512292 h 2793519"/>
+                <a:gd name="csX97" fmla="*/ 1555756 w 2840252"/>
+                <a:gd name="csY97" fmla="*/ 1458026 h 2793519"/>
+                <a:gd name="csX98" fmla="*/ 1916085 w 2840252"/>
+                <a:gd name="csY98" fmla="*/ 1753235 h 2793519"/>
+                <a:gd name="csX99" fmla="*/ 1905774 w 2840252"/>
+                <a:gd name="csY99" fmla="*/ 1677262 h 2793519"/>
+                <a:gd name="csX100" fmla="*/ 2005081 w 2840252"/>
+                <a:gd name="csY100" fmla="*/ 1545937 h 2793519"/>
+                <a:gd name="csX101" fmla="*/ 2081597 w 2840252"/>
+                <a:gd name="csY101" fmla="*/ 1535627 h 2793519"/>
+                <a:gd name="csX102" fmla="*/ 2091907 w 2840252"/>
+                <a:gd name="csY102" fmla="*/ 1611600 h 2793519"/>
+                <a:gd name="csX103" fmla="*/ 1992057 w 2840252"/>
+                <a:gd name="csY103" fmla="*/ 1742924 h 2793519"/>
+                <a:gd name="csX104" fmla="*/ 1948644 w 2840252"/>
+                <a:gd name="csY104" fmla="*/ 1764088 h 2793519"/>
+                <a:gd name="csX105" fmla="*/ 1916085 w 2840252"/>
+                <a:gd name="csY105" fmla="*/ 1753235 h 2793519"/>
+                <a:gd name="csX0" fmla="*/ 2559683 w 2840252"/>
+                <a:gd name="csY0" fmla="*/ 224011 h 2793519"/>
+                <a:gd name="csX1" fmla="*/ 2547201 w 2840252"/>
+                <a:gd name="csY1" fmla="*/ 213158 h 2793519"/>
+                <a:gd name="csX2" fmla="*/ 1886238 w 2840252"/>
+                <a:gd name="csY2" fmla="*/ 6403 h 2793519"/>
+                <a:gd name="csX3" fmla="*/ 1295821 w 2840252"/>
+                <a:gd name="csY3" fmla="*/ 366188 h 2793519"/>
+                <a:gd name="csX4" fmla="*/ 830759 w 2840252"/>
+                <a:gd name="csY4" fmla="*/ 914821 h 2793519"/>
+                <a:gd name="csX5" fmla="*/ 367867 w 2840252"/>
+                <a:gd name="csY5" fmla="*/ 1285459 h 2793519"/>
+                <a:gd name="csX6" fmla="*/ 3198 w 2840252"/>
+                <a:gd name="csY6" fmla="*/ 1897583 h 2793519"/>
+                <a:gd name="csX7" fmla="*/ 249024 w 2840252"/>
+                <a:gd name="csY7" fmla="*/ 2549321 h 2793519"/>
+                <a:gd name="csX8" fmla="*/ 249024 w 2840252"/>
+                <a:gd name="csY8" fmla="*/ 2549864 h 2793519"/>
+                <a:gd name="csX9" fmla="*/ 268560 w 2840252"/>
+                <a:gd name="csY9" fmla="*/ 2568314 h 2793519"/>
+                <a:gd name="csX10" fmla="*/ 828588 w 2840252"/>
+                <a:gd name="csY10" fmla="*/ 2793519 h 2793519"/>
+                <a:gd name="csX11" fmla="*/ 1199227 w 2840252"/>
+                <a:gd name="csY11" fmla="*/ 2702895 h 2793519"/>
+                <a:gd name="csX12" fmla="*/ 2031129 w 2840252"/>
+                <a:gd name="csY12" fmla="*/ 2120075 h 2793519"/>
+                <a:gd name="csX13" fmla="*/ 2715970 w 2840252"/>
+                <a:gd name="csY13" fmla="*/ 1289801 h 2793519"/>
+                <a:gd name="csX14" fmla="*/ 2559683 w 2840252"/>
+                <a:gd name="csY14" fmla="*/ 224011 h 2793519"/>
+                <a:gd name="csX15" fmla="*/ 641370 w 2840252"/>
+                <a:gd name="csY15" fmla="*/ 1742924 h 2793519"/>
+                <a:gd name="csX16" fmla="*/ 588731 w 2840252"/>
+                <a:gd name="csY16" fmla="*/ 1785252 h 2793519"/>
+                <a:gd name="csX17" fmla="*/ 576793 w 2840252"/>
+                <a:gd name="csY17" fmla="*/ 1784166 h 2793519"/>
+                <a:gd name="csX18" fmla="*/ 435158 w 2840252"/>
+                <a:gd name="csY18" fmla="*/ 1752692 h 2793519"/>
+                <a:gd name="csX19" fmla="*/ 393915 w 2840252"/>
+                <a:gd name="csY19" fmla="*/ 1687572 h 2793519"/>
+                <a:gd name="csX20" fmla="*/ 458492 w 2840252"/>
+                <a:gd name="csY20" fmla="*/ 1646330 h 2793519"/>
+                <a:gd name="csX21" fmla="*/ 600127 w 2840252"/>
+                <a:gd name="csY21" fmla="*/ 1677805 h 2793519"/>
+                <a:gd name="csX22" fmla="*/ 641370 w 2840252"/>
+                <a:gd name="csY22" fmla="*/ 1742924 h 2793519"/>
+                <a:gd name="csX23" fmla="*/ 881227 w 2840252"/>
+                <a:gd name="csY23" fmla="*/ 2280703 h 2793519"/>
+                <a:gd name="csX24" fmla="*/ 901848 w 2840252"/>
+                <a:gd name="csY24" fmla="*/ 2260082 h 2793519"/>
+                <a:gd name="csX25" fmla="*/ 978906 w 2840252"/>
+                <a:gd name="csY25" fmla="*/ 2260082 h 2793519"/>
+                <a:gd name="csX26" fmla="*/ 978906 w 2840252"/>
+                <a:gd name="csY26" fmla="*/ 2336597 h 2793519"/>
+                <a:gd name="csX27" fmla="*/ 957742 w 2840252"/>
+                <a:gd name="csY27" fmla="*/ 2357761 h 2793519"/>
+                <a:gd name="csX28" fmla="*/ 919213 w 2840252"/>
+                <a:gd name="csY28" fmla="*/ 2373498 h 2793519"/>
+                <a:gd name="csX29" fmla="*/ 881227 w 2840252"/>
+                <a:gd name="csY29" fmla="*/ 2357761 h 2793519"/>
+                <a:gd name="csX30" fmla="*/ 881227 w 2840252"/>
+                <a:gd name="csY30" fmla="*/ 2280703 h 2793519"/>
+                <a:gd name="csX31" fmla="*/ 1252408 w 2840252"/>
+                <a:gd name="csY31" fmla="*/ 1379340 h 2793519"/>
+                <a:gd name="csX32" fmla="*/ 1208452 w 2840252"/>
+                <a:gd name="csY32" fmla="*/ 1402132 h 2793519"/>
+                <a:gd name="csX33" fmla="*/ 1176978 w 2840252"/>
+                <a:gd name="csY33" fmla="*/ 1391821 h 2793519"/>
+                <a:gd name="csX34" fmla="*/ 1066275 w 2840252"/>
+                <a:gd name="csY34" fmla="*/ 1313135 h 2793519"/>
+                <a:gd name="csX35" fmla="*/ 1053793 w 2840252"/>
+                <a:gd name="csY35" fmla="*/ 1237162 h 2793519"/>
+                <a:gd name="csX36" fmla="*/ 1129766 w 2840252"/>
+                <a:gd name="csY36" fmla="*/ 1224681 h 2793519"/>
+                <a:gd name="csX37" fmla="*/ 1239927 w 2840252"/>
+                <a:gd name="csY37" fmla="*/ 1303367 h 2793519"/>
+                <a:gd name="csX38" fmla="*/ 1252408 w 2840252"/>
+                <a:gd name="csY38" fmla="*/ 1379340 h 2793519"/>
+                <a:gd name="csX39" fmla="*/ 771827 w 2840252"/>
+                <a:gd name="csY39" fmla="*/ 2096222 h 2793519"/>
+                <a:gd name="csX40" fmla="*/ 958738 w 2840252"/>
+                <a:gd name="csY40" fmla="*/ 1629685 h 2793519"/>
+                <a:gd name="csX41" fmla="*/ 1297530 w 2840252"/>
+                <a:gd name="csY41" fmla="*/ 1597279 h 2793519"/>
+                <a:gd name="csX42" fmla="*/ 1485434 w 2840252"/>
+                <a:gd name="csY42" fmla="*/ 1746019 h 2793519"/>
+                <a:gd name="csX43" fmla="*/ 1123833 w 2840252"/>
+                <a:gd name="csY43" fmla="*/ 2150212 h 2793519"/>
+                <a:gd name="csX44" fmla="*/ 771827 w 2840252"/>
+                <a:gd name="csY44" fmla="*/ 2096222 h 2793519"/>
+                <a:gd name="csX45" fmla="*/ 1448309 w 2840252"/>
+                <a:gd name="csY45" fmla="*/ 829622 h 2793519"/>
+                <a:gd name="csX46" fmla="*/ 1521569 w 2840252"/>
+                <a:gd name="csY46" fmla="*/ 805745 h 2793519"/>
+                <a:gd name="csX47" fmla="*/ 1657777 w 2840252"/>
+                <a:gd name="csY47" fmla="*/ 873578 h 2793519"/>
+                <a:gd name="csX48" fmla="*/ 1682197 w 2840252"/>
+                <a:gd name="csY48" fmla="*/ 946838 h 2793519"/>
+                <a:gd name="csX49" fmla="*/ 1633357 w 2840252"/>
+                <a:gd name="csY49" fmla="*/ 976684 h 2793519"/>
+                <a:gd name="csX50" fmla="*/ 1609480 w 2840252"/>
+                <a:gd name="csY50" fmla="*/ 970715 h 2793519"/>
+                <a:gd name="csX51" fmla="*/ 1472729 w 2840252"/>
+                <a:gd name="csY51" fmla="*/ 902339 h 2793519"/>
+                <a:gd name="csX52" fmla="*/ 1448309 w 2840252"/>
+                <a:gd name="csY52" fmla="*/ 829622 h 2793519"/>
+                <a:gd name="csX53" fmla="*/ 1971979 w 2840252"/>
+                <a:gd name="csY53" fmla="*/ 474178 h 2793519"/>
+                <a:gd name="csX54" fmla="*/ 1997484 w 2840252"/>
+                <a:gd name="csY54" fmla="*/ 546353 h 2793519"/>
+                <a:gd name="csX55" fmla="*/ 1945388 w 2840252"/>
+                <a:gd name="csY55" fmla="*/ 657056 h 2793519"/>
+                <a:gd name="csX56" fmla="*/ 1896006 w 2840252"/>
+                <a:gd name="csY56" fmla="*/ 687988 h 2793519"/>
+                <a:gd name="csX57" fmla="*/ 1872672 w 2840252"/>
+                <a:gd name="csY57" fmla="*/ 682561 h 2793519"/>
+                <a:gd name="csX58" fmla="*/ 1847166 w 2840252"/>
+                <a:gd name="csY58" fmla="*/ 610387 h 2793519"/>
+                <a:gd name="csX59" fmla="*/ 1899805 w 2840252"/>
+                <a:gd name="csY59" fmla="*/ 499684 h 2793519"/>
+                <a:gd name="csX60" fmla="*/ 1971979 w 2840252"/>
+                <a:gd name="csY60" fmla="*/ 474178 h 2793519"/>
+                <a:gd name="csX61" fmla="*/ 2277498 w 2840252"/>
+                <a:gd name="csY61" fmla="*/ 919704 h 2793519"/>
+                <a:gd name="csX62" fmla="*/ 2193385 w 2840252"/>
+                <a:gd name="csY62" fmla="*/ 801404 h 2793519"/>
+                <a:gd name="csX63" fmla="*/ 2205867 w 2840252"/>
+                <a:gd name="csY63" fmla="*/ 725974 h 2793519"/>
+                <a:gd name="csX64" fmla="*/ 2281839 w 2840252"/>
+                <a:gd name="csY64" fmla="*/ 738455 h 2793519"/>
+                <a:gd name="csX65" fmla="*/ 2365952 w 2840252"/>
+                <a:gd name="csY65" fmla="*/ 856756 h 2793519"/>
+                <a:gd name="csX66" fmla="*/ 2352928 w 2840252"/>
+                <a:gd name="csY66" fmla="*/ 932186 h 2793519"/>
+                <a:gd name="csX67" fmla="*/ 2321454 w 2840252"/>
+                <a:gd name="csY67" fmla="*/ 942496 h 2793519"/>
+                <a:gd name="csX68" fmla="*/ 2277498 w 2840252"/>
+                <a:gd name="csY68" fmla="*/ 919704 h 2793519"/>
+                <a:gd name="csX69" fmla="*/ 2307344 w 2840252"/>
+                <a:gd name="csY69" fmla="*/ 1226852 h 2793519"/>
+                <a:gd name="csX70" fmla="*/ 2253078 w 2840252"/>
+                <a:gd name="csY70" fmla="*/ 1281118 h 2793519"/>
+                <a:gd name="csX71" fmla="*/ 2196641 w 2840252"/>
+                <a:gd name="csY71" fmla="*/ 1226852 h 2793519"/>
+                <a:gd name="csX72" fmla="*/ 2248194 w 2840252"/>
+                <a:gd name="csY72" fmla="*/ 1172585 h 2793519"/>
+                <a:gd name="csX73" fmla="*/ 2253078 w 2840252"/>
+                <a:gd name="csY73" fmla="*/ 1172585 h 2793519"/>
+                <a:gd name="csX74" fmla="*/ 2307344 w 2840252"/>
+                <a:gd name="csY74" fmla="*/ 1226852 h 2793519"/>
+                <a:gd name="csX75" fmla="*/ 1923682 w 2840252"/>
+                <a:gd name="csY75" fmla="*/ 1254527 h 2793519"/>
+                <a:gd name="csX76" fmla="*/ 1891122 w 2840252"/>
+                <a:gd name="csY76" fmla="*/ 1265381 h 2793519"/>
+                <a:gd name="csX77" fmla="*/ 1847709 w 2840252"/>
+                <a:gd name="csY77" fmla="*/ 1243674 h 2793519"/>
+                <a:gd name="csX78" fmla="*/ 1800497 w 2840252"/>
+                <a:gd name="csY78" fmla="*/ 1180725 h 2793519"/>
+                <a:gd name="csX79" fmla="*/ 1811351 w 2840252"/>
+                <a:gd name="csY79" fmla="*/ 1104753 h 2793519"/>
+                <a:gd name="csX80" fmla="*/ 1887323 w 2840252"/>
+                <a:gd name="csY80" fmla="*/ 1115606 h 2793519"/>
+                <a:gd name="csX81" fmla="*/ 1934535 w 2840252"/>
+                <a:gd name="csY81" fmla="*/ 1178555 h 2793519"/>
+                <a:gd name="csX82" fmla="*/ 1923682 w 2840252"/>
+                <a:gd name="csY82" fmla="*/ 1254527 h 2793519"/>
+                <a:gd name="csX83" fmla="*/ 1559012 w 2840252"/>
+                <a:gd name="csY83" fmla="*/ 1944795 h 2793519"/>
+                <a:gd name="csX84" fmla="*/ 1648552 w 2840252"/>
+                <a:gd name="csY84" fmla="*/ 1934484 h 2793519"/>
+                <a:gd name="csX85" fmla="*/ 1708787 w 2840252"/>
+                <a:gd name="csY85" fmla="*/ 1982238 h 2793519"/>
+                <a:gd name="csX86" fmla="*/ 1661033 w 2840252"/>
+                <a:gd name="csY86" fmla="*/ 2042474 h 2793519"/>
+                <a:gd name="csX87" fmla="*/ 1571494 w 2840252"/>
+                <a:gd name="csY87" fmla="*/ 2052785 h 2793519"/>
+                <a:gd name="csX88" fmla="*/ 1565524 w 2840252"/>
+                <a:gd name="csY88" fmla="*/ 2053327 h 2793519"/>
+                <a:gd name="csX89" fmla="*/ 1511258 w 2840252"/>
+                <a:gd name="csY89" fmla="*/ 2005030 h 2793519"/>
+                <a:gd name="csX90" fmla="*/ 1559012 w 2840252"/>
+                <a:gd name="csY90" fmla="*/ 1944795 h 2793519"/>
+                <a:gd name="csX91" fmla="*/ 1555756 w 2840252"/>
+                <a:gd name="csY91" fmla="*/ 1458026 h 2793519"/>
+                <a:gd name="csX92" fmla="*/ 1555756 w 2840252"/>
+                <a:gd name="csY92" fmla="*/ 1396705 h 2793519"/>
+                <a:gd name="csX93" fmla="*/ 1610023 w 2840252"/>
+                <a:gd name="csY93" fmla="*/ 1342439 h 2793519"/>
+                <a:gd name="csX94" fmla="*/ 1664289 w 2840252"/>
+                <a:gd name="csY94" fmla="*/ 1396705 h 2793519"/>
+                <a:gd name="csX95" fmla="*/ 1664289 w 2840252"/>
+                <a:gd name="csY95" fmla="*/ 1458026 h 2793519"/>
+                <a:gd name="csX96" fmla="*/ 1610023 w 2840252"/>
+                <a:gd name="csY96" fmla="*/ 1512292 h 2793519"/>
+                <a:gd name="csX97" fmla="*/ 1555756 w 2840252"/>
+                <a:gd name="csY97" fmla="*/ 1458026 h 2793519"/>
+                <a:gd name="csX98" fmla="*/ 1916085 w 2840252"/>
+                <a:gd name="csY98" fmla="*/ 1753235 h 2793519"/>
+                <a:gd name="csX99" fmla="*/ 1905774 w 2840252"/>
+                <a:gd name="csY99" fmla="*/ 1677262 h 2793519"/>
+                <a:gd name="csX100" fmla="*/ 2005081 w 2840252"/>
+                <a:gd name="csY100" fmla="*/ 1545937 h 2793519"/>
+                <a:gd name="csX101" fmla="*/ 2081597 w 2840252"/>
+                <a:gd name="csY101" fmla="*/ 1535627 h 2793519"/>
+                <a:gd name="csX102" fmla="*/ 2091907 w 2840252"/>
+                <a:gd name="csY102" fmla="*/ 1611600 h 2793519"/>
+                <a:gd name="csX103" fmla="*/ 1992057 w 2840252"/>
+                <a:gd name="csY103" fmla="*/ 1742924 h 2793519"/>
+                <a:gd name="csX104" fmla="*/ 1948644 w 2840252"/>
+                <a:gd name="csY104" fmla="*/ 1764088 h 2793519"/>
+                <a:gd name="csX105" fmla="*/ 1916085 w 2840252"/>
+                <a:gd name="csY105" fmla="*/ 1753235 h 2793519"/>
+                <a:gd name="csX0" fmla="*/ 2559683 w 2840252"/>
+                <a:gd name="csY0" fmla="*/ 224011 h 2793519"/>
+                <a:gd name="csX1" fmla="*/ 2547201 w 2840252"/>
+                <a:gd name="csY1" fmla="*/ 213158 h 2793519"/>
+                <a:gd name="csX2" fmla="*/ 1886238 w 2840252"/>
+                <a:gd name="csY2" fmla="*/ 6403 h 2793519"/>
+                <a:gd name="csX3" fmla="*/ 1295821 w 2840252"/>
+                <a:gd name="csY3" fmla="*/ 366188 h 2793519"/>
+                <a:gd name="csX4" fmla="*/ 830759 w 2840252"/>
+                <a:gd name="csY4" fmla="*/ 914821 h 2793519"/>
+                <a:gd name="csX5" fmla="*/ 367867 w 2840252"/>
+                <a:gd name="csY5" fmla="*/ 1285459 h 2793519"/>
+                <a:gd name="csX6" fmla="*/ 3198 w 2840252"/>
+                <a:gd name="csY6" fmla="*/ 1897583 h 2793519"/>
+                <a:gd name="csX7" fmla="*/ 249024 w 2840252"/>
+                <a:gd name="csY7" fmla="*/ 2549321 h 2793519"/>
+                <a:gd name="csX8" fmla="*/ 249024 w 2840252"/>
+                <a:gd name="csY8" fmla="*/ 2549864 h 2793519"/>
+                <a:gd name="csX9" fmla="*/ 268560 w 2840252"/>
+                <a:gd name="csY9" fmla="*/ 2568314 h 2793519"/>
+                <a:gd name="csX10" fmla="*/ 828588 w 2840252"/>
+                <a:gd name="csY10" fmla="*/ 2793519 h 2793519"/>
+                <a:gd name="csX11" fmla="*/ 1199227 w 2840252"/>
+                <a:gd name="csY11" fmla="*/ 2702895 h 2793519"/>
+                <a:gd name="csX12" fmla="*/ 2031129 w 2840252"/>
+                <a:gd name="csY12" fmla="*/ 2120075 h 2793519"/>
+                <a:gd name="csX13" fmla="*/ 2715970 w 2840252"/>
+                <a:gd name="csY13" fmla="*/ 1289801 h 2793519"/>
+                <a:gd name="csX14" fmla="*/ 2559683 w 2840252"/>
+                <a:gd name="csY14" fmla="*/ 224011 h 2793519"/>
+                <a:gd name="csX15" fmla="*/ 641370 w 2840252"/>
+                <a:gd name="csY15" fmla="*/ 1742924 h 2793519"/>
+                <a:gd name="csX16" fmla="*/ 588731 w 2840252"/>
+                <a:gd name="csY16" fmla="*/ 1785252 h 2793519"/>
+                <a:gd name="csX17" fmla="*/ 576793 w 2840252"/>
+                <a:gd name="csY17" fmla="*/ 1784166 h 2793519"/>
+                <a:gd name="csX18" fmla="*/ 435158 w 2840252"/>
+                <a:gd name="csY18" fmla="*/ 1752692 h 2793519"/>
+                <a:gd name="csX19" fmla="*/ 393915 w 2840252"/>
+                <a:gd name="csY19" fmla="*/ 1687572 h 2793519"/>
+                <a:gd name="csX20" fmla="*/ 458492 w 2840252"/>
+                <a:gd name="csY20" fmla="*/ 1646330 h 2793519"/>
+                <a:gd name="csX21" fmla="*/ 600127 w 2840252"/>
+                <a:gd name="csY21" fmla="*/ 1677805 h 2793519"/>
+                <a:gd name="csX22" fmla="*/ 641370 w 2840252"/>
+                <a:gd name="csY22" fmla="*/ 1742924 h 2793519"/>
+                <a:gd name="csX23" fmla="*/ 881227 w 2840252"/>
+                <a:gd name="csY23" fmla="*/ 2280703 h 2793519"/>
+                <a:gd name="csX24" fmla="*/ 901848 w 2840252"/>
+                <a:gd name="csY24" fmla="*/ 2260082 h 2793519"/>
+                <a:gd name="csX25" fmla="*/ 978906 w 2840252"/>
+                <a:gd name="csY25" fmla="*/ 2260082 h 2793519"/>
+                <a:gd name="csX26" fmla="*/ 978906 w 2840252"/>
+                <a:gd name="csY26" fmla="*/ 2336597 h 2793519"/>
+                <a:gd name="csX27" fmla="*/ 957742 w 2840252"/>
+                <a:gd name="csY27" fmla="*/ 2357761 h 2793519"/>
+                <a:gd name="csX28" fmla="*/ 919213 w 2840252"/>
+                <a:gd name="csY28" fmla="*/ 2373498 h 2793519"/>
+                <a:gd name="csX29" fmla="*/ 881227 w 2840252"/>
+                <a:gd name="csY29" fmla="*/ 2357761 h 2793519"/>
+                <a:gd name="csX30" fmla="*/ 881227 w 2840252"/>
+                <a:gd name="csY30" fmla="*/ 2280703 h 2793519"/>
+                <a:gd name="csX31" fmla="*/ 1252408 w 2840252"/>
+                <a:gd name="csY31" fmla="*/ 1379340 h 2793519"/>
+                <a:gd name="csX32" fmla="*/ 1208452 w 2840252"/>
+                <a:gd name="csY32" fmla="*/ 1402132 h 2793519"/>
+                <a:gd name="csX33" fmla="*/ 1176978 w 2840252"/>
+                <a:gd name="csY33" fmla="*/ 1391821 h 2793519"/>
+                <a:gd name="csX34" fmla="*/ 1066275 w 2840252"/>
+                <a:gd name="csY34" fmla="*/ 1313135 h 2793519"/>
+                <a:gd name="csX35" fmla="*/ 1053793 w 2840252"/>
+                <a:gd name="csY35" fmla="*/ 1237162 h 2793519"/>
+                <a:gd name="csX36" fmla="*/ 1129766 w 2840252"/>
+                <a:gd name="csY36" fmla="*/ 1224681 h 2793519"/>
+                <a:gd name="csX37" fmla="*/ 1239927 w 2840252"/>
+                <a:gd name="csY37" fmla="*/ 1303367 h 2793519"/>
+                <a:gd name="csX38" fmla="*/ 1252408 w 2840252"/>
+                <a:gd name="csY38" fmla="*/ 1379340 h 2793519"/>
+                <a:gd name="csX39" fmla="*/ 771827 w 2840252"/>
+                <a:gd name="csY39" fmla="*/ 2096222 h 2793519"/>
+                <a:gd name="csX40" fmla="*/ 958738 w 2840252"/>
+                <a:gd name="csY40" fmla="*/ 1629685 h 2793519"/>
+                <a:gd name="csX41" fmla="*/ 1297530 w 2840252"/>
+                <a:gd name="csY41" fmla="*/ 1597279 h 2793519"/>
+                <a:gd name="csX42" fmla="*/ 1485434 w 2840252"/>
+                <a:gd name="csY42" fmla="*/ 1746019 h 2793519"/>
+                <a:gd name="csX43" fmla="*/ 1123833 w 2840252"/>
+                <a:gd name="csY43" fmla="*/ 2150212 h 2793519"/>
+                <a:gd name="csX44" fmla="*/ 771827 w 2840252"/>
+                <a:gd name="csY44" fmla="*/ 2096222 h 2793519"/>
+                <a:gd name="csX45" fmla="*/ 1448309 w 2840252"/>
+                <a:gd name="csY45" fmla="*/ 829622 h 2793519"/>
+                <a:gd name="csX46" fmla="*/ 1521569 w 2840252"/>
+                <a:gd name="csY46" fmla="*/ 805745 h 2793519"/>
+                <a:gd name="csX47" fmla="*/ 1657777 w 2840252"/>
+                <a:gd name="csY47" fmla="*/ 873578 h 2793519"/>
+                <a:gd name="csX48" fmla="*/ 1682197 w 2840252"/>
+                <a:gd name="csY48" fmla="*/ 946838 h 2793519"/>
+                <a:gd name="csX49" fmla="*/ 1633357 w 2840252"/>
+                <a:gd name="csY49" fmla="*/ 976684 h 2793519"/>
+                <a:gd name="csX50" fmla="*/ 1609480 w 2840252"/>
+                <a:gd name="csY50" fmla="*/ 970715 h 2793519"/>
+                <a:gd name="csX51" fmla="*/ 1472729 w 2840252"/>
+                <a:gd name="csY51" fmla="*/ 902339 h 2793519"/>
+                <a:gd name="csX52" fmla="*/ 1448309 w 2840252"/>
+                <a:gd name="csY52" fmla="*/ 829622 h 2793519"/>
+                <a:gd name="csX53" fmla="*/ 1971979 w 2840252"/>
+                <a:gd name="csY53" fmla="*/ 474178 h 2793519"/>
+                <a:gd name="csX54" fmla="*/ 1997484 w 2840252"/>
+                <a:gd name="csY54" fmla="*/ 546353 h 2793519"/>
+                <a:gd name="csX55" fmla="*/ 1945388 w 2840252"/>
+                <a:gd name="csY55" fmla="*/ 657056 h 2793519"/>
+                <a:gd name="csX56" fmla="*/ 1896006 w 2840252"/>
+                <a:gd name="csY56" fmla="*/ 687988 h 2793519"/>
+                <a:gd name="csX57" fmla="*/ 1872672 w 2840252"/>
+                <a:gd name="csY57" fmla="*/ 682561 h 2793519"/>
+                <a:gd name="csX58" fmla="*/ 1847166 w 2840252"/>
+                <a:gd name="csY58" fmla="*/ 610387 h 2793519"/>
+                <a:gd name="csX59" fmla="*/ 1899805 w 2840252"/>
+                <a:gd name="csY59" fmla="*/ 499684 h 2793519"/>
+                <a:gd name="csX60" fmla="*/ 1971979 w 2840252"/>
+                <a:gd name="csY60" fmla="*/ 474178 h 2793519"/>
+                <a:gd name="csX61" fmla="*/ 2277498 w 2840252"/>
+                <a:gd name="csY61" fmla="*/ 919704 h 2793519"/>
+                <a:gd name="csX62" fmla="*/ 2193385 w 2840252"/>
+                <a:gd name="csY62" fmla="*/ 801404 h 2793519"/>
+                <a:gd name="csX63" fmla="*/ 2205867 w 2840252"/>
+                <a:gd name="csY63" fmla="*/ 725974 h 2793519"/>
+                <a:gd name="csX64" fmla="*/ 2281839 w 2840252"/>
+                <a:gd name="csY64" fmla="*/ 738455 h 2793519"/>
+                <a:gd name="csX65" fmla="*/ 2365952 w 2840252"/>
+                <a:gd name="csY65" fmla="*/ 856756 h 2793519"/>
+                <a:gd name="csX66" fmla="*/ 2352928 w 2840252"/>
+                <a:gd name="csY66" fmla="*/ 932186 h 2793519"/>
+                <a:gd name="csX67" fmla="*/ 2321454 w 2840252"/>
+                <a:gd name="csY67" fmla="*/ 942496 h 2793519"/>
+                <a:gd name="csX68" fmla="*/ 2277498 w 2840252"/>
+                <a:gd name="csY68" fmla="*/ 919704 h 2793519"/>
+                <a:gd name="csX69" fmla="*/ 2307344 w 2840252"/>
+                <a:gd name="csY69" fmla="*/ 1226852 h 2793519"/>
+                <a:gd name="csX70" fmla="*/ 2253078 w 2840252"/>
+                <a:gd name="csY70" fmla="*/ 1281118 h 2793519"/>
+                <a:gd name="csX71" fmla="*/ 2196641 w 2840252"/>
+                <a:gd name="csY71" fmla="*/ 1226852 h 2793519"/>
+                <a:gd name="csX72" fmla="*/ 2248194 w 2840252"/>
+                <a:gd name="csY72" fmla="*/ 1172585 h 2793519"/>
+                <a:gd name="csX73" fmla="*/ 2253078 w 2840252"/>
+                <a:gd name="csY73" fmla="*/ 1172585 h 2793519"/>
+                <a:gd name="csX74" fmla="*/ 2307344 w 2840252"/>
+                <a:gd name="csY74" fmla="*/ 1226852 h 2793519"/>
+                <a:gd name="csX75" fmla="*/ 1923682 w 2840252"/>
+                <a:gd name="csY75" fmla="*/ 1254527 h 2793519"/>
+                <a:gd name="csX76" fmla="*/ 1891122 w 2840252"/>
+                <a:gd name="csY76" fmla="*/ 1265381 h 2793519"/>
+                <a:gd name="csX77" fmla="*/ 1847709 w 2840252"/>
+                <a:gd name="csY77" fmla="*/ 1243674 h 2793519"/>
+                <a:gd name="csX78" fmla="*/ 1800497 w 2840252"/>
+                <a:gd name="csY78" fmla="*/ 1180725 h 2793519"/>
+                <a:gd name="csX79" fmla="*/ 1811351 w 2840252"/>
+                <a:gd name="csY79" fmla="*/ 1104753 h 2793519"/>
+                <a:gd name="csX80" fmla="*/ 1887323 w 2840252"/>
+                <a:gd name="csY80" fmla="*/ 1115606 h 2793519"/>
+                <a:gd name="csX81" fmla="*/ 1934535 w 2840252"/>
+                <a:gd name="csY81" fmla="*/ 1178555 h 2793519"/>
+                <a:gd name="csX82" fmla="*/ 1923682 w 2840252"/>
+                <a:gd name="csY82" fmla="*/ 1254527 h 2793519"/>
+                <a:gd name="csX83" fmla="*/ 1559012 w 2840252"/>
+                <a:gd name="csY83" fmla="*/ 1944795 h 2793519"/>
+                <a:gd name="csX84" fmla="*/ 1648552 w 2840252"/>
+                <a:gd name="csY84" fmla="*/ 1934484 h 2793519"/>
+                <a:gd name="csX85" fmla="*/ 1708787 w 2840252"/>
+                <a:gd name="csY85" fmla="*/ 1982238 h 2793519"/>
+                <a:gd name="csX86" fmla="*/ 1661033 w 2840252"/>
+                <a:gd name="csY86" fmla="*/ 2042474 h 2793519"/>
+                <a:gd name="csX87" fmla="*/ 1571494 w 2840252"/>
+                <a:gd name="csY87" fmla="*/ 2052785 h 2793519"/>
+                <a:gd name="csX88" fmla="*/ 1565524 w 2840252"/>
+                <a:gd name="csY88" fmla="*/ 2053327 h 2793519"/>
+                <a:gd name="csX89" fmla="*/ 1511258 w 2840252"/>
+                <a:gd name="csY89" fmla="*/ 2005030 h 2793519"/>
+                <a:gd name="csX90" fmla="*/ 1559012 w 2840252"/>
+                <a:gd name="csY90" fmla="*/ 1944795 h 2793519"/>
+                <a:gd name="csX91" fmla="*/ 1555756 w 2840252"/>
+                <a:gd name="csY91" fmla="*/ 1458026 h 2793519"/>
+                <a:gd name="csX92" fmla="*/ 1555756 w 2840252"/>
+                <a:gd name="csY92" fmla="*/ 1396705 h 2793519"/>
+                <a:gd name="csX93" fmla="*/ 1610023 w 2840252"/>
+                <a:gd name="csY93" fmla="*/ 1342439 h 2793519"/>
+                <a:gd name="csX94" fmla="*/ 1664289 w 2840252"/>
+                <a:gd name="csY94" fmla="*/ 1396705 h 2793519"/>
+                <a:gd name="csX95" fmla="*/ 1664289 w 2840252"/>
+                <a:gd name="csY95" fmla="*/ 1458026 h 2793519"/>
+                <a:gd name="csX96" fmla="*/ 1610023 w 2840252"/>
+                <a:gd name="csY96" fmla="*/ 1512292 h 2793519"/>
+                <a:gd name="csX97" fmla="*/ 1555756 w 2840252"/>
+                <a:gd name="csY97" fmla="*/ 1458026 h 2793519"/>
+                <a:gd name="csX98" fmla="*/ 1916085 w 2840252"/>
+                <a:gd name="csY98" fmla="*/ 1753235 h 2793519"/>
+                <a:gd name="csX99" fmla="*/ 1905774 w 2840252"/>
+                <a:gd name="csY99" fmla="*/ 1677262 h 2793519"/>
+                <a:gd name="csX100" fmla="*/ 2005081 w 2840252"/>
+                <a:gd name="csY100" fmla="*/ 1545937 h 2793519"/>
+                <a:gd name="csX101" fmla="*/ 2081597 w 2840252"/>
+                <a:gd name="csY101" fmla="*/ 1535627 h 2793519"/>
+                <a:gd name="csX102" fmla="*/ 2091907 w 2840252"/>
+                <a:gd name="csY102" fmla="*/ 1611600 h 2793519"/>
+                <a:gd name="csX103" fmla="*/ 1992057 w 2840252"/>
+                <a:gd name="csY103" fmla="*/ 1742924 h 2793519"/>
+                <a:gd name="csX104" fmla="*/ 1948644 w 2840252"/>
+                <a:gd name="csY104" fmla="*/ 1764088 h 2793519"/>
+                <a:gd name="csX105" fmla="*/ 1916085 w 2840252"/>
+                <a:gd name="csY105" fmla="*/ 1753235 h 2793519"/>
+                <a:gd name="csX0" fmla="*/ 2559683 w 2840252"/>
+                <a:gd name="csY0" fmla="*/ 224011 h 2793519"/>
+                <a:gd name="csX1" fmla="*/ 2547201 w 2840252"/>
+                <a:gd name="csY1" fmla="*/ 213158 h 2793519"/>
+                <a:gd name="csX2" fmla="*/ 1886238 w 2840252"/>
+                <a:gd name="csY2" fmla="*/ 6403 h 2793519"/>
+                <a:gd name="csX3" fmla="*/ 1295821 w 2840252"/>
+                <a:gd name="csY3" fmla="*/ 366188 h 2793519"/>
+                <a:gd name="csX4" fmla="*/ 830759 w 2840252"/>
+                <a:gd name="csY4" fmla="*/ 914821 h 2793519"/>
+                <a:gd name="csX5" fmla="*/ 367867 w 2840252"/>
+                <a:gd name="csY5" fmla="*/ 1285459 h 2793519"/>
+                <a:gd name="csX6" fmla="*/ 3198 w 2840252"/>
+                <a:gd name="csY6" fmla="*/ 1897583 h 2793519"/>
+                <a:gd name="csX7" fmla="*/ 249024 w 2840252"/>
+                <a:gd name="csY7" fmla="*/ 2549321 h 2793519"/>
+                <a:gd name="csX8" fmla="*/ 249024 w 2840252"/>
+                <a:gd name="csY8" fmla="*/ 2549864 h 2793519"/>
+                <a:gd name="csX9" fmla="*/ 268560 w 2840252"/>
+                <a:gd name="csY9" fmla="*/ 2568314 h 2793519"/>
+                <a:gd name="csX10" fmla="*/ 828588 w 2840252"/>
+                <a:gd name="csY10" fmla="*/ 2793519 h 2793519"/>
+                <a:gd name="csX11" fmla="*/ 1199227 w 2840252"/>
+                <a:gd name="csY11" fmla="*/ 2702895 h 2793519"/>
+                <a:gd name="csX12" fmla="*/ 2031129 w 2840252"/>
+                <a:gd name="csY12" fmla="*/ 2120075 h 2793519"/>
+                <a:gd name="csX13" fmla="*/ 2715970 w 2840252"/>
+                <a:gd name="csY13" fmla="*/ 1289801 h 2793519"/>
+                <a:gd name="csX14" fmla="*/ 2559683 w 2840252"/>
+                <a:gd name="csY14" fmla="*/ 224011 h 2793519"/>
+                <a:gd name="csX15" fmla="*/ 641370 w 2840252"/>
+                <a:gd name="csY15" fmla="*/ 1742924 h 2793519"/>
+                <a:gd name="csX16" fmla="*/ 588731 w 2840252"/>
+                <a:gd name="csY16" fmla="*/ 1785252 h 2793519"/>
+                <a:gd name="csX17" fmla="*/ 576793 w 2840252"/>
+                <a:gd name="csY17" fmla="*/ 1784166 h 2793519"/>
+                <a:gd name="csX18" fmla="*/ 435158 w 2840252"/>
+                <a:gd name="csY18" fmla="*/ 1752692 h 2793519"/>
+                <a:gd name="csX19" fmla="*/ 393915 w 2840252"/>
+                <a:gd name="csY19" fmla="*/ 1687572 h 2793519"/>
+                <a:gd name="csX20" fmla="*/ 458492 w 2840252"/>
+                <a:gd name="csY20" fmla="*/ 1646330 h 2793519"/>
+                <a:gd name="csX21" fmla="*/ 600127 w 2840252"/>
+                <a:gd name="csY21" fmla="*/ 1677805 h 2793519"/>
+                <a:gd name="csX22" fmla="*/ 641370 w 2840252"/>
+                <a:gd name="csY22" fmla="*/ 1742924 h 2793519"/>
+                <a:gd name="csX23" fmla="*/ 881227 w 2840252"/>
+                <a:gd name="csY23" fmla="*/ 2280703 h 2793519"/>
+                <a:gd name="csX24" fmla="*/ 901848 w 2840252"/>
+                <a:gd name="csY24" fmla="*/ 2260082 h 2793519"/>
+                <a:gd name="csX25" fmla="*/ 978906 w 2840252"/>
+                <a:gd name="csY25" fmla="*/ 2260082 h 2793519"/>
+                <a:gd name="csX26" fmla="*/ 978906 w 2840252"/>
+                <a:gd name="csY26" fmla="*/ 2336597 h 2793519"/>
+                <a:gd name="csX27" fmla="*/ 957742 w 2840252"/>
+                <a:gd name="csY27" fmla="*/ 2357761 h 2793519"/>
+                <a:gd name="csX28" fmla="*/ 919213 w 2840252"/>
+                <a:gd name="csY28" fmla="*/ 2373498 h 2793519"/>
+                <a:gd name="csX29" fmla="*/ 881227 w 2840252"/>
+                <a:gd name="csY29" fmla="*/ 2357761 h 2793519"/>
+                <a:gd name="csX30" fmla="*/ 881227 w 2840252"/>
+                <a:gd name="csY30" fmla="*/ 2280703 h 2793519"/>
+                <a:gd name="csX31" fmla="*/ 1252408 w 2840252"/>
+                <a:gd name="csY31" fmla="*/ 1379340 h 2793519"/>
+                <a:gd name="csX32" fmla="*/ 1208452 w 2840252"/>
+                <a:gd name="csY32" fmla="*/ 1402132 h 2793519"/>
+                <a:gd name="csX33" fmla="*/ 1176978 w 2840252"/>
+                <a:gd name="csY33" fmla="*/ 1391821 h 2793519"/>
+                <a:gd name="csX34" fmla="*/ 1066275 w 2840252"/>
+                <a:gd name="csY34" fmla="*/ 1313135 h 2793519"/>
+                <a:gd name="csX35" fmla="*/ 1053793 w 2840252"/>
+                <a:gd name="csY35" fmla="*/ 1237162 h 2793519"/>
+                <a:gd name="csX36" fmla="*/ 1129766 w 2840252"/>
+                <a:gd name="csY36" fmla="*/ 1224681 h 2793519"/>
+                <a:gd name="csX37" fmla="*/ 1239927 w 2840252"/>
+                <a:gd name="csY37" fmla="*/ 1303367 h 2793519"/>
+                <a:gd name="csX38" fmla="*/ 1252408 w 2840252"/>
+                <a:gd name="csY38" fmla="*/ 1379340 h 2793519"/>
+                <a:gd name="csX39" fmla="*/ 771827 w 2840252"/>
+                <a:gd name="csY39" fmla="*/ 2096222 h 2793519"/>
+                <a:gd name="csX40" fmla="*/ 958738 w 2840252"/>
+                <a:gd name="csY40" fmla="*/ 1629685 h 2793519"/>
+                <a:gd name="csX41" fmla="*/ 1297530 w 2840252"/>
+                <a:gd name="csY41" fmla="*/ 1597279 h 2793519"/>
+                <a:gd name="csX42" fmla="*/ 1485434 w 2840252"/>
+                <a:gd name="csY42" fmla="*/ 1746019 h 2793519"/>
+                <a:gd name="csX43" fmla="*/ 1123833 w 2840252"/>
+                <a:gd name="csY43" fmla="*/ 2150212 h 2793519"/>
+                <a:gd name="csX44" fmla="*/ 771827 w 2840252"/>
+                <a:gd name="csY44" fmla="*/ 2096222 h 2793519"/>
+                <a:gd name="csX45" fmla="*/ 1448309 w 2840252"/>
+                <a:gd name="csY45" fmla="*/ 829622 h 2793519"/>
+                <a:gd name="csX46" fmla="*/ 1521569 w 2840252"/>
+                <a:gd name="csY46" fmla="*/ 805745 h 2793519"/>
+                <a:gd name="csX47" fmla="*/ 1657777 w 2840252"/>
+                <a:gd name="csY47" fmla="*/ 873578 h 2793519"/>
+                <a:gd name="csX48" fmla="*/ 1682197 w 2840252"/>
+                <a:gd name="csY48" fmla="*/ 946838 h 2793519"/>
+                <a:gd name="csX49" fmla="*/ 1633357 w 2840252"/>
+                <a:gd name="csY49" fmla="*/ 976684 h 2793519"/>
+                <a:gd name="csX50" fmla="*/ 1609480 w 2840252"/>
+                <a:gd name="csY50" fmla="*/ 970715 h 2793519"/>
+                <a:gd name="csX51" fmla="*/ 1472729 w 2840252"/>
+                <a:gd name="csY51" fmla="*/ 902339 h 2793519"/>
+                <a:gd name="csX52" fmla="*/ 1448309 w 2840252"/>
+                <a:gd name="csY52" fmla="*/ 829622 h 2793519"/>
+                <a:gd name="csX53" fmla="*/ 1971979 w 2840252"/>
+                <a:gd name="csY53" fmla="*/ 474178 h 2793519"/>
+                <a:gd name="csX54" fmla="*/ 1997484 w 2840252"/>
+                <a:gd name="csY54" fmla="*/ 546353 h 2793519"/>
+                <a:gd name="csX55" fmla="*/ 1945388 w 2840252"/>
+                <a:gd name="csY55" fmla="*/ 657056 h 2793519"/>
+                <a:gd name="csX56" fmla="*/ 1896006 w 2840252"/>
+                <a:gd name="csY56" fmla="*/ 687988 h 2793519"/>
+                <a:gd name="csX57" fmla="*/ 1872672 w 2840252"/>
+                <a:gd name="csY57" fmla="*/ 682561 h 2793519"/>
+                <a:gd name="csX58" fmla="*/ 1847166 w 2840252"/>
+                <a:gd name="csY58" fmla="*/ 610387 h 2793519"/>
+                <a:gd name="csX59" fmla="*/ 1899805 w 2840252"/>
+                <a:gd name="csY59" fmla="*/ 499684 h 2793519"/>
+                <a:gd name="csX60" fmla="*/ 1971979 w 2840252"/>
+                <a:gd name="csY60" fmla="*/ 474178 h 2793519"/>
+                <a:gd name="csX61" fmla="*/ 2277498 w 2840252"/>
+                <a:gd name="csY61" fmla="*/ 919704 h 2793519"/>
+                <a:gd name="csX62" fmla="*/ 2193385 w 2840252"/>
+                <a:gd name="csY62" fmla="*/ 801404 h 2793519"/>
+                <a:gd name="csX63" fmla="*/ 2205867 w 2840252"/>
+                <a:gd name="csY63" fmla="*/ 725974 h 2793519"/>
+                <a:gd name="csX64" fmla="*/ 2281839 w 2840252"/>
+                <a:gd name="csY64" fmla="*/ 738455 h 2793519"/>
+                <a:gd name="csX65" fmla="*/ 2365952 w 2840252"/>
+                <a:gd name="csY65" fmla="*/ 856756 h 2793519"/>
+                <a:gd name="csX66" fmla="*/ 2352928 w 2840252"/>
+                <a:gd name="csY66" fmla="*/ 932186 h 2793519"/>
+                <a:gd name="csX67" fmla="*/ 2321454 w 2840252"/>
+                <a:gd name="csY67" fmla="*/ 942496 h 2793519"/>
+                <a:gd name="csX68" fmla="*/ 2277498 w 2840252"/>
+                <a:gd name="csY68" fmla="*/ 919704 h 2793519"/>
+                <a:gd name="csX69" fmla="*/ 2307344 w 2840252"/>
+                <a:gd name="csY69" fmla="*/ 1226852 h 2793519"/>
+                <a:gd name="csX70" fmla="*/ 2253078 w 2840252"/>
+                <a:gd name="csY70" fmla="*/ 1281118 h 2793519"/>
+                <a:gd name="csX71" fmla="*/ 2196641 w 2840252"/>
+                <a:gd name="csY71" fmla="*/ 1226852 h 2793519"/>
+                <a:gd name="csX72" fmla="*/ 2248194 w 2840252"/>
+                <a:gd name="csY72" fmla="*/ 1172585 h 2793519"/>
+                <a:gd name="csX73" fmla="*/ 2253078 w 2840252"/>
+                <a:gd name="csY73" fmla="*/ 1172585 h 2793519"/>
+                <a:gd name="csX74" fmla="*/ 2307344 w 2840252"/>
+                <a:gd name="csY74" fmla="*/ 1226852 h 2793519"/>
+                <a:gd name="csX75" fmla="*/ 1923682 w 2840252"/>
+                <a:gd name="csY75" fmla="*/ 1254527 h 2793519"/>
+                <a:gd name="csX76" fmla="*/ 1891122 w 2840252"/>
+                <a:gd name="csY76" fmla="*/ 1265381 h 2793519"/>
+                <a:gd name="csX77" fmla="*/ 1847709 w 2840252"/>
+                <a:gd name="csY77" fmla="*/ 1243674 h 2793519"/>
+                <a:gd name="csX78" fmla="*/ 1800497 w 2840252"/>
+                <a:gd name="csY78" fmla="*/ 1180725 h 2793519"/>
+                <a:gd name="csX79" fmla="*/ 1811351 w 2840252"/>
+                <a:gd name="csY79" fmla="*/ 1104753 h 2793519"/>
+                <a:gd name="csX80" fmla="*/ 1887323 w 2840252"/>
+                <a:gd name="csY80" fmla="*/ 1115606 h 2793519"/>
+                <a:gd name="csX81" fmla="*/ 1934535 w 2840252"/>
+                <a:gd name="csY81" fmla="*/ 1178555 h 2793519"/>
+                <a:gd name="csX82" fmla="*/ 1923682 w 2840252"/>
+                <a:gd name="csY82" fmla="*/ 1254527 h 2793519"/>
+                <a:gd name="csX83" fmla="*/ 1559012 w 2840252"/>
+                <a:gd name="csY83" fmla="*/ 1944795 h 2793519"/>
+                <a:gd name="csX84" fmla="*/ 1648552 w 2840252"/>
+                <a:gd name="csY84" fmla="*/ 1934484 h 2793519"/>
+                <a:gd name="csX85" fmla="*/ 1708787 w 2840252"/>
+                <a:gd name="csY85" fmla="*/ 1982238 h 2793519"/>
+                <a:gd name="csX86" fmla="*/ 1661033 w 2840252"/>
+                <a:gd name="csY86" fmla="*/ 2042474 h 2793519"/>
+                <a:gd name="csX87" fmla="*/ 1571494 w 2840252"/>
+                <a:gd name="csY87" fmla="*/ 2052785 h 2793519"/>
+                <a:gd name="csX88" fmla="*/ 1565524 w 2840252"/>
+                <a:gd name="csY88" fmla="*/ 2053327 h 2793519"/>
+                <a:gd name="csX89" fmla="*/ 1511258 w 2840252"/>
+                <a:gd name="csY89" fmla="*/ 2005030 h 2793519"/>
+                <a:gd name="csX90" fmla="*/ 1559012 w 2840252"/>
+                <a:gd name="csY90" fmla="*/ 1944795 h 2793519"/>
+                <a:gd name="csX91" fmla="*/ 1555756 w 2840252"/>
+                <a:gd name="csY91" fmla="*/ 1458026 h 2793519"/>
+                <a:gd name="csX92" fmla="*/ 1555756 w 2840252"/>
+                <a:gd name="csY92" fmla="*/ 1396705 h 2793519"/>
+                <a:gd name="csX93" fmla="*/ 1610023 w 2840252"/>
+                <a:gd name="csY93" fmla="*/ 1342439 h 2793519"/>
+                <a:gd name="csX94" fmla="*/ 1664289 w 2840252"/>
+                <a:gd name="csY94" fmla="*/ 1396705 h 2793519"/>
+                <a:gd name="csX95" fmla="*/ 1664289 w 2840252"/>
+                <a:gd name="csY95" fmla="*/ 1458026 h 2793519"/>
+                <a:gd name="csX96" fmla="*/ 1610023 w 2840252"/>
+                <a:gd name="csY96" fmla="*/ 1512292 h 2793519"/>
+                <a:gd name="csX97" fmla="*/ 1555756 w 2840252"/>
+                <a:gd name="csY97" fmla="*/ 1458026 h 2793519"/>
+                <a:gd name="csX98" fmla="*/ 1916085 w 2840252"/>
+                <a:gd name="csY98" fmla="*/ 1753235 h 2793519"/>
+                <a:gd name="csX99" fmla="*/ 1905774 w 2840252"/>
+                <a:gd name="csY99" fmla="*/ 1677262 h 2793519"/>
+                <a:gd name="csX100" fmla="*/ 2005081 w 2840252"/>
+                <a:gd name="csY100" fmla="*/ 1545937 h 2793519"/>
+                <a:gd name="csX101" fmla="*/ 2081597 w 2840252"/>
+                <a:gd name="csY101" fmla="*/ 1535627 h 2793519"/>
+                <a:gd name="csX102" fmla="*/ 2091907 w 2840252"/>
+                <a:gd name="csY102" fmla="*/ 1611600 h 2793519"/>
+                <a:gd name="csX103" fmla="*/ 1992057 w 2840252"/>
+                <a:gd name="csY103" fmla="*/ 1742924 h 2793519"/>
+                <a:gd name="csX104" fmla="*/ 1948644 w 2840252"/>
+                <a:gd name="csY104" fmla="*/ 1764088 h 2793519"/>
+                <a:gd name="csX105" fmla="*/ 1916085 w 2840252"/>
+                <a:gd name="csY105" fmla="*/ 1753235 h 2793519"/>
+              </a:gdLst>
+              <a:ahLst/>
+              <a:cxnLst>
+                <a:cxn ang="0">
+                  <a:pos x="csX0" y="csY0"/>
+                </a:cxn>
+                <a:cxn ang="0">
+                  <a:pos x="csX1" y="csY1"/>
+                </a:cxn>
+                <a:cxn ang="0">
+                  <a:pos x="csX2" y="csY2"/>
+                </a:cxn>
+                <a:cxn ang="0">
+                  <a:pos x="csX3" y="csY3"/>
+                </a:cxn>
+                <a:cxn ang="0">
+                  <a:pos x="csX4" y="csY4"/>
+                </a:cxn>
+                <a:cxn ang="0">
+                  <a:pos x="csX5" y="csY5"/>
+                </a:cxn>
+                <a:cxn ang="0">
+                  <a:pos x="csX6" y="csY6"/>
+                </a:cxn>
+                <a:cxn ang="0">
+                  <a:pos x="csX7" y="csY7"/>
+                </a:cxn>
+                <a:cxn ang="0">
+                  <a:pos x="csX8" y="csY8"/>
+                </a:cxn>
+                <a:cxn ang="0">
+                  <a:pos x="csX9" y="csY9"/>
+                </a:cxn>
+                <a:cxn ang="0">
+                  <a:pos x="csX10" y="csY10"/>
+                </a:cxn>
+                <a:cxn ang="0">
+                  <a:pos x="csX11" y="csY11"/>
+                </a:cxn>
+                <a:cxn ang="0">
+                  <a:pos x="csX12" y="csY12"/>
+                </a:cxn>
+                <a:cxn ang="0">
+                  <a:pos x="csX13" y="csY13"/>
+                </a:cxn>
+                <a:cxn ang="0">
+                  <a:pos x="csX14" y="csY14"/>
+                </a:cxn>
+                <a:cxn ang="0">
+                  <a:pos x="csX15" y="csY15"/>
+                </a:cxn>
+                <a:cxn ang="0">
+                  <a:pos x="csX16" y="csY16"/>
+                </a:cxn>
+                <a:cxn ang="0">
+                  <a:pos x="csX17" y="csY17"/>
+                </a:cxn>
+                <a:cxn ang="0">
+                  <a:pos x="csX18" y="csY18"/>
+                </a:cxn>
+                <a:cxn ang="0">
+                  <a:pos x="csX19" y="csY19"/>
+                </a:cxn>
+                <a:cxn ang="0">
+                  <a:pos x="csX20" y="csY20"/>
+                </a:cxn>
+                <a:cxn ang="0">
+                  <a:pos x="csX21" y="csY21"/>
+                </a:cxn>
+                <a:cxn ang="0">
+                  <a:pos x="csX22" y="csY22"/>
+                </a:cxn>
+                <a:cxn ang="0">
+                  <a:pos x="csX23" y="csY23"/>
+                </a:cxn>
+                <a:cxn ang="0">
+                  <a:pos x="csX24" y="csY24"/>
+                </a:cxn>
+                <a:cxn ang="0">
+                  <a:pos x="csX25" y="csY25"/>
+                </a:cxn>
+                <a:cxn ang="0">
+                  <a:pos x="csX26" y="csY26"/>
+                </a:cxn>
+                <a:cxn ang="0">
+                  <a:pos x="csX27" y="csY27"/>
+                </a:cxn>
+                <a:cxn ang="0">
+                  <a:pos x="csX28" y="csY28"/>
+                </a:cxn>
+                <a:cxn ang="0">
+                  <a:pos x="csX29" y="csY29"/>
+                </a:cxn>
+                <a:cxn ang="0">
+                  <a:pos x="csX30" y="csY30"/>
+                </a:cxn>
+                <a:cxn ang="0">
+                  <a:pos x="csX31" y="csY31"/>
+                </a:cxn>
+                <a:cxn ang="0">
+                  <a:pos x="csX32" y="csY32"/>
+                </a:cxn>
+                <a:cxn ang="0">
+                  <a:pos x="csX33" y="csY33"/>
+                </a:cxn>
+                <a:cxn ang="0">
+                  <a:pos x="csX34" y="csY34"/>
+                </a:cxn>
+                <a:cxn ang="0">
+                  <a:pos x="csX35" y="csY35"/>
+                </a:cxn>
+                <a:cxn ang="0">
+                  <a:pos x="csX36" y="csY36"/>
+                </a:cxn>
+                <a:cxn ang="0">
+                  <a:pos x="csX37" y="csY37"/>
+                </a:cxn>
+                <a:cxn ang="0">
+                  <a:pos x="csX38" y="csY38"/>
+                </a:cxn>
+                <a:cxn ang="0">
+                  <a:pos x="csX39" y="csY39"/>
+                </a:cxn>
+                <a:cxn ang="0">
+                  <a:pos x="csX40" y="csY40"/>
+                </a:cxn>
+                <a:cxn ang="0">
+                  <a:pos x="csX41" y="csY41"/>
+                </a:cxn>
+                <a:cxn ang="0">
+                  <a:pos x="csX42" y="csY42"/>
+                </a:cxn>
+                <a:cxn ang="0">
+                  <a:pos x="csX43" y="csY43"/>
+                </a:cxn>
+                <a:cxn ang="0">
+                  <a:pos x="csX44" y="csY44"/>
+                </a:cxn>
+                <a:cxn ang="0">
+                  <a:pos x="csX45" y="csY45"/>
+                </a:cxn>
+                <a:cxn ang="0">
+                  <a:pos x="csX46" y="csY46"/>
+                </a:cxn>
+                <a:cxn ang="0">
+                  <a:pos x="csX47" y="csY47"/>
+                </a:cxn>
+                <a:cxn ang="0">
+                  <a:pos x="csX48" y="csY48"/>
+                </a:cxn>
+                <a:cxn ang="0">
+                  <a:pos x="csX49" y="csY49"/>
+                </a:cxn>
+                <a:cxn ang="0">
+                  <a:pos x="csX50" y="csY50"/>
+                </a:cxn>
+                <a:cxn ang="0">
+                  <a:pos x="csX51" y="csY51"/>
+                </a:cxn>
+                <a:cxn ang="0">
+                  <a:pos x="csX52" y="csY52"/>
+                </a:cxn>
+                <a:cxn ang="0">
+                  <a:pos x="csX53" y="csY53"/>
+                </a:cxn>
+                <a:cxn ang="0">
+                  <a:pos x="csX54" y="csY54"/>
+                </a:cxn>
+                <a:cxn ang="0">
+                  <a:pos x="csX55" y="csY55"/>
+                </a:cxn>
+                <a:cxn ang="0">
+                  <a:pos x="csX56" y="csY56"/>
+                </a:cxn>
+                <a:cxn ang="0">
+                  <a:pos x="csX57" y="csY57"/>
+                </a:cxn>
+                <a:cxn ang="0">
+                  <a:pos x="csX58" y="csY58"/>
+                </a:cxn>
+                <a:cxn ang="0">
+                  <a:pos x="csX59" y="csY59"/>
+                </a:cxn>
+                <a:cxn ang="0">
+                  <a:pos x="csX60" y="csY60"/>
+                </a:cxn>
+                <a:cxn ang="0">
+                  <a:pos x="csX61" y="csY61"/>
+                </a:cxn>
+                <a:cxn ang="0">
+                  <a:pos x="csX62" y="csY62"/>
+                </a:cxn>
+                <a:cxn ang="0">
+                  <a:pos x="csX63" y="csY63"/>
+                </a:cxn>
+                <a:cxn ang="0">
+                  <a:pos x="csX64" y="csY64"/>
+                </a:cxn>
+                <a:cxn ang="0">
+                  <a:pos x="csX65" y="csY65"/>
+                </a:cxn>
+                <a:cxn ang="0">
+                  <a:pos x="csX66" y="csY66"/>
+                </a:cxn>
+                <a:cxn ang="0">
+                  <a:pos x="csX67" y="csY67"/>
+                </a:cxn>
+                <a:cxn ang="0">
+                  <a:pos x="csX68" y="csY68"/>
+                </a:cxn>
+                <a:cxn ang="0">
+                  <a:pos x="csX69" y="csY69"/>
+                </a:cxn>
+                <a:cxn ang="0">
+                  <a:pos x="csX70" y="csY70"/>
+                </a:cxn>
+                <a:cxn ang="0">
+                  <a:pos x="csX71" y="csY71"/>
+                </a:cxn>
+                <a:cxn ang="0">
+                  <a:pos x="csX72" y="csY72"/>
+                </a:cxn>
+                <a:cxn ang="0">
+                  <a:pos x="csX73" y="csY73"/>
+                </a:cxn>
+                <a:cxn ang="0">
+                  <a:pos x="csX74" y="csY74"/>
+                </a:cxn>
+                <a:cxn ang="0">
+                  <a:pos x="csX75" y="csY75"/>
+                </a:cxn>
+                <a:cxn ang="0">
+                  <a:pos x="csX76" y="csY76"/>
+                </a:cxn>
+                <a:cxn ang="0">
+                  <a:pos x="csX77" y="csY77"/>
+                </a:cxn>
+                <a:cxn ang="0">
+                  <a:pos x="csX78" y="csY78"/>
+                </a:cxn>
+                <a:cxn ang="0">
+                  <a:pos x="csX79" y="csY79"/>
+                </a:cxn>
+                <a:cxn ang="0">
+                  <a:pos x="csX80" y="csY80"/>
+                </a:cxn>
+                <a:cxn ang="0">
+                  <a:pos x="csX81" y="csY81"/>
+                </a:cxn>
+                <a:cxn ang="0">
+                  <a:pos x="csX82" y="csY82"/>
+                </a:cxn>
+                <a:cxn ang="0">
+                  <a:pos x="csX83" y="csY83"/>
+                </a:cxn>
+                <a:cxn ang="0">
+                  <a:pos x="csX84" y="csY84"/>
+                </a:cxn>
+                <a:cxn ang="0">
+                  <a:pos x="csX85" y="csY85"/>
+                </a:cxn>
+                <a:cxn ang="0">
+                  <a:pos x="csX86" y="csY86"/>
+                </a:cxn>
+                <a:cxn ang="0">
+                  <a:pos x="csX87" y="csY87"/>
+                </a:cxn>
+                <a:cxn ang="0">
+                  <a:pos x="csX88" y="csY88"/>
+                </a:cxn>
+                <a:cxn ang="0">
+                  <a:pos x="csX89" y="csY89"/>
+                </a:cxn>
+                <a:cxn ang="0">
+                  <a:pos x="csX90" y="csY90"/>
+                </a:cxn>
+                <a:cxn ang="0">
+                  <a:pos x="csX91" y="csY91"/>
+                </a:cxn>
+                <a:cxn ang="0">
+                  <a:pos x="csX92" y="csY92"/>
+                </a:cxn>
+                <a:cxn ang="0">
+                  <a:pos x="csX93" y="csY93"/>
+                </a:cxn>
+                <a:cxn ang="0">
+                  <a:pos x="csX94" y="csY94"/>
+                </a:cxn>
+                <a:cxn ang="0">
+                  <a:pos x="csX95" y="csY95"/>
+                </a:cxn>
+                <a:cxn ang="0">
+                  <a:pos x="csX96" y="csY96"/>
+                </a:cxn>
+                <a:cxn ang="0">
+                  <a:pos x="csX97" y="csY97"/>
+                </a:cxn>
+                <a:cxn ang="0">
+                  <a:pos x="csX98" y="csY98"/>
+                </a:cxn>
+                <a:cxn ang="0">
+                  <a:pos x="csX99" y="csY99"/>
+                </a:cxn>
+                <a:cxn ang="0">
+                  <a:pos x="csX100" y="csY100"/>
+                </a:cxn>
+                <a:cxn ang="0">
+                  <a:pos x="csX101" y="csY101"/>
+                </a:cxn>
+                <a:cxn ang="0">
+                  <a:pos x="csX102" y="csY102"/>
+                </a:cxn>
+                <a:cxn ang="0">
+                  <a:pos x="csX103" y="csY103"/>
+                </a:cxn>
+                <a:cxn ang="0">
+                  <a:pos x="csX104" y="csY104"/>
+                </a:cxn>
+                <a:cxn ang="0">
+                  <a:pos x="csX105" y="csY105"/>
+                </a:cxn>
+              </a:cxnLst>
+              <a:rect l="l" t="t" r="r" b="b"/>
+              <a:pathLst>
+                <a:path w="2840252" h="2793519">
+                  <a:moveTo>
+                    <a:pt x="2559683" y="224011"/>
+                  </a:moveTo>
+                  <a:lnTo>
+                    <a:pt x="2547201" y="213158"/>
+                  </a:lnTo>
+                  <a:cubicBezTo>
+                    <a:pt x="2367037" y="51987"/>
+                    <a:pt x="2126095" y="-23443"/>
+                    <a:pt x="1886238" y="6403"/>
+                  </a:cubicBezTo>
+                  <a:cubicBezTo>
+                    <a:pt x="1646924" y="35707"/>
+                    <a:pt x="1431487" y="167031"/>
+                    <a:pt x="1295821" y="366188"/>
+                  </a:cubicBezTo>
+                  <a:cubicBezTo>
+                    <a:pt x="1160698" y="564803"/>
+                    <a:pt x="1003868" y="749308"/>
+                    <a:pt x="830759" y="914821"/>
+                  </a:cubicBezTo>
+                  <a:cubicBezTo>
+                    <a:pt x="688039" y="1051029"/>
+                    <a:pt x="532294" y="1175841"/>
+                    <a:pt x="367867" y="1285459"/>
+                  </a:cubicBezTo>
+                  <a:cubicBezTo>
+                    <a:pt x="157857" y="1425466"/>
+                    <a:pt x="24905" y="1648501"/>
+                    <a:pt x="3198" y="1897583"/>
+                  </a:cubicBezTo>
+                  <a:cubicBezTo>
+                    <a:pt x="-18508" y="2141781"/>
+                    <a:pt x="71031" y="2379468"/>
+                    <a:pt x="249024" y="2549321"/>
+                  </a:cubicBezTo>
+                  <a:lnTo>
+                    <a:pt x="249024" y="2549864"/>
+                  </a:lnTo>
+                  <a:lnTo>
+                    <a:pt x="268560" y="2568314"/>
+                  </a:lnTo>
+                  <a:cubicBezTo>
+                    <a:pt x="423219" y="2716461"/>
+                    <a:pt x="625090" y="2793519"/>
+                    <a:pt x="828588" y="2793519"/>
+                  </a:cubicBezTo>
+                  <a:cubicBezTo>
+                    <a:pt x="955029" y="2793519"/>
+                    <a:pt x="1082012" y="2764216"/>
+                    <a:pt x="1199227" y="2702895"/>
+                  </a:cubicBezTo>
+                  <a:cubicBezTo>
+                    <a:pt x="1500948" y="2545522"/>
+                    <a:pt x="1780962" y="2349621"/>
+                    <a:pt x="2031129" y="2120075"/>
+                  </a:cubicBezTo>
+                  <a:cubicBezTo>
+                    <a:pt x="2295949" y="1877504"/>
+                    <a:pt x="2526038" y="1598033"/>
+                    <a:pt x="2715970" y="1289801"/>
+                  </a:cubicBezTo>
+                  <a:cubicBezTo>
+                    <a:pt x="2928693" y="943039"/>
+                    <a:pt x="2863031" y="494800"/>
+                    <a:pt x="2559683" y="224011"/>
+                  </a:cubicBezTo>
+                  <a:close/>
+                  <a:moveTo>
+                    <a:pt x="641370" y="1742924"/>
+                  </a:moveTo>
+                  <a:cubicBezTo>
+                    <a:pt x="635943" y="1767887"/>
+                    <a:pt x="613694" y="1785252"/>
+                    <a:pt x="588731" y="1785252"/>
+                  </a:cubicBezTo>
+                  <a:cubicBezTo>
+                    <a:pt x="584933" y="1785252"/>
+                    <a:pt x="580591" y="1784709"/>
+                    <a:pt x="576793" y="1784166"/>
+                  </a:cubicBezTo>
+                  <a:lnTo>
+                    <a:pt x="435158" y="1752692"/>
+                  </a:lnTo>
+                  <a:cubicBezTo>
+                    <a:pt x="405854" y="1746180"/>
+                    <a:pt x="387403" y="1716876"/>
+                    <a:pt x="393915" y="1687572"/>
+                  </a:cubicBezTo>
+                  <a:cubicBezTo>
+                    <a:pt x="400427" y="1658811"/>
+                    <a:pt x="429188" y="1640361"/>
+                    <a:pt x="458492" y="1646330"/>
+                  </a:cubicBezTo>
+                  <a:lnTo>
+                    <a:pt x="600127" y="1677805"/>
+                  </a:lnTo>
+                  <a:cubicBezTo>
+                    <a:pt x="629431" y="1684316"/>
+                    <a:pt x="647882" y="1713620"/>
+                    <a:pt x="641370" y="1742924"/>
+                  </a:cubicBezTo>
+                  <a:close/>
+                  <a:moveTo>
+                    <a:pt x="881227" y="2280703"/>
+                  </a:moveTo>
+                  <a:lnTo>
+                    <a:pt x="901848" y="2260082"/>
+                  </a:lnTo>
+                  <a:cubicBezTo>
+                    <a:pt x="923012" y="2238918"/>
+                    <a:pt x="957742" y="2238918"/>
+                    <a:pt x="978906" y="2260082"/>
+                  </a:cubicBezTo>
+                  <a:cubicBezTo>
+                    <a:pt x="1000070" y="2281246"/>
+                    <a:pt x="1000070" y="2315433"/>
+                    <a:pt x="978906" y="2336597"/>
+                  </a:cubicBezTo>
+                  <a:lnTo>
+                    <a:pt x="957742" y="2357761"/>
+                  </a:lnTo>
+                  <a:cubicBezTo>
+                    <a:pt x="947431" y="2368072"/>
+                    <a:pt x="933322" y="2373498"/>
+                    <a:pt x="919213" y="2373498"/>
+                  </a:cubicBezTo>
+                  <a:cubicBezTo>
+                    <a:pt x="905646" y="2373498"/>
+                    <a:pt x="891537" y="2368072"/>
+                    <a:pt x="881227" y="2357761"/>
+                  </a:cubicBezTo>
+                  <a:cubicBezTo>
+                    <a:pt x="860063" y="2336597"/>
+                    <a:pt x="860063" y="2301867"/>
+                    <a:pt x="881227" y="2280703"/>
+                  </a:cubicBezTo>
+                  <a:close/>
+                  <a:moveTo>
+                    <a:pt x="1252408" y="1379340"/>
+                  </a:moveTo>
+                  <a:cubicBezTo>
+                    <a:pt x="1242097" y="1393992"/>
+                    <a:pt x="1225275" y="1402132"/>
+                    <a:pt x="1208452" y="1402132"/>
+                  </a:cubicBezTo>
+                  <a:cubicBezTo>
+                    <a:pt x="1197056" y="1402132"/>
+                    <a:pt x="1186203" y="1398876"/>
+                    <a:pt x="1176978" y="1391821"/>
+                  </a:cubicBezTo>
+                  <a:lnTo>
+                    <a:pt x="1066275" y="1313135"/>
+                  </a:lnTo>
+                  <a:cubicBezTo>
+                    <a:pt x="1041855" y="1295770"/>
+                    <a:pt x="1036428" y="1261582"/>
+                    <a:pt x="1053793" y="1237162"/>
+                  </a:cubicBezTo>
+                  <a:cubicBezTo>
+                    <a:pt x="1071159" y="1212743"/>
+                    <a:pt x="1105346" y="1207316"/>
+                    <a:pt x="1129766" y="1224681"/>
+                  </a:cubicBezTo>
+                  <a:lnTo>
+                    <a:pt x="1239927" y="1303367"/>
+                  </a:lnTo>
+                  <a:cubicBezTo>
+                    <a:pt x="1264346" y="1320732"/>
+                    <a:pt x="1269773" y="1354920"/>
+                    <a:pt x="1252408" y="1379340"/>
+                  </a:cubicBezTo>
+                  <a:close/>
+                  <a:moveTo>
+                    <a:pt x="771827" y="2096222"/>
+                  </a:moveTo>
+                  <a:cubicBezTo>
+                    <a:pt x="691459" y="2002391"/>
+                    <a:pt x="871121" y="1712842"/>
+                    <a:pt x="958738" y="1629685"/>
+                  </a:cubicBezTo>
+                  <a:cubicBezTo>
+                    <a:pt x="1046355" y="1546528"/>
+                    <a:pt x="1167725" y="1534204"/>
+                    <a:pt x="1297530" y="1597279"/>
+                  </a:cubicBezTo>
+                  <a:cubicBezTo>
+                    <a:pt x="1360165" y="1646859"/>
+                    <a:pt x="1481069" y="1662664"/>
+                    <a:pt x="1485434" y="1746019"/>
+                  </a:cubicBezTo>
+                  <a:cubicBezTo>
+                    <a:pt x="1525718" y="1841781"/>
+                    <a:pt x="1297844" y="1973768"/>
+                    <a:pt x="1123833" y="2150212"/>
+                  </a:cubicBezTo>
+                  <a:cubicBezTo>
+                    <a:pt x="1044464" y="2230278"/>
+                    <a:pt x="771827" y="2126068"/>
+                    <a:pt x="771827" y="2096222"/>
+                  </a:cubicBezTo>
+                  <a:close/>
+                  <a:moveTo>
+                    <a:pt x="1448309" y="829622"/>
+                  </a:moveTo>
+                  <a:cubicBezTo>
+                    <a:pt x="1461876" y="803032"/>
+                    <a:pt x="1494435" y="792179"/>
+                    <a:pt x="1521569" y="805745"/>
+                  </a:cubicBezTo>
+                  <a:lnTo>
+                    <a:pt x="1657777" y="873578"/>
+                  </a:lnTo>
+                  <a:cubicBezTo>
+                    <a:pt x="1684910" y="887145"/>
+                    <a:pt x="1695764" y="919704"/>
+                    <a:pt x="1682197" y="946838"/>
+                  </a:cubicBezTo>
+                  <a:cubicBezTo>
+                    <a:pt x="1672429" y="965831"/>
+                    <a:pt x="1653436" y="976684"/>
+                    <a:pt x="1633357" y="976684"/>
+                  </a:cubicBezTo>
+                  <a:cubicBezTo>
+                    <a:pt x="1625217" y="976684"/>
+                    <a:pt x="1617077" y="974513"/>
+                    <a:pt x="1609480" y="970715"/>
+                  </a:cubicBezTo>
+                  <a:lnTo>
+                    <a:pt x="1472729" y="902339"/>
+                  </a:lnTo>
+                  <a:cubicBezTo>
+                    <a:pt x="1446139" y="889315"/>
+                    <a:pt x="1435285" y="856756"/>
+                    <a:pt x="1448309" y="829622"/>
+                  </a:cubicBezTo>
+                  <a:close/>
+                  <a:moveTo>
+                    <a:pt x="1971979" y="474178"/>
+                  </a:moveTo>
+                  <a:cubicBezTo>
+                    <a:pt x="1999112" y="487202"/>
+                    <a:pt x="2010508" y="519219"/>
+                    <a:pt x="1997484" y="546353"/>
+                  </a:cubicBezTo>
+                  <a:lnTo>
+                    <a:pt x="1945388" y="657056"/>
+                  </a:lnTo>
+                  <a:cubicBezTo>
+                    <a:pt x="1936163" y="676592"/>
+                    <a:pt x="1916627" y="687988"/>
+                    <a:pt x="1896006" y="687988"/>
+                  </a:cubicBezTo>
+                  <a:cubicBezTo>
+                    <a:pt x="1888409" y="687988"/>
+                    <a:pt x="1880269" y="685817"/>
+                    <a:pt x="1872672" y="682561"/>
+                  </a:cubicBezTo>
+                  <a:cubicBezTo>
+                    <a:pt x="1846081" y="669537"/>
+                    <a:pt x="1834143" y="636977"/>
+                    <a:pt x="1847166" y="610387"/>
+                  </a:cubicBezTo>
+                  <a:lnTo>
+                    <a:pt x="1899805" y="499684"/>
+                  </a:lnTo>
+                  <a:cubicBezTo>
+                    <a:pt x="1912829" y="472550"/>
+                    <a:pt x="1944846" y="461154"/>
+                    <a:pt x="1971979" y="474178"/>
+                  </a:cubicBezTo>
+                  <a:close/>
+                  <a:moveTo>
+                    <a:pt x="2277498" y="919704"/>
+                  </a:moveTo>
+                  <a:lnTo>
+                    <a:pt x="2193385" y="801404"/>
+                  </a:lnTo>
+                  <a:cubicBezTo>
+                    <a:pt x="2176020" y="776984"/>
+                    <a:pt x="2181447" y="743339"/>
+                    <a:pt x="2205867" y="725974"/>
+                  </a:cubicBezTo>
+                  <a:cubicBezTo>
+                    <a:pt x="2230829" y="708609"/>
+                    <a:pt x="2264474" y="714035"/>
+                    <a:pt x="2281839" y="738455"/>
+                  </a:cubicBezTo>
+                  <a:lnTo>
+                    <a:pt x="2365952" y="856756"/>
+                  </a:lnTo>
+                  <a:cubicBezTo>
+                    <a:pt x="2383317" y="881175"/>
+                    <a:pt x="2377348" y="914821"/>
+                    <a:pt x="2352928" y="932186"/>
+                  </a:cubicBezTo>
+                  <a:cubicBezTo>
+                    <a:pt x="2343703" y="939240"/>
+                    <a:pt x="2332307" y="942496"/>
+                    <a:pt x="2321454" y="942496"/>
+                  </a:cubicBezTo>
+                  <a:cubicBezTo>
+                    <a:pt x="2304631" y="942496"/>
+                    <a:pt x="2287809" y="934356"/>
+                    <a:pt x="2277498" y="919704"/>
+                  </a:cubicBezTo>
+                  <a:close/>
+                  <a:moveTo>
+                    <a:pt x="2307344" y="1226852"/>
+                  </a:moveTo>
+                  <a:cubicBezTo>
+                    <a:pt x="2307344" y="1256698"/>
+                    <a:pt x="2283467" y="1281118"/>
+                    <a:pt x="2253078" y="1281118"/>
+                  </a:cubicBezTo>
+                  <a:cubicBezTo>
+                    <a:pt x="2223232" y="1281118"/>
+                    <a:pt x="2196641" y="1256698"/>
+                    <a:pt x="2196641" y="1226852"/>
+                  </a:cubicBezTo>
+                  <a:cubicBezTo>
+                    <a:pt x="2196641" y="1197005"/>
+                    <a:pt x="2218348" y="1172585"/>
+                    <a:pt x="2248194" y="1172585"/>
+                  </a:cubicBezTo>
+                  <a:lnTo>
+                    <a:pt x="2253078" y="1172585"/>
+                  </a:lnTo>
+                  <a:cubicBezTo>
+                    <a:pt x="2283467" y="1172585"/>
+                    <a:pt x="2307344" y="1197005"/>
+                    <a:pt x="2307344" y="1226852"/>
+                  </a:cubicBezTo>
+                  <a:close/>
+                  <a:moveTo>
+                    <a:pt x="1923682" y="1254527"/>
+                  </a:moveTo>
+                  <a:cubicBezTo>
+                    <a:pt x="1913914" y="1262125"/>
+                    <a:pt x="1902518" y="1265381"/>
+                    <a:pt x="1891122" y="1265381"/>
+                  </a:cubicBezTo>
+                  <a:cubicBezTo>
+                    <a:pt x="1874299" y="1265381"/>
+                    <a:pt x="1858020" y="1257784"/>
+                    <a:pt x="1847709" y="1243674"/>
+                  </a:cubicBezTo>
+                  <a:lnTo>
+                    <a:pt x="1800497" y="1180725"/>
+                  </a:lnTo>
+                  <a:cubicBezTo>
+                    <a:pt x="1782590" y="1156848"/>
+                    <a:pt x="1787473" y="1122660"/>
+                    <a:pt x="1811351" y="1104753"/>
+                  </a:cubicBezTo>
+                  <a:cubicBezTo>
+                    <a:pt x="1835228" y="1086845"/>
+                    <a:pt x="1869415" y="1091729"/>
+                    <a:pt x="1887323" y="1115606"/>
+                  </a:cubicBezTo>
+                  <a:lnTo>
+                    <a:pt x="1934535" y="1178555"/>
+                  </a:lnTo>
+                  <a:cubicBezTo>
+                    <a:pt x="1952443" y="1202432"/>
+                    <a:pt x="1947559" y="1236620"/>
+                    <a:pt x="1923682" y="1254527"/>
+                  </a:cubicBezTo>
+                  <a:close/>
+                  <a:moveTo>
+                    <a:pt x="1559012" y="1944795"/>
+                  </a:moveTo>
+                  <a:lnTo>
+                    <a:pt x="1648552" y="1934484"/>
+                  </a:lnTo>
+                  <a:cubicBezTo>
+                    <a:pt x="1677856" y="1930685"/>
+                    <a:pt x="1704989" y="1952392"/>
+                    <a:pt x="1708787" y="1982238"/>
+                  </a:cubicBezTo>
+                  <a:cubicBezTo>
+                    <a:pt x="1712043" y="2011542"/>
+                    <a:pt x="1690880" y="2038675"/>
+                    <a:pt x="1661033" y="2042474"/>
+                  </a:cubicBezTo>
+                  <a:lnTo>
+                    <a:pt x="1571494" y="2052785"/>
+                  </a:lnTo>
+                  <a:cubicBezTo>
+                    <a:pt x="1569323" y="2052785"/>
+                    <a:pt x="1567152" y="2053327"/>
+                    <a:pt x="1565524" y="2053327"/>
+                  </a:cubicBezTo>
+                  <a:cubicBezTo>
+                    <a:pt x="1538391" y="2053327"/>
+                    <a:pt x="1514514" y="2032706"/>
+                    <a:pt x="1511258" y="2005030"/>
+                  </a:cubicBezTo>
+                  <a:cubicBezTo>
+                    <a:pt x="1508002" y="1975726"/>
+                    <a:pt x="1529166" y="1948593"/>
+                    <a:pt x="1559012" y="1944795"/>
+                  </a:cubicBezTo>
+                  <a:close/>
+                  <a:moveTo>
+                    <a:pt x="1555756" y="1458026"/>
+                  </a:moveTo>
+                  <a:lnTo>
+                    <a:pt x="1555756" y="1396705"/>
+                  </a:lnTo>
+                  <a:cubicBezTo>
+                    <a:pt x="1555756" y="1366859"/>
+                    <a:pt x="1580176" y="1342439"/>
+                    <a:pt x="1610023" y="1342439"/>
+                  </a:cubicBezTo>
+                  <a:cubicBezTo>
+                    <a:pt x="1639869" y="1342439"/>
+                    <a:pt x="1664289" y="1366859"/>
+                    <a:pt x="1664289" y="1396705"/>
+                  </a:cubicBezTo>
+                  <a:lnTo>
+                    <a:pt x="1664289" y="1458026"/>
+                  </a:lnTo>
+                  <a:cubicBezTo>
+                    <a:pt x="1664289" y="1487873"/>
+                    <a:pt x="1639869" y="1512292"/>
+                    <a:pt x="1610023" y="1512292"/>
+                  </a:cubicBezTo>
+                  <a:cubicBezTo>
+                    <a:pt x="1580176" y="1512292"/>
+                    <a:pt x="1555756" y="1487873"/>
+                    <a:pt x="1555756" y="1458026"/>
+                  </a:cubicBezTo>
+                  <a:close/>
+                  <a:moveTo>
+                    <a:pt x="1916085" y="1753235"/>
+                  </a:moveTo>
+                  <a:cubicBezTo>
+                    <a:pt x="1892207" y="1735327"/>
+                    <a:pt x="1887323" y="1701139"/>
+                    <a:pt x="1905774" y="1677262"/>
+                  </a:cubicBezTo>
+                  <a:lnTo>
+                    <a:pt x="2005081" y="1545937"/>
+                  </a:lnTo>
+                  <a:cubicBezTo>
+                    <a:pt x="2023532" y="1522060"/>
+                    <a:pt x="2057720" y="1517176"/>
+                    <a:pt x="2081597" y="1535627"/>
+                  </a:cubicBezTo>
+                  <a:cubicBezTo>
+                    <a:pt x="2105474" y="1553535"/>
+                    <a:pt x="2109815" y="1587723"/>
+                    <a:pt x="2091907" y="1611600"/>
+                  </a:cubicBezTo>
+                  <a:lnTo>
+                    <a:pt x="1992057" y="1742924"/>
+                  </a:lnTo>
+                  <a:cubicBezTo>
+                    <a:pt x="1981204" y="1757033"/>
+                    <a:pt x="1964924" y="1764088"/>
+                    <a:pt x="1948644" y="1764088"/>
+                  </a:cubicBezTo>
+                  <a:cubicBezTo>
+                    <a:pt x="1937248" y="1764088"/>
+                    <a:pt x="1925852" y="1760832"/>
+                    <a:pt x="1916085" y="1753235"/>
+                  </a:cubicBezTo>
+                  <a:close/>
+                </a:path>
+              </a:pathLst>
+            </a:custGeom>
+            <a:solidFill>
+              <a:srgbClr val="000000"/>
+            </a:solidFill>
+            <a:ln w="54173" cap="flat">
+              <a:noFill/>
+              <a:prstDash val="solid"/>
+              <a:miter/>
+            </a:ln>
+          </p:spPr>
+          <p:txBody>
+            <a:bodyPr/>
+            <a:lstStyle/>
+            <a:p>
+              <a:endParaRPr lang="en-US"/>
+            </a:p>
+          </p:txBody>
+        </p:sp>
+      </p:grpSp>
     </p:spTree>
     <p:extLst>
       <p:ext uri="{BB962C8B-B14F-4D97-AF65-F5344CB8AC3E}">

</xml_diff>